<commit_message>
Commit workspace changes: visual rules, composition, audit tooling
- Add visual-director execution rules (docs/视觉导演执行规则.md, 内容导演执行规则.md)
- Add composition layouts catalog and schemas/composition-plan.schema.json
- Add page-composition renderer and src/composition/
- Add audit tooling: audit-core-asset-quality, audit-distillation-batch,
  audit-distillation-governance, audit-rendered-typography, render-pptx-evidence
- Add director-guidelines.mjs and update agent providers/workflow
- Add adaptive-structure and rendered-typography tests
- Update asset library (正文, 结构图, 备选资产), catalogs, and quality-report
- Exclude local .obsidian editor config

Co-Authored-By: Claude <noreply@anthropic.com>
</commit_message>
<xml_diff>
--- a/assets/正文/问题与改进措施-001/example.pptx
+++ b/assets/正文/问题与改进措施-001/example.pptx
@@ -2,13 +2,13 @@
 <file path=ppt/presentation.xml><?xml version="1.0" encoding="utf-8"?>
 <p:presentation xmlns:p="http://schemas.openxmlformats.org/presentationml/2006/main">
   <p:sldMasterIdLst>
-    <p:sldMasterId xmlns:r="http://schemas.openxmlformats.org/officeDocument/2006/relationships" id="2147483648" r:id="R47519a9968ae44a9"/>
+    <p:sldMasterId xmlns:r="http://schemas.openxmlformats.org/officeDocument/2006/relationships" id="2147483648" r:id="Rb6915671ff2a4d0d"/>
   </p:sldMasterIdLst>
   <p:notesMasterIdLst>
-    <p:notesMasterId xmlns:r="http://schemas.openxmlformats.org/officeDocument/2006/relationships" r:id="Ra9b2660c681544cb"/>
+    <p:notesMasterId xmlns:r="http://schemas.openxmlformats.org/officeDocument/2006/relationships" r:id="R792ff71ca8dd4e66"/>
   </p:notesMasterIdLst>
   <p:sldIdLst>
-    <p:sldId xmlns:r="http://schemas.openxmlformats.org/officeDocument/2006/relationships" id="256" r:id="Ra2145662f90d4b2a"/>
+    <p:sldId xmlns:r="http://schemas.openxmlformats.org/officeDocument/2006/relationships" id="256" r:id="Ra3800c43ed954db9"/>
   </p:sldIdLst>
   <p:sldSz cx="12192000" cy="6858000"/>
   <p:notesSz cx="6858000" cy="9144000"/>
@@ -506,7 +506,7 @@
   </p:cSld>
   <p:clrMap bg1="lt1" tx1="dk1" bg2="lt2" tx2="dk2" accent1="accent1" accent2="accent2" accent3="accent3" accent4="accent4" accent5="accent5" accent6="accent6" hlink="hlink" folHlink="folHlink"/>
   <p:sldLayoutIdLst>
-    <p:sldLayoutId xmlns:r="http://schemas.openxmlformats.org/officeDocument/2006/relationships" id="2147483649" r:id="R0388cd3c1dc440e7"/>
+    <p:sldLayoutId xmlns:r="http://schemas.openxmlformats.org/officeDocument/2006/relationships" id="2147483649" r:id="R25316345f5f64b56"/>
   </p:sldLayoutIdLst>
   <p:txStyles>
     <p:titleStyle>
@@ -1057,7 +1057,7 @@
           <p:cNvPr id="20" name="">
             <a:extLst xmlns:a="http://schemas.openxmlformats.org/drawingml/2006/main">
               <a:ext uri="{FF2B5EF4-FFF2-40B4-BE49-F238E27FC236}">
-                <a16:creationId xmlns:a16="http://schemas.microsoft.com/office/drawing/2014/main" id="{C60DD236-A713-4B92-98C3-D43FD8D482F3}"/>
+                <a16:creationId xmlns:a16="http://schemas.microsoft.com/office/drawing/2014/main" id="{D0A662CD-AF1D-4338-B339-48DB9070D593}"/>
               </a:ext>
             </a:extLst>
           </p:cNvPr>
@@ -1115,7 +1115,7 @@
           <p:cNvPr id="2" name="">
             <a:extLst xmlns:a="http://schemas.openxmlformats.org/drawingml/2006/main">
               <a:ext uri="{FF2B5EF4-FFF2-40B4-BE49-F238E27FC236}">
-                <a16:creationId xmlns:a16="http://schemas.microsoft.com/office/drawing/2014/main" id="{39E8E88F-D0AD-4750-9E76-4AF212B31F5B}"/>
+                <a16:creationId xmlns:a16="http://schemas.microsoft.com/office/drawing/2014/main" id="{E720BD10-FA04-417F-A292-1D6FBEBB130B}"/>
               </a:ext>
             </a:extLst>
           </p:cNvPr>
@@ -1173,7 +1173,7 @@
           <p:cNvPr id="3" name="">
             <a:extLst xmlns:a="http://schemas.openxmlformats.org/drawingml/2006/main">
               <a:ext uri="{FF2B5EF4-FFF2-40B4-BE49-F238E27FC236}">
-                <a16:creationId xmlns:a16="http://schemas.microsoft.com/office/drawing/2014/main" id="{2D79D2A5-C0E9-402C-A3A0-8418CCC8DE21}"/>
+                <a16:creationId xmlns:a16="http://schemas.microsoft.com/office/drawing/2014/main" id="{9F91D5A6-8B7B-4CA6-962F-513E3FC92590}"/>
               </a:ext>
             </a:extLst>
           </p:cNvPr>
@@ -1214,7 +1214,7 @@
           <p:cNvPr id="4" name="">
             <a:extLst xmlns:a="http://schemas.openxmlformats.org/drawingml/2006/main">
               <a:ext uri="{FF2B5EF4-FFF2-40B4-BE49-F238E27FC236}">
-                <a16:creationId xmlns:a16="http://schemas.microsoft.com/office/drawing/2014/main" id="{3C2F948E-72C5-4392-A75F-FF755D385C06}"/>
+                <a16:creationId xmlns:a16="http://schemas.microsoft.com/office/drawing/2014/main" id="{6E76672C-4A50-4FDC-8E2F-B2E92A7F8774}"/>
               </a:ext>
             </a:extLst>
           </p:cNvPr>
@@ -1255,7 +1255,7 @@
           <p:cNvPr id="5" name="">
             <a:extLst xmlns:a="http://schemas.openxmlformats.org/drawingml/2006/main">
               <a:ext uri="{FF2B5EF4-FFF2-40B4-BE49-F238E27FC236}">
-                <a16:creationId xmlns:a16="http://schemas.microsoft.com/office/drawing/2014/main" id="{873F7239-B154-4D84-AFF4-A21FA9C81704}"/>
+                <a16:creationId xmlns:a16="http://schemas.microsoft.com/office/drawing/2014/main" id="{FCF3EB8D-DC5E-45E3-B7BE-1C7FFFF933D3}"/>
               </a:ext>
             </a:extLst>
           </p:cNvPr>
@@ -1313,7 +1313,7 @@
           <p:cNvPr id="6" name="">
             <a:extLst xmlns:a="http://schemas.openxmlformats.org/drawingml/2006/main">
               <a:ext uri="{FF2B5EF4-FFF2-40B4-BE49-F238E27FC236}">
-                <a16:creationId xmlns:a16="http://schemas.microsoft.com/office/drawing/2014/main" id="{2F2B34CF-EF99-4D32-A87F-BF7C39F04EB3}"/>
+                <a16:creationId xmlns:a16="http://schemas.microsoft.com/office/drawing/2014/main" id="{8743A5F0-5F44-4D28-9700-FA3DACC98269}"/>
               </a:ext>
             </a:extLst>
           </p:cNvPr>
@@ -1368,10 +1368,10 @@
       </p:sp>
       <p:sp>
         <p:nvSpPr>
-          <p:cNvPr id="7" name="">
+          <p:cNvPr id="7" name="PPAGENT_QA|parent=problem-item-0|domains=problem-items">
             <a:extLst xmlns:a="http://schemas.openxmlformats.org/drawingml/2006/main">
               <a:ext uri="{FF2B5EF4-FFF2-40B4-BE49-F238E27FC236}">
-                <a16:creationId xmlns:a16="http://schemas.microsoft.com/office/drawing/2014/main" id="{8C8890C9-A443-4BA6-B5BF-03C1EBDAF7AB}"/>
+                <a16:creationId xmlns:a16="http://schemas.microsoft.com/office/drawing/2014/main" id="{B8ADB154-0150-4110-A72A-AD8D623C2D33}"/>
               </a:ext>
             </a:extLst>
           </p:cNvPr>
@@ -1403,10 +1403,10 @@
       </p:sp>
       <p:sp>
         <p:nvSpPr>
-          <p:cNvPr id="8" name="">
+          <p:cNvPr id="8" name="PPAGENT_QA|within=problem-item-0|role=title">
             <a:extLst xmlns:a="http://schemas.openxmlformats.org/drawingml/2006/main">
               <a:ext uri="{FF2B5EF4-FFF2-40B4-BE49-F238E27FC236}">
-                <a16:creationId xmlns:a16="http://schemas.microsoft.com/office/drawing/2014/main" id="{78B2C96B-7F2B-42C7-A6C2-9CA2CB39E2CB}"/>
+                <a16:creationId xmlns:a16="http://schemas.microsoft.com/office/drawing/2014/main" id="{3DD08794-626F-4B20-9773-921D11E4B574}"/>
               </a:ext>
             </a:extLst>
           </p:cNvPr>
@@ -1436,7 +1436,7 @@
           <a:lstStyle xmlns:a="http://schemas.openxmlformats.org/drawingml/2006/main"/>
           <a:p xmlns:a="http://schemas.openxmlformats.org/drawingml/2006/main">
             <a:pPr algn="l">
-              <a:defRPr sz="1275" b="1">
+              <a:defRPr sz="1425" b="1">
                 <a:solidFill>
                   <a:srgbClr val="475569"/>
                 </a:solidFill>
@@ -1446,7 +1446,7 @@
               </a:defRPr>
             </a:pPr>
             <a:r>
-              <a:rPr sz="1275" b="1">
+              <a:rPr sz="1425" b="1">
                 <a:solidFill>
                   <a:srgbClr val="475569"/>
                 </a:solidFill>
@@ -1461,10 +1461,10 @@
       </p:sp>
       <p:sp>
         <p:nvSpPr>
-          <p:cNvPr id="9" name="">
+          <p:cNvPr id="9" name="PPAGENT_QA|within=problem-item-0|role=body">
             <a:extLst xmlns:a="http://schemas.openxmlformats.org/drawingml/2006/main">
               <a:ext uri="{FF2B5EF4-FFF2-40B4-BE49-F238E27FC236}">
-                <a16:creationId xmlns:a16="http://schemas.microsoft.com/office/drawing/2014/main" id="{AD51A384-B2C6-475F-9AAF-7DB72165DFA1}"/>
+                <a16:creationId xmlns:a16="http://schemas.microsoft.com/office/drawing/2014/main" id="{8FC99885-2662-4968-97CE-EAF3DB96082C}"/>
               </a:ext>
             </a:extLst>
           </p:cNvPr>
@@ -1494,7 +1494,7 @@
           <a:lstStyle xmlns:a="http://schemas.openxmlformats.org/drawingml/2006/main"/>
           <a:p xmlns:a="http://schemas.openxmlformats.org/drawingml/2006/main">
             <a:pPr algn="l">
-              <a:defRPr sz="1050" b="0">
+              <a:defRPr sz="1350" b="0">
                 <a:solidFill>
                   <a:srgbClr val="475569"/>
                 </a:solidFill>
@@ -1504,7 +1504,7 @@
               </a:defRPr>
             </a:pPr>
             <a:r>
-              <a:rPr sz="1050" b="0">
+              <a:rPr sz="1350" b="0">
                 <a:solidFill>
                   <a:srgbClr val="475569"/>
                 </a:solidFill>
@@ -1519,10 +1519,10 @@
       </p:sp>
       <p:sp>
         <p:nvSpPr>
-          <p:cNvPr id="10" name="">
+          <p:cNvPr id="10" name="PPAGENT_QA|parent=problem-item-1|domains=problem-items">
             <a:extLst xmlns:a="http://schemas.openxmlformats.org/drawingml/2006/main">
               <a:ext uri="{FF2B5EF4-FFF2-40B4-BE49-F238E27FC236}">
-                <a16:creationId xmlns:a16="http://schemas.microsoft.com/office/drawing/2014/main" id="{F9625D4A-9944-4B68-8BAB-03D7AC850327}"/>
+                <a16:creationId xmlns:a16="http://schemas.microsoft.com/office/drawing/2014/main" id="{6B1A441E-8373-47DF-A338-959C946B9837}"/>
               </a:ext>
             </a:extLst>
           </p:cNvPr>
@@ -1554,10 +1554,10 @@
       </p:sp>
       <p:sp>
         <p:nvSpPr>
-          <p:cNvPr id="11" name="">
+          <p:cNvPr id="11" name="PPAGENT_QA|within=problem-item-1|role=title">
             <a:extLst xmlns:a="http://schemas.openxmlformats.org/drawingml/2006/main">
               <a:ext uri="{FF2B5EF4-FFF2-40B4-BE49-F238E27FC236}">
-                <a16:creationId xmlns:a16="http://schemas.microsoft.com/office/drawing/2014/main" id="{219DB2EA-A495-4954-88D4-7F941306E0BD}"/>
+                <a16:creationId xmlns:a16="http://schemas.microsoft.com/office/drawing/2014/main" id="{86C79766-0971-4282-BC48-AAC2C73B53B3}"/>
               </a:ext>
             </a:extLst>
           </p:cNvPr>
@@ -1587,7 +1587,7 @@
           <a:lstStyle xmlns:a="http://schemas.openxmlformats.org/drawingml/2006/main"/>
           <a:p xmlns:a="http://schemas.openxmlformats.org/drawingml/2006/main">
             <a:pPr algn="l">
-              <a:defRPr sz="1275" b="1">
+              <a:defRPr sz="1425" b="1">
                 <a:solidFill>
                   <a:srgbClr val="475569"/>
                 </a:solidFill>
@@ -1597,7 +1597,7 @@
               </a:defRPr>
             </a:pPr>
             <a:r>
-              <a:rPr sz="1275" b="1">
+              <a:rPr sz="1425" b="1">
                 <a:solidFill>
                   <a:srgbClr val="475569"/>
                 </a:solidFill>
@@ -1612,10 +1612,10 @@
       </p:sp>
       <p:sp>
         <p:nvSpPr>
-          <p:cNvPr id="12" name="">
+          <p:cNvPr id="12" name="PPAGENT_QA|within=problem-item-1|role=body">
             <a:extLst xmlns:a="http://schemas.openxmlformats.org/drawingml/2006/main">
               <a:ext uri="{FF2B5EF4-FFF2-40B4-BE49-F238E27FC236}">
-                <a16:creationId xmlns:a16="http://schemas.microsoft.com/office/drawing/2014/main" id="{5376DD6D-1261-439A-A915-5F45538DA3B9}"/>
+                <a16:creationId xmlns:a16="http://schemas.microsoft.com/office/drawing/2014/main" id="{54CB99B6-C32B-4C66-9DB1-92A3DB12C8E9}"/>
               </a:ext>
             </a:extLst>
           </p:cNvPr>
@@ -1645,7 +1645,7 @@
           <a:lstStyle xmlns:a="http://schemas.openxmlformats.org/drawingml/2006/main"/>
           <a:p xmlns:a="http://schemas.openxmlformats.org/drawingml/2006/main">
             <a:pPr algn="l">
-              <a:defRPr sz="1050" b="0">
+              <a:defRPr sz="1350" b="0">
                 <a:solidFill>
                   <a:srgbClr val="475569"/>
                 </a:solidFill>
@@ -1655,7 +1655,7 @@
               </a:defRPr>
             </a:pPr>
             <a:r>
-              <a:rPr sz="1050" b="0">
+              <a:rPr sz="1350" b="0">
                 <a:solidFill>
                   <a:srgbClr val="475569"/>
                 </a:solidFill>
@@ -1670,10 +1670,10 @@
       </p:sp>
       <p:sp>
         <p:nvSpPr>
-          <p:cNvPr id="13" name="">
+          <p:cNvPr id="13" name="PPAGENT_QA|parent=improvement-item-0|domains=improvement-items">
             <a:extLst xmlns:a="http://schemas.openxmlformats.org/drawingml/2006/main">
               <a:ext uri="{FF2B5EF4-FFF2-40B4-BE49-F238E27FC236}">
-                <a16:creationId xmlns:a16="http://schemas.microsoft.com/office/drawing/2014/main" id="{ED4DA3AC-2A48-429C-95B4-04290D8BEE68}"/>
+                <a16:creationId xmlns:a16="http://schemas.microsoft.com/office/drawing/2014/main" id="{04998040-BEE8-4267-99F2-B9E6CFEB44AE}"/>
               </a:ext>
             </a:extLst>
           </p:cNvPr>
@@ -1705,10 +1705,10 @@
       </p:sp>
       <p:sp>
         <p:nvSpPr>
-          <p:cNvPr id="14" name="">
+          <p:cNvPr id="14" name="PPAGENT_QA|within=improvement-item-0|role=title">
             <a:extLst xmlns:a="http://schemas.openxmlformats.org/drawingml/2006/main">
               <a:ext uri="{FF2B5EF4-FFF2-40B4-BE49-F238E27FC236}">
-                <a16:creationId xmlns:a16="http://schemas.microsoft.com/office/drawing/2014/main" id="{0B7D440C-5681-41FD-876C-97102212E731}"/>
+                <a16:creationId xmlns:a16="http://schemas.microsoft.com/office/drawing/2014/main" id="{AA20A19E-4CEA-4EB6-8D63-EF722FA96706}"/>
               </a:ext>
             </a:extLst>
           </p:cNvPr>
@@ -1738,7 +1738,7 @@
           <a:lstStyle xmlns:a="http://schemas.openxmlformats.org/drawingml/2006/main"/>
           <a:p xmlns:a="http://schemas.openxmlformats.org/drawingml/2006/main">
             <a:pPr algn="l">
-              <a:defRPr sz="1275" b="1">
+              <a:defRPr sz="1425" b="1">
                 <a:solidFill>
                   <a:srgbClr val="475569"/>
                 </a:solidFill>
@@ -1748,7 +1748,7 @@
               </a:defRPr>
             </a:pPr>
             <a:r>
-              <a:rPr sz="1275" b="1">
+              <a:rPr sz="1425" b="1">
                 <a:solidFill>
                   <a:srgbClr val="475569"/>
                 </a:solidFill>
@@ -1763,10 +1763,10 @@
       </p:sp>
       <p:sp>
         <p:nvSpPr>
-          <p:cNvPr id="15" name="">
+          <p:cNvPr id="15" name="PPAGENT_QA|within=improvement-item-0|role=body">
             <a:extLst xmlns:a="http://schemas.openxmlformats.org/drawingml/2006/main">
               <a:ext uri="{FF2B5EF4-FFF2-40B4-BE49-F238E27FC236}">
-                <a16:creationId xmlns:a16="http://schemas.microsoft.com/office/drawing/2014/main" id="{897F5039-BFA2-41C3-B53C-2EE3152D5C40}"/>
+                <a16:creationId xmlns:a16="http://schemas.microsoft.com/office/drawing/2014/main" id="{25B502CB-EB47-4B90-9459-FCE307EAA7A7}"/>
               </a:ext>
             </a:extLst>
           </p:cNvPr>
@@ -1796,7 +1796,7 @@
           <a:lstStyle xmlns:a="http://schemas.openxmlformats.org/drawingml/2006/main"/>
           <a:p xmlns:a="http://schemas.openxmlformats.org/drawingml/2006/main">
             <a:pPr algn="l">
-              <a:defRPr sz="1050" b="0">
+              <a:defRPr sz="1350" b="0">
                 <a:solidFill>
                   <a:srgbClr val="475569"/>
                 </a:solidFill>
@@ -1806,7 +1806,7 @@
               </a:defRPr>
             </a:pPr>
             <a:r>
-              <a:rPr sz="1050" b="0">
+              <a:rPr sz="1350" b="0">
                 <a:solidFill>
                   <a:srgbClr val="475569"/>
                 </a:solidFill>
@@ -1821,10 +1821,10 @@
       </p:sp>
       <p:sp>
         <p:nvSpPr>
-          <p:cNvPr id="16" name="">
+          <p:cNvPr id="16" name="PPAGENT_QA|parent=improvement-item-1|domains=improvement-items">
             <a:extLst xmlns:a="http://schemas.openxmlformats.org/drawingml/2006/main">
               <a:ext uri="{FF2B5EF4-FFF2-40B4-BE49-F238E27FC236}">
-                <a16:creationId xmlns:a16="http://schemas.microsoft.com/office/drawing/2014/main" id="{60966E39-9D06-45FE-9260-19D404F0F990}"/>
+                <a16:creationId xmlns:a16="http://schemas.microsoft.com/office/drawing/2014/main" id="{0DAE2A6E-8652-40AB-8A39-6415853C66A8}"/>
               </a:ext>
             </a:extLst>
           </p:cNvPr>
@@ -1862,10 +1862,10 @@
       </p:sp>
       <p:sp>
         <p:nvSpPr>
-          <p:cNvPr id="17" name="">
+          <p:cNvPr id="17" name="PPAGENT_QA|within=improvement-item-1|role=title">
             <a:extLst xmlns:a="http://schemas.openxmlformats.org/drawingml/2006/main">
               <a:ext uri="{FF2B5EF4-FFF2-40B4-BE49-F238E27FC236}">
-                <a16:creationId xmlns:a16="http://schemas.microsoft.com/office/drawing/2014/main" id="{73BD2AB6-04B3-4F14-92B1-05969F03C538}"/>
+                <a16:creationId xmlns:a16="http://schemas.microsoft.com/office/drawing/2014/main" id="{EF1C4BCE-3E5F-482A-A8F2-1AAC61E9FD31}"/>
               </a:ext>
             </a:extLst>
           </p:cNvPr>
@@ -1895,7 +1895,7 @@
           <a:lstStyle xmlns:a="http://schemas.openxmlformats.org/drawingml/2006/main"/>
           <a:p xmlns:a="http://schemas.openxmlformats.org/drawingml/2006/main">
             <a:pPr algn="l">
-              <a:defRPr sz="1275" b="1">
+              <a:defRPr sz="1425" b="1">
                 <a:solidFill>
                   <a:srgbClr val="FFFFFF"/>
                 </a:solidFill>
@@ -1905,7 +1905,7 @@
               </a:defRPr>
             </a:pPr>
             <a:r>
-              <a:rPr sz="1275" b="1">
+              <a:rPr sz="1425" b="1">
                 <a:solidFill>
                   <a:srgbClr val="FFFFFF"/>
                 </a:solidFill>
@@ -1920,10 +1920,10 @@
       </p:sp>
       <p:sp>
         <p:nvSpPr>
-          <p:cNvPr id="18" name="">
+          <p:cNvPr id="18" name="PPAGENT_QA|within=improvement-item-1|role=body">
             <a:extLst xmlns:a="http://schemas.openxmlformats.org/drawingml/2006/main">
               <a:ext uri="{FF2B5EF4-FFF2-40B4-BE49-F238E27FC236}">
-                <a16:creationId xmlns:a16="http://schemas.microsoft.com/office/drawing/2014/main" id="{8D962800-69DC-4003-8346-C3ED1B738777}"/>
+                <a16:creationId xmlns:a16="http://schemas.microsoft.com/office/drawing/2014/main" id="{4EC5A8AF-11B5-47B6-AF92-57180CD0083B}"/>
               </a:ext>
             </a:extLst>
           </p:cNvPr>
@@ -1953,7 +1953,7 @@
           <a:lstStyle xmlns:a="http://schemas.openxmlformats.org/drawingml/2006/main"/>
           <a:p xmlns:a="http://schemas.openxmlformats.org/drawingml/2006/main">
             <a:pPr algn="l">
-              <a:defRPr sz="1050" b="0">
+              <a:defRPr sz="1350" b="0">
                 <a:solidFill>
                   <a:srgbClr val="FFFFFF"/>
                 </a:solidFill>
@@ -1963,7 +1963,7 @@
               </a:defRPr>
             </a:pPr>
             <a:r>
-              <a:rPr sz="1050" b="0">
+              <a:rPr sz="1350" b="0">
                 <a:solidFill>
                   <a:srgbClr val="FFFFFF"/>
                 </a:solidFill>
@@ -1981,7 +1981,7 @@
           <p:cNvPr id="19" name="">
             <a:extLst xmlns:a="http://schemas.openxmlformats.org/drawingml/2006/main">
               <a:ext uri="{FF2B5EF4-FFF2-40B4-BE49-F238E27FC236}">
-                <a16:creationId xmlns:a16="http://schemas.microsoft.com/office/drawing/2014/main" id="{23DDA663-CE0A-4494-BBB5-D15D0D3B0143}"/>
+                <a16:creationId xmlns:a16="http://schemas.microsoft.com/office/drawing/2014/main" id="{2CD075DD-6CAA-49BF-BEB2-0A32687F53B0}"/>
               </a:ext>
             </a:extLst>
           </p:cNvPr>
@@ -2016,7 +2016,7 @@
     </p:spTree>
     <p:extLst>
       <p:ext uri="{BB962C8B-B14F-4D97-AF65-F5344CB8AC3E}">
-        <p14:creationId xmlns:p14="http://schemas.microsoft.com/office/powerpoint/2010/main" val="306334950"/>
+        <p14:creationId xmlns:p14="http://schemas.microsoft.com/office/powerpoint/2010/main" val="860145192"/>
       </p:ext>
     </p:extLst>
   </p:cSld>

</xml_diff>

<commit_message>
feat: migrate formal style groups to unified asset packages
</commit_message>
<xml_diff>
--- a/assets/正文/问题与改进措施-001/example.pptx
+++ b/assets/正文/问题与改进措施-001/example.pptx
@@ -2,13 +2,16 @@
 <file path=ppt/presentation.xml><?xml version="1.0" encoding="utf-8"?>
 <p:presentation xmlns:p="http://schemas.openxmlformats.org/presentationml/2006/main">
   <p:sldMasterIdLst>
-    <p:sldMasterId xmlns:r="http://schemas.openxmlformats.org/officeDocument/2006/relationships" id="2147483648" r:id="Rb6915671ff2a4d0d"/>
+    <p:sldMasterId xmlns:r="http://schemas.openxmlformats.org/officeDocument/2006/relationships" id="2147483648" r:id="Rd916d382d2b94ae0"/>
   </p:sldMasterIdLst>
   <p:notesMasterIdLst>
-    <p:notesMasterId xmlns:r="http://schemas.openxmlformats.org/officeDocument/2006/relationships" r:id="R792ff71ca8dd4e66"/>
+    <p:notesMasterId xmlns:r="http://schemas.openxmlformats.org/officeDocument/2006/relationships" r:id="Ra7269c9f874c4065"/>
   </p:notesMasterIdLst>
   <p:sldIdLst>
-    <p:sldId xmlns:r="http://schemas.openxmlformats.org/officeDocument/2006/relationships" id="256" r:id="Ra3800c43ed954db9"/>
+    <p:sldId xmlns:r="http://schemas.openxmlformats.org/officeDocument/2006/relationships" id="256" r:id="Rd3bcf120408e4f49"/>
+    <p:sldId xmlns:r="http://schemas.openxmlformats.org/officeDocument/2006/relationships" id="257" r:id="R78aa793a7d7c42a3"/>
+    <p:sldId xmlns:r="http://schemas.openxmlformats.org/officeDocument/2006/relationships" id="258" r:id="R6f201a3336054462"/>
+    <p:sldId xmlns:r="http://schemas.openxmlformats.org/officeDocument/2006/relationships" id="259" r:id="R08dc352e374e4fdf"/>
   </p:sldIdLst>
   <p:sldSz cx="12192000" cy="6858000"/>
   <p:notesSz cx="6858000" cy="9144000"/>
@@ -468,6 +471,204 @@
 </p:notes>
 </file>
 
+<file path=ppt/notesSlides/notesSlide2.xml><?xml version="1.0" encoding="utf-8"?>
+<p:notes xmlns:p="http://schemas.openxmlformats.org/presentationml/2006/main">
+  <p:cSld>
+    <p:spTree>
+      <p:nvGrpSpPr>
+        <p:cNvPr id="1" name=""/>
+        <p:cNvGrpSpPr/>
+        <p:nvPr/>
+      </p:nvGrpSpPr>
+      <p:grpSpPr>
+        <a:xfrm xmlns:a="http://schemas.openxmlformats.org/drawingml/2006/main"/>
+      </p:grpSpPr>
+      <p:sp>
+        <p:nvSpPr>
+          <p:cNvPr id="2" name="Slide Image Placeholder 1"/>
+          <p:cNvSpPr>
+            <a:spLocks xmlns:a="http://schemas.openxmlformats.org/drawingml/2006/main" noGrp="1"/>
+          </p:cNvSpPr>
+          <p:nvPr>
+            <p:ph type="sldImg" idx="0"/>
+          </p:nvPr>
+        </p:nvSpPr>
+        <p:spPr/>
+      </p:sp>
+      <p:sp>
+        <p:nvSpPr>
+          <p:cNvPr id="3" name="Notes Placeholder 2"/>
+          <p:cNvSpPr>
+            <a:spLocks xmlns:a="http://schemas.openxmlformats.org/drawingml/2006/main" noGrp="1"/>
+          </p:cNvSpPr>
+          <p:nvPr>
+            <p:ph type="body" idx="1"/>
+          </p:nvPr>
+        </p:nvSpPr>
+        <p:spPr/>
+        <p:txBody>
+          <a:bodyPr xmlns:a="http://schemas.openxmlformats.org/drawingml/2006/main"/>
+          <a:lstStyle xmlns:a="http://schemas.openxmlformats.org/drawingml/2006/main"/>
+          <a:p xmlns:a="http://schemas.openxmlformats.org/drawingml/2006/main"/>
+        </p:txBody>
+      </p:sp>
+      <p:sp>
+        <p:nvSpPr>
+          <p:cNvPr id="4" name="Slide Number Placeholder 3"/>
+          <p:cNvSpPr>
+            <a:spLocks xmlns:a="http://schemas.openxmlformats.org/drawingml/2006/main" noGrp="1"/>
+          </p:cNvSpPr>
+          <p:nvPr>
+            <p:ph type="sldNum" idx="5"/>
+          </p:nvPr>
+        </p:nvSpPr>
+        <p:spPr/>
+        <p:txBody>
+          <a:bodyPr xmlns:a="http://schemas.openxmlformats.org/drawingml/2006/main"/>
+          <a:lstStyle xmlns:a="http://schemas.openxmlformats.org/drawingml/2006/main"/>
+          <a:p xmlns:a="http://schemas.openxmlformats.org/drawingml/2006/main"/>
+        </p:txBody>
+      </p:sp>
+    </p:spTree>
+  </p:cSld>
+  <p:clrMapOvr>
+    <a:masterClrMapping xmlns:a="http://schemas.openxmlformats.org/drawingml/2006/main"/>
+  </p:clrMapOvr>
+</p:notes>
+</file>
+
+<file path=ppt/notesSlides/notesSlide3.xml><?xml version="1.0" encoding="utf-8"?>
+<p:notes xmlns:p="http://schemas.openxmlformats.org/presentationml/2006/main">
+  <p:cSld>
+    <p:spTree>
+      <p:nvGrpSpPr>
+        <p:cNvPr id="1" name=""/>
+        <p:cNvGrpSpPr/>
+        <p:nvPr/>
+      </p:nvGrpSpPr>
+      <p:grpSpPr>
+        <a:xfrm xmlns:a="http://schemas.openxmlformats.org/drawingml/2006/main"/>
+      </p:grpSpPr>
+      <p:sp>
+        <p:nvSpPr>
+          <p:cNvPr id="2" name="Slide Image Placeholder 1"/>
+          <p:cNvSpPr>
+            <a:spLocks xmlns:a="http://schemas.openxmlformats.org/drawingml/2006/main" noGrp="1"/>
+          </p:cNvSpPr>
+          <p:nvPr>
+            <p:ph type="sldImg" idx="0"/>
+          </p:nvPr>
+        </p:nvSpPr>
+        <p:spPr/>
+      </p:sp>
+      <p:sp>
+        <p:nvSpPr>
+          <p:cNvPr id="3" name="Notes Placeholder 2"/>
+          <p:cNvSpPr>
+            <a:spLocks xmlns:a="http://schemas.openxmlformats.org/drawingml/2006/main" noGrp="1"/>
+          </p:cNvSpPr>
+          <p:nvPr>
+            <p:ph type="body" idx="1"/>
+          </p:nvPr>
+        </p:nvSpPr>
+        <p:spPr/>
+        <p:txBody>
+          <a:bodyPr xmlns:a="http://schemas.openxmlformats.org/drawingml/2006/main"/>
+          <a:lstStyle xmlns:a="http://schemas.openxmlformats.org/drawingml/2006/main"/>
+          <a:p xmlns:a="http://schemas.openxmlformats.org/drawingml/2006/main"/>
+        </p:txBody>
+      </p:sp>
+      <p:sp>
+        <p:nvSpPr>
+          <p:cNvPr id="4" name="Slide Number Placeholder 3"/>
+          <p:cNvSpPr>
+            <a:spLocks xmlns:a="http://schemas.openxmlformats.org/drawingml/2006/main" noGrp="1"/>
+          </p:cNvSpPr>
+          <p:nvPr>
+            <p:ph type="sldNum" idx="5"/>
+          </p:nvPr>
+        </p:nvSpPr>
+        <p:spPr/>
+        <p:txBody>
+          <a:bodyPr xmlns:a="http://schemas.openxmlformats.org/drawingml/2006/main"/>
+          <a:lstStyle xmlns:a="http://schemas.openxmlformats.org/drawingml/2006/main"/>
+          <a:p xmlns:a="http://schemas.openxmlformats.org/drawingml/2006/main"/>
+        </p:txBody>
+      </p:sp>
+    </p:spTree>
+  </p:cSld>
+  <p:clrMapOvr>
+    <a:masterClrMapping xmlns:a="http://schemas.openxmlformats.org/drawingml/2006/main"/>
+  </p:clrMapOvr>
+</p:notes>
+</file>
+
+<file path=ppt/notesSlides/notesSlide4.xml><?xml version="1.0" encoding="utf-8"?>
+<p:notes xmlns:p="http://schemas.openxmlformats.org/presentationml/2006/main">
+  <p:cSld>
+    <p:spTree>
+      <p:nvGrpSpPr>
+        <p:cNvPr id="1" name=""/>
+        <p:cNvGrpSpPr/>
+        <p:nvPr/>
+      </p:nvGrpSpPr>
+      <p:grpSpPr>
+        <a:xfrm xmlns:a="http://schemas.openxmlformats.org/drawingml/2006/main"/>
+      </p:grpSpPr>
+      <p:sp>
+        <p:nvSpPr>
+          <p:cNvPr id="2" name="Slide Image Placeholder 1"/>
+          <p:cNvSpPr>
+            <a:spLocks xmlns:a="http://schemas.openxmlformats.org/drawingml/2006/main" noGrp="1"/>
+          </p:cNvSpPr>
+          <p:nvPr>
+            <p:ph type="sldImg" idx="0"/>
+          </p:nvPr>
+        </p:nvSpPr>
+        <p:spPr/>
+      </p:sp>
+      <p:sp>
+        <p:nvSpPr>
+          <p:cNvPr id="3" name="Notes Placeholder 2"/>
+          <p:cNvSpPr>
+            <a:spLocks xmlns:a="http://schemas.openxmlformats.org/drawingml/2006/main" noGrp="1"/>
+          </p:cNvSpPr>
+          <p:nvPr>
+            <p:ph type="body" idx="1"/>
+          </p:nvPr>
+        </p:nvSpPr>
+        <p:spPr/>
+        <p:txBody>
+          <a:bodyPr xmlns:a="http://schemas.openxmlformats.org/drawingml/2006/main"/>
+          <a:lstStyle xmlns:a="http://schemas.openxmlformats.org/drawingml/2006/main"/>
+          <a:p xmlns:a="http://schemas.openxmlformats.org/drawingml/2006/main"/>
+        </p:txBody>
+      </p:sp>
+      <p:sp>
+        <p:nvSpPr>
+          <p:cNvPr id="4" name="Slide Number Placeholder 3"/>
+          <p:cNvSpPr>
+            <a:spLocks xmlns:a="http://schemas.openxmlformats.org/drawingml/2006/main" noGrp="1"/>
+          </p:cNvSpPr>
+          <p:nvPr>
+            <p:ph type="sldNum" idx="5"/>
+          </p:nvPr>
+        </p:nvSpPr>
+        <p:spPr/>
+        <p:txBody>
+          <a:bodyPr xmlns:a="http://schemas.openxmlformats.org/drawingml/2006/main"/>
+          <a:lstStyle xmlns:a="http://schemas.openxmlformats.org/drawingml/2006/main"/>
+          <a:p xmlns:a="http://schemas.openxmlformats.org/drawingml/2006/main"/>
+        </p:txBody>
+      </p:sp>
+    </p:spTree>
+  </p:cSld>
+  <p:clrMapOvr>
+    <a:masterClrMapping xmlns:a="http://schemas.openxmlformats.org/drawingml/2006/main"/>
+  </p:clrMapOvr>
+</p:notes>
+</file>
+
 <file path=ppt/slideLayouts/slideLayout1.xml><?xml version="1.0" encoding="utf-8"?>
 <p:sldLayout xmlns:p="http://schemas.openxmlformats.org/presentationml/2006/main" type="title">
   <p:cSld name="Title Slide">
@@ -506,7 +707,7 @@
   </p:cSld>
   <p:clrMap bg1="lt1" tx1="dk1" bg2="lt2" tx2="dk2" accent1="accent1" accent2="accent2" accent3="accent3" accent4="accent4" accent5="accent5" accent6="accent6" hlink="hlink" folHlink="folHlink"/>
   <p:sldLayoutIdLst>
-    <p:sldLayoutId xmlns:r="http://schemas.openxmlformats.org/officeDocument/2006/relationships" id="2147483649" r:id="R25316345f5f64b56"/>
+    <p:sldLayoutId xmlns:r="http://schemas.openxmlformats.org/officeDocument/2006/relationships" id="2147483649" r:id="Rd0da9b5d10b24e1e"/>
   </p:sldLayoutIdLst>
   <p:txStyles>
     <p:titleStyle>
@@ -1057,7 +1258,7 @@
           <p:cNvPr id="20" name="">
             <a:extLst xmlns:a="http://schemas.openxmlformats.org/drawingml/2006/main">
               <a:ext uri="{FF2B5EF4-FFF2-40B4-BE49-F238E27FC236}">
-                <a16:creationId xmlns:a16="http://schemas.microsoft.com/office/drawing/2014/main" id="{D0A662CD-AF1D-4338-B339-48DB9070D593}"/>
+                <a16:creationId xmlns:a16="http://schemas.microsoft.com/office/drawing/2014/main" id="{A076AF39-6B1E-4EA4-9A7E-C25A9C525967}"/>
               </a:ext>
             </a:extLst>
           </p:cNvPr>
@@ -1105,7 +1306,7 @@
                 <a:ea typeface="Microsoft YaHei"/>
                 <a:cs typeface="Microsoft YaHei"/>
               </a:rPr>
-              <a:t>让制作能力变成可复用的生产能力</a:t>
+              <a:t>问题与改进措施</a:t>
             </a:r>
           </a:p>
         </p:txBody>
@@ -1115,7 +1316,7 @@
           <p:cNvPr id="2" name="">
             <a:extLst xmlns:a="http://schemas.openxmlformats.org/drawingml/2006/main">
               <a:ext uri="{FF2B5EF4-FFF2-40B4-BE49-F238E27FC236}">
-                <a16:creationId xmlns:a16="http://schemas.microsoft.com/office/drawing/2014/main" id="{E720BD10-FA04-417F-A292-1D6FBEBB130B}"/>
+                <a16:creationId xmlns:a16="http://schemas.microsoft.com/office/drawing/2014/main" id="{FF489B8A-1CA4-4327-9496-01ADE4DC54CF}"/>
               </a:ext>
             </a:extLst>
           </p:cNvPr>
@@ -1173,7 +1374,7 @@
           <p:cNvPr id="3" name="">
             <a:extLst xmlns:a="http://schemas.openxmlformats.org/drawingml/2006/main">
               <a:ext uri="{FF2B5EF4-FFF2-40B4-BE49-F238E27FC236}">
-                <a16:creationId xmlns:a16="http://schemas.microsoft.com/office/drawing/2014/main" id="{9F91D5A6-8B7B-4CA6-962F-513E3FC92590}"/>
+                <a16:creationId xmlns:a16="http://schemas.microsoft.com/office/drawing/2014/main" id="{90A62CBB-7BE7-4AF3-BB2F-DEF69737B0BB}"/>
               </a:ext>
             </a:extLst>
           </p:cNvPr>
@@ -1214,7 +1415,7 @@
           <p:cNvPr id="4" name="">
             <a:extLst xmlns:a="http://schemas.openxmlformats.org/drawingml/2006/main">
               <a:ext uri="{FF2B5EF4-FFF2-40B4-BE49-F238E27FC236}">
-                <a16:creationId xmlns:a16="http://schemas.microsoft.com/office/drawing/2014/main" id="{6E76672C-4A50-4FDC-8E2F-B2E92A7F8774}"/>
+                <a16:creationId xmlns:a16="http://schemas.microsoft.com/office/drawing/2014/main" id="{C402A8CB-38B4-4797-B4D1-D1FD2D9EEDA7}"/>
               </a:ext>
             </a:extLst>
           </p:cNvPr>
@@ -1255,7 +1456,7 @@
           <p:cNvPr id="5" name="">
             <a:extLst xmlns:a="http://schemas.openxmlformats.org/drawingml/2006/main">
               <a:ext uri="{FF2B5EF4-FFF2-40B4-BE49-F238E27FC236}">
-                <a16:creationId xmlns:a16="http://schemas.microsoft.com/office/drawing/2014/main" id="{FCF3EB8D-DC5E-45E3-B7BE-1C7FFFF933D3}"/>
+                <a16:creationId xmlns:a16="http://schemas.microsoft.com/office/drawing/2014/main" id="{03A89194-B801-401C-82AA-EE30959A7734}"/>
               </a:ext>
             </a:extLst>
           </p:cNvPr>
@@ -1313,7 +1514,7 @@
           <p:cNvPr id="6" name="">
             <a:extLst xmlns:a="http://schemas.openxmlformats.org/drawingml/2006/main">
               <a:ext uri="{FF2B5EF4-FFF2-40B4-BE49-F238E27FC236}">
-                <a16:creationId xmlns:a16="http://schemas.microsoft.com/office/drawing/2014/main" id="{8743A5F0-5F44-4D28-9700-FA3DACC98269}"/>
+                <a16:creationId xmlns:a16="http://schemas.microsoft.com/office/drawing/2014/main" id="{CAB66060-4F87-45F4-BABD-D13981136AC6}"/>
               </a:ext>
             </a:extLst>
           </p:cNvPr>
@@ -1371,7 +1572,7 @@
           <p:cNvPr id="7" name="PPAGENT_QA|parent=problem-item-0|domains=problem-items">
             <a:extLst xmlns:a="http://schemas.openxmlformats.org/drawingml/2006/main">
               <a:ext uri="{FF2B5EF4-FFF2-40B4-BE49-F238E27FC236}">
-                <a16:creationId xmlns:a16="http://schemas.microsoft.com/office/drawing/2014/main" id="{B8ADB154-0150-4110-A72A-AD8D623C2D33}"/>
+                <a16:creationId xmlns:a16="http://schemas.microsoft.com/office/drawing/2014/main" id="{968EC813-A0C8-4147-9381-2515F601BA93}"/>
               </a:ext>
             </a:extLst>
           </p:cNvPr>
@@ -1406,7 +1607,7 @@
           <p:cNvPr id="8" name="PPAGENT_QA|within=problem-item-0|role=title">
             <a:extLst xmlns:a="http://schemas.openxmlformats.org/drawingml/2006/main">
               <a:ext uri="{FF2B5EF4-FFF2-40B4-BE49-F238E27FC236}">
-                <a16:creationId xmlns:a16="http://schemas.microsoft.com/office/drawing/2014/main" id="{3DD08794-626F-4B20-9773-921D11E4B574}"/>
+                <a16:creationId xmlns:a16="http://schemas.microsoft.com/office/drawing/2014/main" id="{C6CA9616-AD4C-4D1D-AB5B-D35B5488EFC2}"/>
               </a:ext>
             </a:extLst>
           </p:cNvPr>
@@ -1454,7 +1655,7 @@
                 <a:ea typeface="Microsoft YaHei"/>
                 <a:cs typeface="Microsoft YaHei"/>
               </a:rPr>
-              <a:t>已有内容</a:t>
+              <a:t>结果不稳定</a:t>
             </a:r>
           </a:p>
         </p:txBody>
@@ -1464,7 +1665,7 @@
           <p:cNvPr id="9" name="PPAGENT_QA|within=problem-item-0|role=body">
             <a:extLst xmlns:a="http://schemas.openxmlformats.org/drawingml/2006/main">
               <a:ext uri="{FF2B5EF4-FFF2-40B4-BE49-F238E27FC236}">
-                <a16:creationId xmlns:a16="http://schemas.microsoft.com/office/drawing/2014/main" id="{8FC99885-2662-4968-97CE-EAF3DB96082C}"/>
+                <a16:creationId xmlns:a16="http://schemas.microsoft.com/office/drawing/2014/main" id="{4EA45D61-F14B-4815-A4F9-0A1740D905C5}"/>
               </a:ext>
             </a:extLst>
           </p:cNvPr>
@@ -1512,7 +1713,7 @@
                 <a:ea typeface="Microsoft YaHei"/>
                 <a:cs typeface="Microsoft YaHei"/>
               </a:rPr>
-              <a:t>有专业知识，也有真实的汇报任务。</a:t>
+              <a:t>相同输入仍可能得到差异较大的页面</a:t>
             </a:r>
           </a:p>
         </p:txBody>
@@ -1522,7 +1723,7 @@
           <p:cNvPr id="10" name="PPAGENT_QA|parent=problem-item-1|domains=problem-items">
             <a:extLst xmlns:a="http://schemas.openxmlformats.org/drawingml/2006/main">
               <a:ext uri="{FF2B5EF4-FFF2-40B4-BE49-F238E27FC236}">
-                <a16:creationId xmlns:a16="http://schemas.microsoft.com/office/drawing/2014/main" id="{6B1A441E-8373-47DF-A338-959C946B9837}"/>
+                <a16:creationId xmlns:a16="http://schemas.microsoft.com/office/drawing/2014/main" id="{8371F8AD-F343-45F7-BD12-5E140696B788}"/>
               </a:ext>
             </a:extLst>
           </p:cNvPr>
@@ -1557,7 +1758,7 @@
           <p:cNvPr id="11" name="PPAGENT_QA|within=problem-item-1|role=title">
             <a:extLst xmlns:a="http://schemas.openxmlformats.org/drawingml/2006/main">
               <a:ext uri="{FF2B5EF4-FFF2-40B4-BE49-F238E27FC236}">
-                <a16:creationId xmlns:a16="http://schemas.microsoft.com/office/drawing/2014/main" id="{86C79766-0971-4282-BC48-AAC2C73B53B3}"/>
+                <a16:creationId xmlns:a16="http://schemas.microsoft.com/office/drawing/2014/main" id="{31166185-4F7D-4B7C-B20F-289BBBF523DD}"/>
               </a:ext>
             </a:extLst>
           </p:cNvPr>
@@ -1605,7 +1806,7 @@
                 <a:ea typeface="Microsoft YaHei"/>
                 <a:cs typeface="Microsoft YaHei"/>
               </a:rPr>
-              <a:t>缺少制作能力</a:t>
+              <a:t>经验难沉淀</a:t>
             </a:r>
           </a:p>
         </p:txBody>
@@ -1615,7 +1816,7 @@
           <p:cNvPr id="12" name="PPAGENT_QA|within=problem-item-1|role=body">
             <a:extLst xmlns:a="http://schemas.openxmlformats.org/drawingml/2006/main">
               <a:ext uri="{FF2B5EF4-FFF2-40B4-BE49-F238E27FC236}">
-                <a16:creationId xmlns:a16="http://schemas.microsoft.com/office/drawing/2014/main" id="{54CB99B6-C32B-4C66-9DB1-92A3DB12C8E9}"/>
+                <a16:creationId xmlns:a16="http://schemas.microsoft.com/office/drawing/2014/main" id="{C7C5A9BD-3999-4C52-A789-2B2D7A6C0644}"/>
               </a:ext>
             </a:extLst>
           </p:cNvPr>
@@ -1663,7 +1864,7 @@
                 <a:ea typeface="Microsoft YaHei"/>
                 <a:cs typeface="Microsoft YaHei"/>
               </a:rPr>
-              <a:t>不擅长拆页、选表达方式和视觉排版。</a:t>
+              <a:t>每次任务都需要重新判断和修正</a:t>
             </a:r>
           </a:p>
         </p:txBody>
@@ -1673,7 +1874,7 @@
           <p:cNvPr id="13" name="PPAGENT_QA|parent=improvement-item-0|domains=improvement-items">
             <a:extLst xmlns:a="http://schemas.openxmlformats.org/drawingml/2006/main">
               <a:ext uri="{FF2B5EF4-FFF2-40B4-BE49-F238E27FC236}">
-                <a16:creationId xmlns:a16="http://schemas.microsoft.com/office/drawing/2014/main" id="{04998040-BEE8-4267-99F2-B9E6CFEB44AE}"/>
+                <a16:creationId xmlns:a16="http://schemas.microsoft.com/office/drawing/2014/main" id="{5C1425E3-5B8E-4067-B907-36DC7F6FFF52}"/>
               </a:ext>
             </a:extLst>
           </p:cNvPr>
@@ -1708,7 +1909,7 @@
           <p:cNvPr id="14" name="PPAGENT_QA|within=improvement-item-0|role=title">
             <a:extLst xmlns:a="http://schemas.openxmlformats.org/drawingml/2006/main">
               <a:ext uri="{FF2B5EF4-FFF2-40B4-BE49-F238E27FC236}">
-                <a16:creationId xmlns:a16="http://schemas.microsoft.com/office/drawing/2014/main" id="{AA20A19E-4CEA-4EB6-8D63-EF722FA96706}"/>
+                <a16:creationId xmlns:a16="http://schemas.microsoft.com/office/drawing/2014/main" id="{626A3BD1-C493-43F0-A49B-6F7B5F4AE362}"/>
               </a:ext>
             </a:extLst>
           </p:cNvPr>
@@ -1756,7 +1957,7 @@
                 <a:ea typeface="Microsoft YaHei"/>
                 <a:cs typeface="Microsoft YaHei"/>
               </a:rPr>
-              <a:t>把方法做成系统</a:t>
+              <a:t>固定能力边界</a:t>
             </a:r>
           </a:p>
         </p:txBody>
@@ -1766,7 +1967,7 @@
           <p:cNvPr id="15" name="PPAGENT_QA|within=improvement-item-0|role=body">
             <a:extLst xmlns:a="http://schemas.openxmlformats.org/drawingml/2006/main">
               <a:ext uri="{FF2B5EF4-FFF2-40B4-BE49-F238E27FC236}">
-                <a16:creationId xmlns:a16="http://schemas.microsoft.com/office/drawing/2014/main" id="{25B502CB-EB47-4B90-9459-FCE307EAA7A7}"/>
+                <a16:creationId xmlns:a16="http://schemas.microsoft.com/office/drawing/2014/main" id="{2F8DB8DE-EF34-41AB-8F8E-42F7705EFBA4}"/>
               </a:ext>
             </a:extLst>
           </p:cNvPr>
@@ -1814,7 +2015,7 @@
                 <a:ea typeface="Microsoft YaHei"/>
                 <a:cs typeface="Microsoft YaHei"/>
               </a:rPr>
-              <a:t>以较低成本获得接近专业标准的结果。</a:t>
+              <a:t>用已登记 Style Group 承担结构表达</a:t>
             </a:r>
           </a:p>
         </p:txBody>
@@ -1824,7 +2025,7 @@
           <p:cNvPr id="16" name="PPAGENT_QA|parent=improvement-item-1|domains=improvement-items">
             <a:extLst xmlns:a="http://schemas.openxmlformats.org/drawingml/2006/main">
               <a:ext uri="{FF2B5EF4-FFF2-40B4-BE49-F238E27FC236}">
-                <a16:creationId xmlns:a16="http://schemas.microsoft.com/office/drawing/2014/main" id="{0DAE2A6E-8652-40AB-8A39-6415853C66A8}"/>
+                <a16:creationId xmlns:a16="http://schemas.microsoft.com/office/drawing/2014/main" id="{2F1A1930-FF8F-444F-A8D7-87533FB3A448}"/>
               </a:ext>
             </a:extLst>
           </p:cNvPr>
@@ -1844,11 +2045,344 @@
             </a:avLst>
           </a:prstGeom>
           <a:solidFill xmlns:a="http://schemas.openxmlformats.org/drawingml/2006/main">
-            <a:srgbClr val="00A8D8"/>
+            <a:srgbClr val="ECFBFC"/>
           </a:solidFill>
           <a:ln xmlns:a="http://schemas.openxmlformats.org/drawingml/2006/main" w="9525">
             <a:solidFill>
-              <a:srgbClr val="00A8D8"/>
+              <a:srgbClr val="A8E7EA"/>
+            </a:solidFill>
+            <a:prstDash val="solid"/>
+          </a:ln>
+        </p:spPr>
+      </p:sp>
+      <p:sp>
+        <p:nvSpPr>
+          <p:cNvPr id="17" name="PPAGENT_QA|within=improvement-item-1|role=title">
+            <a:extLst xmlns:a="http://schemas.openxmlformats.org/drawingml/2006/main">
+              <a:ext uri="{FF2B5EF4-FFF2-40B4-BE49-F238E27FC236}">
+                <a16:creationId xmlns:a16="http://schemas.microsoft.com/office/drawing/2014/main" id="{1E4DA6E2-AF13-4134-B612-080E167BD860}"/>
+              </a:ext>
+            </a:extLst>
+          </p:cNvPr>
+          <p:cNvSpPr>
+            <a:spLocks xmlns:a="http://schemas.openxmlformats.org/drawingml/2006/main" noGrp="1"/>
+          </p:cNvSpPr>
+          <p:nvPr/>
+        </p:nvSpPr>
+        <p:spPr>
+          <a:xfrm xmlns:a="http://schemas.openxmlformats.org/drawingml/2006/main">
+            <a:off x="7562850" y="4114800"/>
+            <a:ext cx="3409950" cy="247650"/>
+          </a:xfrm>
+          <a:prstGeom xmlns:a="http://schemas.openxmlformats.org/drawingml/2006/main" prst="rect">
+            <a:avLst/>
+          </a:prstGeom>
+          <a:noFill xmlns:a="http://schemas.openxmlformats.org/drawingml/2006/main"/>
+          <a:ln xmlns:a="http://schemas.openxmlformats.org/drawingml/2006/main" w="0">
+            <a:noFill/>
+            <a:prstDash val="solid"/>
+          </a:ln>
+        </p:spPr>
+        <p:txBody>
+          <a:bodyPr xmlns:a="http://schemas.openxmlformats.org/drawingml/2006/main" lIns="0" tIns="0" rIns="0" bIns="0" anchor="ctr">
+            <a:normAutofit fontScale="100000"/>
+          </a:bodyPr>
+          <a:lstStyle xmlns:a="http://schemas.openxmlformats.org/drawingml/2006/main"/>
+          <a:p xmlns:a="http://schemas.openxmlformats.org/drawingml/2006/main">
+            <a:pPr algn="l">
+              <a:defRPr sz="1425" b="1">
+                <a:solidFill>
+                  <a:srgbClr val="475569"/>
+                </a:solidFill>
+                <a:latin typeface="Microsoft YaHei"/>
+                <a:ea typeface="Microsoft YaHei"/>
+                <a:cs typeface="Microsoft YaHei"/>
+              </a:defRPr>
+            </a:pPr>
+            <a:r>
+              <a:rPr sz="1425" b="1">
+                <a:solidFill>
+                  <a:srgbClr val="475569"/>
+                </a:solidFill>
+                <a:latin typeface="Microsoft YaHei"/>
+                <a:ea typeface="Microsoft YaHei"/>
+                <a:cs typeface="Microsoft YaHei"/>
+              </a:rPr>
+              <a:t>统一参数接口</a:t>
+            </a:r>
+          </a:p>
+        </p:txBody>
+      </p:sp>
+      <p:sp>
+        <p:nvSpPr>
+          <p:cNvPr id="18" name="PPAGENT_QA|within=improvement-item-1|role=body">
+            <a:extLst xmlns:a="http://schemas.openxmlformats.org/drawingml/2006/main">
+              <a:ext uri="{FF2B5EF4-FFF2-40B4-BE49-F238E27FC236}">
+                <a16:creationId xmlns:a16="http://schemas.microsoft.com/office/drawing/2014/main" id="{768D8CA5-45AB-43C1-9439-6E7D78E9BF05}"/>
+              </a:ext>
+            </a:extLst>
+          </p:cNvPr>
+          <p:cNvSpPr>
+            <a:spLocks xmlns:a="http://schemas.openxmlformats.org/drawingml/2006/main" noGrp="1"/>
+          </p:cNvSpPr>
+          <p:nvPr/>
+        </p:nvSpPr>
+        <p:spPr>
+          <a:xfrm xmlns:a="http://schemas.openxmlformats.org/drawingml/2006/main">
+            <a:off x="7562850" y="4400550"/>
+            <a:ext cx="3409950" cy="514350"/>
+          </a:xfrm>
+          <a:prstGeom xmlns:a="http://schemas.openxmlformats.org/drawingml/2006/main" prst="rect">
+            <a:avLst/>
+          </a:prstGeom>
+          <a:noFill xmlns:a="http://schemas.openxmlformats.org/drawingml/2006/main"/>
+          <a:ln xmlns:a="http://schemas.openxmlformats.org/drawingml/2006/main" w="0">
+            <a:noFill/>
+            <a:prstDash val="solid"/>
+          </a:ln>
+        </p:spPr>
+        <p:txBody>
+          <a:bodyPr xmlns:a="http://schemas.openxmlformats.org/drawingml/2006/main" lIns="0" tIns="0" rIns="0" bIns="0" anchor="t">
+            <a:normAutofit fontScale="100000"/>
+          </a:bodyPr>
+          <a:lstStyle xmlns:a="http://schemas.openxmlformats.org/drawingml/2006/main"/>
+          <a:p xmlns:a="http://schemas.openxmlformats.org/drawingml/2006/main">
+            <a:pPr algn="l">
+              <a:defRPr sz="1350" b="0">
+                <a:solidFill>
+                  <a:srgbClr val="475569"/>
+                </a:solidFill>
+                <a:latin typeface="Microsoft YaHei"/>
+                <a:ea typeface="Microsoft YaHei"/>
+                <a:cs typeface="Microsoft YaHei"/>
+              </a:defRPr>
+            </a:pPr>
+            <a:r>
+              <a:rPr sz="1350" b="0">
+                <a:solidFill>
+                  <a:srgbClr val="475569"/>
+                </a:solidFill>
+                <a:latin typeface="Microsoft YaHei"/>
+                <a:ea typeface="Microsoft YaHei"/>
+                <a:cs typeface="Microsoft YaHei"/>
+              </a:rPr>
+              <a:t>让 HTML 与 Builder 使用同一输入</a:t>
+            </a:r>
+          </a:p>
+        </p:txBody>
+      </p:sp>
+      <p:sp>
+        <p:nvSpPr>
+          <p:cNvPr id="19" name="">
+            <a:extLst xmlns:a="http://schemas.openxmlformats.org/drawingml/2006/main">
+              <a:ext uri="{FF2B5EF4-FFF2-40B4-BE49-F238E27FC236}">
+                <a16:creationId xmlns:a16="http://schemas.microsoft.com/office/drawing/2014/main" id="{7C3C5A7E-2020-4E10-9D06-DC62A93BF7B0}"/>
+              </a:ext>
+            </a:extLst>
+          </p:cNvPr>
+          <p:cNvSpPr>
+            <a:spLocks xmlns:a="http://schemas.openxmlformats.org/drawingml/2006/main" noGrp="1"/>
+          </p:cNvSpPr>
+          <p:nvPr/>
+        </p:nvSpPr>
+        <p:spPr>
+          <a:xfrm xmlns:a="http://schemas.openxmlformats.org/drawingml/2006/main">
+            <a:off x="5543550" y="3124200"/>
+            <a:ext cx="1104900" cy="1104900"/>
+          </a:xfrm>
+          <a:prstGeom xmlns:a="http://schemas.openxmlformats.org/drawingml/2006/main" prst="rightArrow">
+            <a:avLst/>
+          </a:prstGeom>
+          <a:solidFill xmlns:a="http://schemas.openxmlformats.org/drawingml/2006/main">
+            <a:srgbClr val="14CBD1"/>
+          </a:solidFill>
+          <a:ln xmlns:a="http://schemas.openxmlformats.org/drawingml/2006/main" w="0">
+            <a:noFill/>
+            <a:prstDash val="solid"/>
+          </a:ln>
+        </p:spPr>
+        <p:style>
+          <a:lnRef xmlns:a="http://schemas.openxmlformats.org/drawingml/2006/main" idx="0"/>
+          <a:fillRef xmlns:a="http://schemas.openxmlformats.org/drawingml/2006/main" idx="0"/>
+          <a:effectRef xmlns:a="http://schemas.openxmlformats.org/drawingml/2006/main" idx="6"/>
+          <a:fontRef xmlns:a="http://schemas.openxmlformats.org/drawingml/2006/main" idx="major"/>
+        </p:style>
+      </p:sp>
+    </p:spTree>
+    <p:extLst>
+      <p:ext uri="{BB962C8B-B14F-4D97-AF65-F5344CB8AC3E}">
+        <p14:creationId xmlns:p14="http://schemas.microsoft.com/office/powerpoint/2010/main" val="2079357124"/>
+      </p:ext>
+    </p:extLst>
+  </p:cSld>
+</p:sld>
+</file>
+
+<file path=ppt/slides/slide2.xml><?xml version="1.0" encoding="utf-8"?>
+<p:sld xmlns:p="http://schemas.openxmlformats.org/presentationml/2006/main">
+  <p:cSld>
+    <p:bg>
+      <p:bgPr>
+        <a:solidFill xmlns:a="http://schemas.openxmlformats.org/drawingml/2006/main">
+          <a:srgbClr val="F7FAFC"/>
+        </a:solidFill>
+      </p:bgPr>
+    </p:bg>
+    <p:spTree>
+      <p:nvGrpSpPr>
+        <p:cNvPr id="1" name=""/>
+        <p:cNvGrpSpPr/>
+        <p:nvPr/>
+      </p:nvGrpSpPr>
+      <p:grpSpPr>
+        <a:xfrm xmlns:a="http://schemas.openxmlformats.org/drawingml/2006/main"/>
+      </p:grpSpPr>
+      <p:sp>
+        <p:nvSpPr>
+          <p:cNvPr id="23" name="">
+            <a:extLst xmlns:a="http://schemas.openxmlformats.org/drawingml/2006/main">
+              <a:ext uri="{FF2B5EF4-FFF2-40B4-BE49-F238E27FC236}">
+                <a16:creationId xmlns:a16="http://schemas.microsoft.com/office/drawing/2014/main" id="{C473AF54-3795-4259-9E20-86A346213A60}"/>
+              </a:ext>
+            </a:extLst>
+          </p:cNvPr>
+          <p:cNvSpPr>
+            <a:spLocks xmlns:a="http://schemas.openxmlformats.org/drawingml/2006/main" noGrp="1"/>
+          </p:cNvSpPr>
+          <p:nvPr/>
+        </p:nvSpPr>
+        <p:spPr>
+          <a:xfrm xmlns:a="http://schemas.openxmlformats.org/drawingml/2006/main">
+            <a:off x="685800" y="400050"/>
+            <a:ext cx="8382000" cy="457200"/>
+          </a:xfrm>
+          <a:prstGeom xmlns:a="http://schemas.openxmlformats.org/drawingml/2006/main" prst="rect">
+            <a:avLst/>
+          </a:prstGeom>
+          <a:noFill xmlns:a="http://schemas.openxmlformats.org/drawingml/2006/main"/>
+          <a:ln xmlns:a="http://schemas.openxmlformats.org/drawingml/2006/main" w="0">
+            <a:noFill/>
+            <a:prstDash val="solid"/>
+          </a:ln>
+        </p:spPr>
+        <p:txBody>
+          <a:bodyPr xmlns:a="http://schemas.openxmlformats.org/drawingml/2006/main" lIns="0" tIns="0" rIns="0" bIns="0" anchor="ctr">
+            <a:normAutofit fontScale="100000"/>
+          </a:bodyPr>
+          <a:lstStyle xmlns:a="http://schemas.openxmlformats.org/drawingml/2006/main"/>
+          <a:p xmlns:a="http://schemas.openxmlformats.org/drawingml/2006/main">
+            <a:pPr algn="l">
+              <a:defRPr sz="2700" b="1">
+                <a:solidFill>
+                  <a:srgbClr val="1677C8"/>
+                </a:solidFill>
+                <a:latin typeface="Microsoft YaHei"/>
+                <a:ea typeface="Microsoft YaHei"/>
+                <a:cs typeface="Microsoft YaHei"/>
+              </a:defRPr>
+            </a:pPr>
+            <a:r>
+              <a:rPr sz="2700" b="1">
+                <a:solidFill>
+                  <a:srgbClr val="1677C8"/>
+                </a:solidFill>
+                <a:latin typeface="Microsoft YaHei"/>
+                <a:ea typeface="Microsoft YaHei"/>
+                <a:cs typeface="Microsoft YaHei"/>
+              </a:rPr>
+              <a:t>问题与改进措施</a:t>
+            </a:r>
+          </a:p>
+        </p:txBody>
+      </p:sp>
+      <p:sp>
+        <p:nvSpPr>
+          <p:cNvPr id="2" name="">
+            <a:extLst xmlns:a="http://schemas.openxmlformats.org/drawingml/2006/main">
+              <a:ext uri="{FF2B5EF4-FFF2-40B4-BE49-F238E27FC236}">
+                <a16:creationId xmlns:a16="http://schemas.microsoft.com/office/drawing/2014/main" id="{BE89ED26-4223-4007-B8A0-6014DFA6A3A7}"/>
+              </a:ext>
+            </a:extLst>
+          </p:cNvPr>
+          <p:cNvSpPr>
+            <a:spLocks xmlns:a="http://schemas.openxmlformats.org/drawingml/2006/main" noGrp="1"/>
+          </p:cNvSpPr>
+          <p:nvPr/>
+        </p:nvSpPr>
+        <p:spPr>
+          <a:xfrm xmlns:a="http://schemas.openxmlformats.org/drawingml/2006/main">
+            <a:off x="704850" y="876300"/>
+            <a:ext cx="4953000" cy="247650"/>
+          </a:xfrm>
+          <a:prstGeom xmlns:a="http://schemas.openxmlformats.org/drawingml/2006/main" prst="rect">
+            <a:avLst/>
+          </a:prstGeom>
+          <a:noFill xmlns:a="http://schemas.openxmlformats.org/drawingml/2006/main"/>
+          <a:ln xmlns:a="http://schemas.openxmlformats.org/drawingml/2006/main" w="0">
+            <a:noFill/>
+            <a:prstDash val="solid"/>
+          </a:ln>
+        </p:spPr>
+        <p:txBody>
+          <a:bodyPr xmlns:a="http://schemas.openxmlformats.org/drawingml/2006/main" lIns="0" tIns="0" rIns="0" bIns="0" anchor="ctr">
+            <a:normAutofit fontScale="100000"/>
+          </a:bodyPr>
+          <a:lstStyle xmlns:a="http://schemas.openxmlformats.org/drawingml/2006/main"/>
+          <a:p xmlns:a="http://schemas.openxmlformats.org/drawingml/2006/main">
+            <a:pPr algn="l">
+              <a:defRPr sz="1200" b="0">
+                <a:solidFill>
+                  <a:srgbClr val="7C8A9A"/>
+                </a:solidFill>
+                <a:latin typeface="Microsoft YaHei"/>
+                <a:ea typeface="Microsoft YaHei"/>
+                <a:cs typeface="Microsoft YaHei"/>
+              </a:defRPr>
+            </a:pPr>
+            <a:r>
+              <a:rPr sz="1200" b="0">
+                <a:solidFill>
+                  <a:srgbClr val="7C8A9A"/>
+                </a:solidFill>
+                <a:latin typeface="Microsoft YaHei"/>
+                <a:ea typeface="Microsoft YaHei"/>
+                <a:cs typeface="Microsoft YaHei"/>
+              </a:rPr>
+              <a:t>问题—改进</a:t>
+            </a:r>
+          </a:p>
+        </p:txBody>
+      </p:sp>
+      <p:sp>
+        <p:nvSpPr>
+          <p:cNvPr id="3" name="">
+            <a:extLst xmlns:a="http://schemas.openxmlformats.org/drawingml/2006/main">
+              <a:ext uri="{FF2B5EF4-FFF2-40B4-BE49-F238E27FC236}">
+                <a16:creationId xmlns:a16="http://schemas.microsoft.com/office/drawing/2014/main" id="{D7AF1337-C1DD-4E2F-A08F-AAF6B5689FCD}"/>
+              </a:ext>
+            </a:extLst>
+          </p:cNvPr>
+          <p:cNvSpPr>
+            <a:spLocks xmlns:a="http://schemas.openxmlformats.org/drawingml/2006/main" noGrp="1"/>
+          </p:cNvSpPr>
+          <p:nvPr/>
+        </p:nvSpPr>
+        <p:spPr>
+          <a:xfrm xmlns:a="http://schemas.openxmlformats.org/drawingml/2006/main">
+            <a:off x="685800" y="1428750"/>
+            <a:ext cx="4476750" cy="4572000"/>
+          </a:xfrm>
+          <a:prstGeom xmlns:a="http://schemas.openxmlformats.org/drawingml/2006/main" prst="roundRect">
+            <a:avLst>
+              <a:gd name="adj" fmla="val 2553"/>
+            </a:avLst>
+          </a:prstGeom>
+          <a:solidFill xmlns:a="http://schemas.openxmlformats.org/drawingml/2006/main">
+            <a:srgbClr val="FFFFFF"/>
+          </a:solidFill>
+          <a:ln xmlns:a="http://schemas.openxmlformats.org/drawingml/2006/main" w="19050">
+            <a:solidFill>
+              <a:srgbClr val="1677C8"/>
             </a:solidFill>
             <a:prstDash val="solid"/>
           </a:ln>
@@ -1862,22 +2396,63 @@
       </p:sp>
       <p:sp>
         <p:nvSpPr>
-          <p:cNvPr id="17" name="PPAGENT_QA|within=improvement-item-1|role=title">
-            <a:extLst xmlns:a="http://schemas.openxmlformats.org/drawingml/2006/main">
-              <a:ext uri="{FF2B5EF4-FFF2-40B4-BE49-F238E27FC236}">
-                <a16:creationId xmlns:a16="http://schemas.microsoft.com/office/drawing/2014/main" id="{EF1C4BCE-3E5F-482A-A8F2-1AAC61E9FD31}"/>
-              </a:ext>
-            </a:extLst>
-          </p:cNvPr>
-          <p:cNvSpPr>
-            <a:spLocks xmlns:a="http://schemas.openxmlformats.org/drawingml/2006/main" noGrp="1"/>
-          </p:cNvSpPr>
-          <p:nvPr/>
-        </p:nvSpPr>
-        <p:spPr>
-          <a:xfrm xmlns:a="http://schemas.openxmlformats.org/drawingml/2006/main">
-            <a:off x="7562850" y="4114800"/>
-            <a:ext cx="3409950" cy="247650"/>
+          <p:cNvPr id="4" name="">
+            <a:extLst xmlns:a="http://schemas.openxmlformats.org/drawingml/2006/main">
+              <a:ext uri="{FF2B5EF4-FFF2-40B4-BE49-F238E27FC236}">
+                <a16:creationId xmlns:a16="http://schemas.microsoft.com/office/drawing/2014/main" id="{4BB98543-3784-43B2-9CAD-A88EA3FE0A35}"/>
+              </a:ext>
+            </a:extLst>
+          </p:cNvPr>
+          <p:cNvSpPr>
+            <a:spLocks xmlns:a="http://schemas.openxmlformats.org/drawingml/2006/main" noGrp="1"/>
+          </p:cNvSpPr>
+          <p:nvPr/>
+        </p:nvSpPr>
+        <p:spPr>
+          <a:xfrm xmlns:a="http://schemas.openxmlformats.org/drawingml/2006/main">
+            <a:off x="7029450" y="1428750"/>
+            <a:ext cx="4476750" cy="4572000"/>
+          </a:xfrm>
+          <a:prstGeom xmlns:a="http://schemas.openxmlformats.org/drawingml/2006/main" prst="roundRect">
+            <a:avLst>
+              <a:gd name="adj" fmla="val 2553"/>
+            </a:avLst>
+          </a:prstGeom>
+          <a:solidFill xmlns:a="http://schemas.openxmlformats.org/drawingml/2006/main">
+            <a:srgbClr val="FFFFFF"/>
+          </a:solidFill>
+          <a:ln xmlns:a="http://schemas.openxmlformats.org/drawingml/2006/main" w="19050">
+            <a:solidFill>
+              <a:srgbClr val="00A8D8"/>
+            </a:solidFill>
+            <a:prstDash val="solid"/>
+          </a:ln>
+        </p:spPr>
+        <p:style>
+          <a:lnRef xmlns:a="http://schemas.openxmlformats.org/drawingml/2006/main" idx="0"/>
+          <a:fillRef xmlns:a="http://schemas.openxmlformats.org/drawingml/2006/main" idx="0"/>
+          <a:effectRef xmlns:a="http://schemas.openxmlformats.org/drawingml/2006/main" idx="4"/>
+          <a:fontRef xmlns:a="http://schemas.openxmlformats.org/drawingml/2006/main" idx="major"/>
+        </p:style>
+      </p:sp>
+      <p:sp>
+        <p:nvSpPr>
+          <p:cNvPr id="5" name="">
+            <a:extLst xmlns:a="http://schemas.openxmlformats.org/drawingml/2006/main">
+              <a:ext uri="{FF2B5EF4-FFF2-40B4-BE49-F238E27FC236}">
+                <a16:creationId xmlns:a16="http://schemas.microsoft.com/office/drawing/2014/main" id="{BE1EF357-E870-4032-9741-CCEB104E9363}"/>
+              </a:ext>
+            </a:extLst>
+          </p:cNvPr>
+          <p:cNvSpPr>
+            <a:spLocks xmlns:a="http://schemas.openxmlformats.org/drawingml/2006/main" noGrp="1"/>
+          </p:cNvSpPr>
+          <p:nvPr/>
+        </p:nvSpPr>
+        <p:spPr>
+          <a:xfrm xmlns:a="http://schemas.openxmlformats.org/drawingml/2006/main">
+            <a:off x="971550" y="1695450"/>
+            <a:ext cx="3905250" cy="419100"/>
           </a:xfrm>
           <a:prstGeom xmlns:a="http://schemas.openxmlformats.org/drawingml/2006/main" prst="rect">
             <a:avLst/>
@@ -1894,10 +2469,161 @@
           </a:bodyPr>
           <a:lstStyle xmlns:a="http://schemas.openxmlformats.org/drawingml/2006/main"/>
           <a:p xmlns:a="http://schemas.openxmlformats.org/drawingml/2006/main">
+            <a:pPr algn="ctr">
+              <a:defRPr sz="1950" b="1">
+                <a:solidFill>
+                  <a:srgbClr val="1677C8"/>
+                </a:solidFill>
+                <a:latin typeface="Microsoft YaHei"/>
+                <a:ea typeface="Microsoft YaHei"/>
+                <a:cs typeface="Microsoft YaHei"/>
+              </a:defRPr>
+            </a:pPr>
+            <a:r>
+              <a:rPr sz="1950" b="1">
+                <a:solidFill>
+                  <a:srgbClr val="1677C8"/>
+                </a:solidFill>
+                <a:latin typeface="Microsoft YaHei"/>
+                <a:ea typeface="Microsoft YaHei"/>
+                <a:cs typeface="Microsoft YaHei"/>
+              </a:rPr>
+              <a:t>现状与缺口</a:t>
+            </a:r>
+          </a:p>
+        </p:txBody>
+      </p:sp>
+      <p:sp>
+        <p:nvSpPr>
+          <p:cNvPr id="6" name="">
+            <a:extLst xmlns:a="http://schemas.openxmlformats.org/drawingml/2006/main">
+              <a:ext uri="{FF2B5EF4-FFF2-40B4-BE49-F238E27FC236}">
+                <a16:creationId xmlns:a16="http://schemas.microsoft.com/office/drawing/2014/main" id="{1D3DBA68-4AEC-4114-811D-F887AA553D8A}"/>
+              </a:ext>
+            </a:extLst>
+          </p:cNvPr>
+          <p:cNvSpPr>
+            <a:spLocks xmlns:a="http://schemas.openxmlformats.org/drawingml/2006/main" noGrp="1"/>
+          </p:cNvSpPr>
+          <p:nvPr/>
+        </p:nvSpPr>
+        <p:spPr>
+          <a:xfrm xmlns:a="http://schemas.openxmlformats.org/drawingml/2006/main">
+            <a:off x="7315200" y="1695450"/>
+            <a:ext cx="3905250" cy="419100"/>
+          </a:xfrm>
+          <a:prstGeom xmlns:a="http://schemas.openxmlformats.org/drawingml/2006/main" prst="rect">
+            <a:avLst/>
+          </a:prstGeom>
+          <a:noFill xmlns:a="http://schemas.openxmlformats.org/drawingml/2006/main"/>
+          <a:ln xmlns:a="http://schemas.openxmlformats.org/drawingml/2006/main" w="0">
+            <a:noFill/>
+            <a:prstDash val="solid"/>
+          </a:ln>
+        </p:spPr>
+        <p:txBody>
+          <a:bodyPr xmlns:a="http://schemas.openxmlformats.org/drawingml/2006/main" lIns="0" tIns="0" rIns="0" bIns="0" anchor="ctr">
+            <a:normAutofit fontScale="100000"/>
+          </a:bodyPr>
+          <a:lstStyle xmlns:a="http://schemas.openxmlformats.org/drawingml/2006/main"/>
+          <a:p xmlns:a="http://schemas.openxmlformats.org/drawingml/2006/main">
+            <a:pPr algn="ctr">
+              <a:defRPr sz="1950" b="1">
+                <a:solidFill>
+                  <a:srgbClr val="00A8D8"/>
+                </a:solidFill>
+                <a:latin typeface="Microsoft YaHei"/>
+                <a:ea typeface="Microsoft YaHei"/>
+                <a:cs typeface="Microsoft YaHei"/>
+              </a:defRPr>
+            </a:pPr>
+            <a:r>
+              <a:rPr sz="1950" b="1">
+                <a:solidFill>
+                  <a:srgbClr val="00A8D8"/>
+                </a:solidFill>
+                <a:latin typeface="Microsoft YaHei"/>
+                <a:ea typeface="Microsoft YaHei"/>
+                <a:cs typeface="Microsoft YaHei"/>
+              </a:rPr>
+              <a:t>系统介入与结果</a:t>
+            </a:r>
+          </a:p>
+        </p:txBody>
+      </p:sp>
+      <p:sp>
+        <p:nvSpPr>
+          <p:cNvPr id="7" name="PPAGENT_QA|parent=problem-item-0|domains=problem-items">
+            <a:extLst xmlns:a="http://schemas.openxmlformats.org/drawingml/2006/main">
+              <a:ext uri="{FF2B5EF4-FFF2-40B4-BE49-F238E27FC236}">
+                <a16:creationId xmlns:a16="http://schemas.microsoft.com/office/drawing/2014/main" id="{B33238A9-41CC-400E-9944-0916584EF5F9}"/>
+              </a:ext>
+            </a:extLst>
+          </p:cNvPr>
+          <p:cNvSpPr>
+            <a:spLocks xmlns:a="http://schemas.openxmlformats.org/drawingml/2006/main" noGrp="1"/>
+          </p:cNvSpPr>
+          <p:nvPr/>
+        </p:nvSpPr>
+        <p:spPr>
+          <a:xfrm xmlns:a="http://schemas.openxmlformats.org/drawingml/2006/main">
+            <a:off x="1066800" y="2647950"/>
+            <a:ext cx="3714750" cy="990600"/>
+          </a:xfrm>
+          <a:prstGeom xmlns:a="http://schemas.openxmlformats.org/drawingml/2006/main" prst="roundRect">
+            <a:avLst>
+              <a:gd name="adj" fmla="val 11538"/>
+            </a:avLst>
+          </a:prstGeom>
+          <a:solidFill xmlns:a="http://schemas.openxmlformats.org/drawingml/2006/main">
+            <a:srgbClr val="F1F7FB"/>
+          </a:solidFill>
+          <a:ln xmlns:a="http://schemas.openxmlformats.org/drawingml/2006/main" w="9525">
+            <a:solidFill>
+              <a:srgbClr val="C9D5E3"/>
+            </a:solidFill>
+            <a:prstDash val="solid"/>
+          </a:ln>
+        </p:spPr>
+      </p:sp>
+      <p:sp>
+        <p:nvSpPr>
+          <p:cNvPr id="8" name="PPAGENT_QA|within=problem-item-0|role=title">
+            <a:extLst xmlns:a="http://schemas.openxmlformats.org/drawingml/2006/main">
+              <a:ext uri="{FF2B5EF4-FFF2-40B4-BE49-F238E27FC236}">
+                <a16:creationId xmlns:a16="http://schemas.microsoft.com/office/drawing/2014/main" id="{913A4FFA-82C6-4BAF-AD7B-891C9313A6E9}"/>
+              </a:ext>
+            </a:extLst>
+          </p:cNvPr>
+          <p:cNvSpPr>
+            <a:spLocks xmlns:a="http://schemas.openxmlformats.org/drawingml/2006/main" noGrp="1"/>
+          </p:cNvSpPr>
+          <p:nvPr/>
+        </p:nvSpPr>
+        <p:spPr>
+          <a:xfrm xmlns:a="http://schemas.openxmlformats.org/drawingml/2006/main">
+            <a:off x="1219200" y="2762250"/>
+            <a:ext cx="3409950" cy="247650"/>
+          </a:xfrm>
+          <a:prstGeom xmlns:a="http://schemas.openxmlformats.org/drawingml/2006/main" prst="rect">
+            <a:avLst/>
+          </a:prstGeom>
+          <a:noFill xmlns:a="http://schemas.openxmlformats.org/drawingml/2006/main"/>
+          <a:ln xmlns:a="http://schemas.openxmlformats.org/drawingml/2006/main" w="0">
+            <a:noFill/>
+            <a:prstDash val="solid"/>
+          </a:ln>
+        </p:spPr>
+        <p:txBody>
+          <a:bodyPr xmlns:a="http://schemas.openxmlformats.org/drawingml/2006/main" lIns="0" tIns="0" rIns="0" bIns="0" anchor="ctr">
+            <a:normAutofit fontScale="100000"/>
+          </a:bodyPr>
+          <a:lstStyle xmlns:a="http://schemas.openxmlformats.org/drawingml/2006/main"/>
+          <a:p xmlns:a="http://schemas.openxmlformats.org/drawingml/2006/main">
             <a:pPr algn="l">
               <a:defRPr sz="1425" b="1">
                 <a:solidFill>
-                  <a:srgbClr val="FFFFFF"/>
+                  <a:srgbClr val="475569"/>
                 </a:solidFill>
                 <a:latin typeface="Microsoft YaHei"/>
                 <a:ea typeface="Microsoft YaHei"/>
@@ -1907,34 +2633,34 @@
             <a:r>
               <a:rPr sz="1425" b="1">
                 <a:solidFill>
-                  <a:srgbClr val="FFFFFF"/>
+                  <a:srgbClr val="475569"/>
                 </a:solidFill>
                 <a:latin typeface="Microsoft YaHei"/>
                 <a:ea typeface="Microsoft YaHei"/>
                 <a:cs typeface="Microsoft YaHei"/>
               </a:rPr>
-              <a:t>形成生产能力</a:t>
+              <a:t>结果不稳定</a:t>
             </a:r>
           </a:p>
         </p:txBody>
       </p:sp>
       <p:sp>
         <p:nvSpPr>
-          <p:cNvPr id="18" name="PPAGENT_QA|within=improvement-item-1|role=body">
-            <a:extLst xmlns:a="http://schemas.openxmlformats.org/drawingml/2006/main">
-              <a:ext uri="{FF2B5EF4-FFF2-40B4-BE49-F238E27FC236}">
-                <a16:creationId xmlns:a16="http://schemas.microsoft.com/office/drawing/2014/main" id="{4EC5A8AF-11B5-47B6-AF92-57180CD0083B}"/>
-              </a:ext>
-            </a:extLst>
-          </p:cNvPr>
-          <p:cNvSpPr>
-            <a:spLocks xmlns:a="http://schemas.openxmlformats.org/drawingml/2006/main" noGrp="1"/>
-          </p:cNvSpPr>
-          <p:nvPr/>
-        </p:nvSpPr>
-        <p:spPr>
-          <a:xfrm xmlns:a="http://schemas.openxmlformats.org/drawingml/2006/main">
-            <a:off x="7562850" y="4400550"/>
+          <p:cNvPr id="9" name="PPAGENT_QA|within=problem-item-0|role=body">
+            <a:extLst xmlns:a="http://schemas.openxmlformats.org/drawingml/2006/main">
+              <a:ext uri="{FF2B5EF4-FFF2-40B4-BE49-F238E27FC236}">
+                <a16:creationId xmlns:a16="http://schemas.microsoft.com/office/drawing/2014/main" id="{9787ECBB-929A-4021-AF87-E0F21CE45564}"/>
+              </a:ext>
+            </a:extLst>
+          </p:cNvPr>
+          <p:cNvSpPr>
+            <a:spLocks xmlns:a="http://schemas.openxmlformats.org/drawingml/2006/main" noGrp="1"/>
+          </p:cNvSpPr>
+          <p:nvPr/>
+        </p:nvSpPr>
+        <p:spPr>
+          <a:xfrm xmlns:a="http://schemas.openxmlformats.org/drawingml/2006/main">
+            <a:off x="1219200" y="3048000"/>
             <a:ext cx="3409950" cy="514350"/>
           </a:xfrm>
           <a:prstGeom xmlns:a="http://schemas.openxmlformats.org/drawingml/2006/main" prst="rect">
@@ -1955,7 +2681,7 @@
             <a:pPr algn="l">
               <a:defRPr sz="1350" b="0">
                 <a:solidFill>
-                  <a:srgbClr val="FFFFFF"/>
+                  <a:srgbClr val="475569"/>
                 </a:solidFill>
                 <a:latin typeface="Microsoft YaHei"/>
                 <a:ea typeface="Microsoft YaHei"/>
@@ -1965,23 +2691,627 @@
             <a:r>
               <a:rPr sz="1350" b="0">
                 <a:solidFill>
-                  <a:srgbClr val="FFFFFF"/>
+                  <a:srgbClr val="475569"/>
                 </a:solidFill>
                 <a:latin typeface="Microsoft YaHei"/>
                 <a:ea typeface="Microsoft YaHei"/>
                 <a:cs typeface="Microsoft YaHei"/>
               </a:rPr>
-              <a:t>让少数人的经验被更多人使用。</a:t>
+              <a:t>相同输入仍可能得到差异较大的页面</a:t>
             </a:r>
           </a:p>
         </p:txBody>
       </p:sp>
       <p:sp>
         <p:nvSpPr>
-          <p:cNvPr id="19" name="">
-            <a:extLst xmlns:a="http://schemas.openxmlformats.org/drawingml/2006/main">
-              <a:ext uri="{FF2B5EF4-FFF2-40B4-BE49-F238E27FC236}">
-                <a16:creationId xmlns:a16="http://schemas.microsoft.com/office/drawing/2014/main" id="{2CD075DD-6CAA-49BF-BEB2-0A32687F53B0}"/>
+          <p:cNvPr id="10" name="PPAGENT_QA|parent=problem-item-1|domains=problem-items">
+            <a:extLst xmlns:a="http://schemas.openxmlformats.org/drawingml/2006/main">
+              <a:ext uri="{FF2B5EF4-FFF2-40B4-BE49-F238E27FC236}">
+                <a16:creationId xmlns:a16="http://schemas.microsoft.com/office/drawing/2014/main" id="{2D30BE9E-90A1-48B4-BED1-319906BF608E}"/>
+              </a:ext>
+            </a:extLst>
+          </p:cNvPr>
+          <p:cNvSpPr>
+            <a:spLocks xmlns:a="http://schemas.openxmlformats.org/drawingml/2006/main" noGrp="1"/>
+          </p:cNvSpPr>
+          <p:nvPr/>
+        </p:nvSpPr>
+        <p:spPr>
+          <a:xfrm xmlns:a="http://schemas.openxmlformats.org/drawingml/2006/main">
+            <a:off x="1066800" y="4000500"/>
+            <a:ext cx="3714750" cy="990600"/>
+          </a:xfrm>
+          <a:prstGeom xmlns:a="http://schemas.openxmlformats.org/drawingml/2006/main" prst="roundRect">
+            <a:avLst>
+              <a:gd name="adj" fmla="val 11538"/>
+            </a:avLst>
+          </a:prstGeom>
+          <a:solidFill xmlns:a="http://schemas.openxmlformats.org/drawingml/2006/main">
+            <a:srgbClr val="F1F7FB"/>
+          </a:solidFill>
+          <a:ln xmlns:a="http://schemas.openxmlformats.org/drawingml/2006/main" w="9525">
+            <a:solidFill>
+              <a:srgbClr val="C9D5E3"/>
+            </a:solidFill>
+            <a:prstDash val="solid"/>
+          </a:ln>
+        </p:spPr>
+      </p:sp>
+      <p:sp>
+        <p:nvSpPr>
+          <p:cNvPr id="11" name="PPAGENT_QA|within=problem-item-1|role=title">
+            <a:extLst xmlns:a="http://schemas.openxmlformats.org/drawingml/2006/main">
+              <a:ext uri="{FF2B5EF4-FFF2-40B4-BE49-F238E27FC236}">
+                <a16:creationId xmlns:a16="http://schemas.microsoft.com/office/drawing/2014/main" id="{633D90A6-D9EA-46C7-B4DD-88FD41C19B04}"/>
+              </a:ext>
+            </a:extLst>
+          </p:cNvPr>
+          <p:cNvSpPr>
+            <a:spLocks xmlns:a="http://schemas.openxmlformats.org/drawingml/2006/main" noGrp="1"/>
+          </p:cNvSpPr>
+          <p:nvPr/>
+        </p:nvSpPr>
+        <p:spPr>
+          <a:xfrm xmlns:a="http://schemas.openxmlformats.org/drawingml/2006/main">
+            <a:off x="1219200" y="4114800"/>
+            <a:ext cx="3409950" cy="247650"/>
+          </a:xfrm>
+          <a:prstGeom xmlns:a="http://schemas.openxmlformats.org/drawingml/2006/main" prst="rect">
+            <a:avLst/>
+          </a:prstGeom>
+          <a:noFill xmlns:a="http://schemas.openxmlformats.org/drawingml/2006/main"/>
+          <a:ln xmlns:a="http://schemas.openxmlformats.org/drawingml/2006/main" w="0">
+            <a:noFill/>
+            <a:prstDash val="solid"/>
+          </a:ln>
+        </p:spPr>
+        <p:txBody>
+          <a:bodyPr xmlns:a="http://schemas.openxmlformats.org/drawingml/2006/main" lIns="0" tIns="0" rIns="0" bIns="0" anchor="ctr">
+            <a:normAutofit fontScale="100000"/>
+          </a:bodyPr>
+          <a:lstStyle xmlns:a="http://schemas.openxmlformats.org/drawingml/2006/main"/>
+          <a:p xmlns:a="http://schemas.openxmlformats.org/drawingml/2006/main">
+            <a:pPr algn="l">
+              <a:defRPr sz="1425" b="1">
+                <a:solidFill>
+                  <a:srgbClr val="475569"/>
+                </a:solidFill>
+                <a:latin typeface="Microsoft YaHei"/>
+                <a:ea typeface="Microsoft YaHei"/>
+                <a:cs typeface="Microsoft YaHei"/>
+              </a:defRPr>
+            </a:pPr>
+            <a:r>
+              <a:rPr sz="1425" b="1">
+                <a:solidFill>
+                  <a:srgbClr val="475569"/>
+                </a:solidFill>
+                <a:latin typeface="Microsoft YaHei"/>
+                <a:ea typeface="Microsoft YaHei"/>
+                <a:cs typeface="Microsoft YaHei"/>
+              </a:rPr>
+              <a:t>经验难沉淀</a:t>
+            </a:r>
+          </a:p>
+        </p:txBody>
+      </p:sp>
+      <p:sp>
+        <p:nvSpPr>
+          <p:cNvPr id="12" name="PPAGENT_QA|within=problem-item-1|role=body">
+            <a:extLst xmlns:a="http://schemas.openxmlformats.org/drawingml/2006/main">
+              <a:ext uri="{FF2B5EF4-FFF2-40B4-BE49-F238E27FC236}">
+                <a16:creationId xmlns:a16="http://schemas.microsoft.com/office/drawing/2014/main" id="{08B1F5EF-E809-44AD-B832-F1B8FC46EF06}"/>
+              </a:ext>
+            </a:extLst>
+          </p:cNvPr>
+          <p:cNvSpPr>
+            <a:spLocks xmlns:a="http://schemas.openxmlformats.org/drawingml/2006/main" noGrp="1"/>
+          </p:cNvSpPr>
+          <p:nvPr/>
+        </p:nvSpPr>
+        <p:spPr>
+          <a:xfrm xmlns:a="http://schemas.openxmlformats.org/drawingml/2006/main">
+            <a:off x="1219200" y="4400550"/>
+            <a:ext cx="3409950" cy="514350"/>
+          </a:xfrm>
+          <a:prstGeom xmlns:a="http://schemas.openxmlformats.org/drawingml/2006/main" prst="rect">
+            <a:avLst/>
+          </a:prstGeom>
+          <a:noFill xmlns:a="http://schemas.openxmlformats.org/drawingml/2006/main"/>
+          <a:ln xmlns:a="http://schemas.openxmlformats.org/drawingml/2006/main" w="0">
+            <a:noFill/>
+            <a:prstDash val="solid"/>
+          </a:ln>
+        </p:spPr>
+        <p:txBody>
+          <a:bodyPr xmlns:a="http://schemas.openxmlformats.org/drawingml/2006/main" lIns="0" tIns="0" rIns="0" bIns="0" anchor="t">
+            <a:normAutofit fontScale="100000"/>
+          </a:bodyPr>
+          <a:lstStyle xmlns:a="http://schemas.openxmlformats.org/drawingml/2006/main"/>
+          <a:p xmlns:a="http://schemas.openxmlformats.org/drawingml/2006/main">
+            <a:pPr algn="l">
+              <a:defRPr sz="1350" b="0">
+                <a:solidFill>
+                  <a:srgbClr val="475569"/>
+                </a:solidFill>
+                <a:latin typeface="Microsoft YaHei"/>
+                <a:ea typeface="Microsoft YaHei"/>
+                <a:cs typeface="Microsoft YaHei"/>
+              </a:defRPr>
+            </a:pPr>
+            <a:r>
+              <a:rPr sz="1350" b="0">
+                <a:solidFill>
+                  <a:srgbClr val="475569"/>
+                </a:solidFill>
+                <a:latin typeface="Microsoft YaHei"/>
+                <a:ea typeface="Microsoft YaHei"/>
+                <a:cs typeface="Microsoft YaHei"/>
+              </a:rPr>
+              <a:t>每次任务都需要重新判断和修正</a:t>
+            </a:r>
+          </a:p>
+        </p:txBody>
+      </p:sp>
+      <p:sp>
+        <p:nvSpPr>
+          <p:cNvPr id="13" name="PPAGENT_QA|parent=improvement-item-0|domains=improvement-items">
+            <a:extLst xmlns:a="http://schemas.openxmlformats.org/drawingml/2006/main">
+              <a:ext uri="{FF2B5EF4-FFF2-40B4-BE49-F238E27FC236}">
+                <a16:creationId xmlns:a16="http://schemas.microsoft.com/office/drawing/2014/main" id="{A1A6DA46-B7C2-4C9C-9B91-6881DE755323}"/>
+              </a:ext>
+            </a:extLst>
+          </p:cNvPr>
+          <p:cNvSpPr>
+            <a:spLocks xmlns:a="http://schemas.openxmlformats.org/drawingml/2006/main" noGrp="1"/>
+          </p:cNvSpPr>
+          <p:nvPr/>
+        </p:nvSpPr>
+        <p:spPr>
+          <a:xfrm xmlns:a="http://schemas.openxmlformats.org/drawingml/2006/main">
+            <a:off x="7410450" y="2343150"/>
+            <a:ext cx="3714750" cy="819150"/>
+          </a:xfrm>
+          <a:prstGeom xmlns:a="http://schemas.openxmlformats.org/drawingml/2006/main" prst="roundRect">
+            <a:avLst>
+              <a:gd name="adj" fmla="val 13953"/>
+            </a:avLst>
+          </a:prstGeom>
+          <a:solidFill xmlns:a="http://schemas.openxmlformats.org/drawingml/2006/main">
+            <a:srgbClr val="ECFBFC"/>
+          </a:solidFill>
+          <a:ln xmlns:a="http://schemas.openxmlformats.org/drawingml/2006/main" w="9525">
+            <a:solidFill>
+              <a:srgbClr val="A8E7EA"/>
+            </a:solidFill>
+            <a:prstDash val="solid"/>
+          </a:ln>
+        </p:spPr>
+      </p:sp>
+      <p:sp>
+        <p:nvSpPr>
+          <p:cNvPr id="14" name="PPAGENT_QA|within=improvement-item-0|role=title">
+            <a:extLst xmlns:a="http://schemas.openxmlformats.org/drawingml/2006/main">
+              <a:ext uri="{FF2B5EF4-FFF2-40B4-BE49-F238E27FC236}">
+                <a16:creationId xmlns:a16="http://schemas.microsoft.com/office/drawing/2014/main" id="{9418CDCB-588B-4F40-A311-45EFDC157646}"/>
+              </a:ext>
+            </a:extLst>
+          </p:cNvPr>
+          <p:cNvSpPr>
+            <a:spLocks xmlns:a="http://schemas.openxmlformats.org/drawingml/2006/main" noGrp="1"/>
+          </p:cNvSpPr>
+          <p:nvPr/>
+        </p:nvSpPr>
+        <p:spPr>
+          <a:xfrm xmlns:a="http://schemas.openxmlformats.org/drawingml/2006/main">
+            <a:off x="7562850" y="2457450"/>
+            <a:ext cx="3409950" cy="247650"/>
+          </a:xfrm>
+          <a:prstGeom xmlns:a="http://schemas.openxmlformats.org/drawingml/2006/main" prst="rect">
+            <a:avLst/>
+          </a:prstGeom>
+          <a:noFill xmlns:a="http://schemas.openxmlformats.org/drawingml/2006/main"/>
+          <a:ln xmlns:a="http://schemas.openxmlformats.org/drawingml/2006/main" w="0">
+            <a:noFill/>
+            <a:prstDash val="solid"/>
+          </a:ln>
+        </p:spPr>
+        <p:txBody>
+          <a:bodyPr xmlns:a="http://schemas.openxmlformats.org/drawingml/2006/main" lIns="0" tIns="0" rIns="0" bIns="0" anchor="ctr">
+            <a:normAutofit fontScale="100000"/>
+          </a:bodyPr>
+          <a:lstStyle xmlns:a="http://schemas.openxmlformats.org/drawingml/2006/main"/>
+          <a:p xmlns:a="http://schemas.openxmlformats.org/drawingml/2006/main">
+            <a:pPr algn="l">
+              <a:defRPr sz="1425" b="1">
+                <a:solidFill>
+                  <a:srgbClr val="475569"/>
+                </a:solidFill>
+                <a:latin typeface="Microsoft YaHei"/>
+                <a:ea typeface="Microsoft YaHei"/>
+                <a:cs typeface="Microsoft YaHei"/>
+              </a:defRPr>
+            </a:pPr>
+            <a:r>
+              <a:rPr sz="1425" b="1">
+                <a:solidFill>
+                  <a:srgbClr val="475569"/>
+                </a:solidFill>
+                <a:latin typeface="Microsoft YaHei"/>
+                <a:ea typeface="Microsoft YaHei"/>
+                <a:cs typeface="Microsoft YaHei"/>
+              </a:rPr>
+              <a:t>固定能力边界</a:t>
+            </a:r>
+          </a:p>
+        </p:txBody>
+      </p:sp>
+      <p:sp>
+        <p:nvSpPr>
+          <p:cNvPr id="15" name="PPAGENT_QA|within=improvement-item-0|role=body">
+            <a:extLst xmlns:a="http://schemas.openxmlformats.org/drawingml/2006/main">
+              <a:ext uri="{FF2B5EF4-FFF2-40B4-BE49-F238E27FC236}">
+                <a16:creationId xmlns:a16="http://schemas.microsoft.com/office/drawing/2014/main" id="{093AB093-D2A8-4314-BED2-84D67505C60E}"/>
+              </a:ext>
+            </a:extLst>
+          </p:cNvPr>
+          <p:cNvSpPr>
+            <a:spLocks xmlns:a="http://schemas.openxmlformats.org/drawingml/2006/main" noGrp="1"/>
+          </p:cNvSpPr>
+          <p:nvPr/>
+        </p:nvSpPr>
+        <p:spPr>
+          <a:xfrm xmlns:a="http://schemas.openxmlformats.org/drawingml/2006/main">
+            <a:off x="7562850" y="2743200"/>
+            <a:ext cx="3409950" cy="342900"/>
+          </a:xfrm>
+          <a:prstGeom xmlns:a="http://schemas.openxmlformats.org/drawingml/2006/main" prst="rect">
+            <a:avLst/>
+          </a:prstGeom>
+          <a:noFill xmlns:a="http://schemas.openxmlformats.org/drawingml/2006/main"/>
+          <a:ln xmlns:a="http://schemas.openxmlformats.org/drawingml/2006/main" w="0">
+            <a:noFill/>
+            <a:prstDash val="solid"/>
+          </a:ln>
+        </p:spPr>
+        <p:txBody>
+          <a:bodyPr xmlns:a="http://schemas.openxmlformats.org/drawingml/2006/main" lIns="0" tIns="0" rIns="0" bIns="0" anchor="t">
+            <a:normAutofit fontScale="100000"/>
+          </a:bodyPr>
+          <a:lstStyle xmlns:a="http://schemas.openxmlformats.org/drawingml/2006/main"/>
+          <a:p xmlns:a="http://schemas.openxmlformats.org/drawingml/2006/main">
+            <a:pPr algn="l">
+              <a:defRPr sz="1350" b="0">
+                <a:solidFill>
+                  <a:srgbClr val="475569"/>
+                </a:solidFill>
+                <a:latin typeface="Microsoft YaHei"/>
+                <a:ea typeface="Microsoft YaHei"/>
+                <a:cs typeface="Microsoft YaHei"/>
+              </a:defRPr>
+            </a:pPr>
+            <a:r>
+              <a:rPr sz="1350" b="0">
+                <a:solidFill>
+                  <a:srgbClr val="475569"/>
+                </a:solidFill>
+                <a:latin typeface="Microsoft YaHei"/>
+                <a:ea typeface="Microsoft YaHei"/>
+                <a:cs typeface="Microsoft YaHei"/>
+              </a:rPr>
+              <a:t>用已登记 Style Group 承担结构表达</a:t>
+            </a:r>
+          </a:p>
+        </p:txBody>
+      </p:sp>
+      <p:sp>
+        <p:nvSpPr>
+          <p:cNvPr id="16" name="PPAGENT_QA|parent=improvement-item-1|domains=improvement-items">
+            <a:extLst xmlns:a="http://schemas.openxmlformats.org/drawingml/2006/main">
+              <a:ext uri="{FF2B5EF4-FFF2-40B4-BE49-F238E27FC236}">
+                <a16:creationId xmlns:a16="http://schemas.microsoft.com/office/drawing/2014/main" id="{EA6F57A7-2A09-430D-929B-6F8E0873AAF1}"/>
+              </a:ext>
+            </a:extLst>
+          </p:cNvPr>
+          <p:cNvSpPr>
+            <a:spLocks xmlns:a="http://schemas.openxmlformats.org/drawingml/2006/main" noGrp="1"/>
+          </p:cNvSpPr>
+          <p:nvPr/>
+        </p:nvSpPr>
+        <p:spPr>
+          <a:xfrm xmlns:a="http://schemas.openxmlformats.org/drawingml/2006/main">
+            <a:off x="7410450" y="3409950"/>
+            <a:ext cx="3714750" cy="819150"/>
+          </a:xfrm>
+          <a:prstGeom xmlns:a="http://schemas.openxmlformats.org/drawingml/2006/main" prst="roundRect">
+            <a:avLst>
+              <a:gd name="adj" fmla="val 13953"/>
+            </a:avLst>
+          </a:prstGeom>
+          <a:solidFill xmlns:a="http://schemas.openxmlformats.org/drawingml/2006/main">
+            <a:srgbClr val="ECFBFC"/>
+          </a:solidFill>
+          <a:ln xmlns:a="http://schemas.openxmlformats.org/drawingml/2006/main" w="9525">
+            <a:solidFill>
+              <a:srgbClr val="A8E7EA"/>
+            </a:solidFill>
+            <a:prstDash val="solid"/>
+          </a:ln>
+        </p:spPr>
+      </p:sp>
+      <p:sp>
+        <p:nvSpPr>
+          <p:cNvPr id="17" name="PPAGENT_QA|within=improvement-item-1|role=title">
+            <a:extLst xmlns:a="http://schemas.openxmlformats.org/drawingml/2006/main">
+              <a:ext uri="{FF2B5EF4-FFF2-40B4-BE49-F238E27FC236}">
+                <a16:creationId xmlns:a16="http://schemas.microsoft.com/office/drawing/2014/main" id="{849D19D4-503D-4EFC-97AD-FC0EB1EB1E83}"/>
+              </a:ext>
+            </a:extLst>
+          </p:cNvPr>
+          <p:cNvSpPr>
+            <a:spLocks xmlns:a="http://schemas.openxmlformats.org/drawingml/2006/main" noGrp="1"/>
+          </p:cNvSpPr>
+          <p:nvPr/>
+        </p:nvSpPr>
+        <p:spPr>
+          <a:xfrm xmlns:a="http://schemas.openxmlformats.org/drawingml/2006/main">
+            <a:off x="7562850" y="3524250"/>
+            <a:ext cx="3409950" cy="247650"/>
+          </a:xfrm>
+          <a:prstGeom xmlns:a="http://schemas.openxmlformats.org/drawingml/2006/main" prst="rect">
+            <a:avLst/>
+          </a:prstGeom>
+          <a:noFill xmlns:a="http://schemas.openxmlformats.org/drawingml/2006/main"/>
+          <a:ln xmlns:a="http://schemas.openxmlformats.org/drawingml/2006/main" w="0">
+            <a:noFill/>
+            <a:prstDash val="solid"/>
+          </a:ln>
+        </p:spPr>
+        <p:txBody>
+          <a:bodyPr xmlns:a="http://schemas.openxmlformats.org/drawingml/2006/main" lIns="0" tIns="0" rIns="0" bIns="0" anchor="ctr">
+            <a:normAutofit fontScale="100000"/>
+          </a:bodyPr>
+          <a:lstStyle xmlns:a="http://schemas.openxmlformats.org/drawingml/2006/main"/>
+          <a:p xmlns:a="http://schemas.openxmlformats.org/drawingml/2006/main">
+            <a:pPr algn="l">
+              <a:defRPr sz="1425" b="1">
+                <a:solidFill>
+                  <a:srgbClr val="475569"/>
+                </a:solidFill>
+                <a:latin typeface="Microsoft YaHei"/>
+                <a:ea typeface="Microsoft YaHei"/>
+                <a:cs typeface="Microsoft YaHei"/>
+              </a:defRPr>
+            </a:pPr>
+            <a:r>
+              <a:rPr sz="1425" b="1">
+                <a:solidFill>
+                  <a:srgbClr val="475569"/>
+                </a:solidFill>
+                <a:latin typeface="Microsoft YaHei"/>
+                <a:ea typeface="Microsoft YaHei"/>
+                <a:cs typeface="Microsoft YaHei"/>
+              </a:rPr>
+              <a:t>统一参数接口</a:t>
+            </a:r>
+          </a:p>
+        </p:txBody>
+      </p:sp>
+      <p:sp>
+        <p:nvSpPr>
+          <p:cNvPr id="18" name="PPAGENT_QA|within=improvement-item-1|role=body">
+            <a:extLst xmlns:a="http://schemas.openxmlformats.org/drawingml/2006/main">
+              <a:ext uri="{FF2B5EF4-FFF2-40B4-BE49-F238E27FC236}">
+                <a16:creationId xmlns:a16="http://schemas.microsoft.com/office/drawing/2014/main" id="{2E472132-66C8-4FAC-A0FE-835CAAFED037}"/>
+              </a:ext>
+            </a:extLst>
+          </p:cNvPr>
+          <p:cNvSpPr>
+            <a:spLocks xmlns:a="http://schemas.openxmlformats.org/drawingml/2006/main" noGrp="1"/>
+          </p:cNvSpPr>
+          <p:nvPr/>
+        </p:nvSpPr>
+        <p:spPr>
+          <a:xfrm xmlns:a="http://schemas.openxmlformats.org/drawingml/2006/main">
+            <a:off x="7562850" y="3810000"/>
+            <a:ext cx="3409950" cy="342900"/>
+          </a:xfrm>
+          <a:prstGeom xmlns:a="http://schemas.openxmlformats.org/drawingml/2006/main" prst="rect">
+            <a:avLst/>
+          </a:prstGeom>
+          <a:noFill xmlns:a="http://schemas.openxmlformats.org/drawingml/2006/main"/>
+          <a:ln xmlns:a="http://schemas.openxmlformats.org/drawingml/2006/main" w="0">
+            <a:noFill/>
+            <a:prstDash val="solid"/>
+          </a:ln>
+        </p:spPr>
+        <p:txBody>
+          <a:bodyPr xmlns:a="http://schemas.openxmlformats.org/drawingml/2006/main" lIns="0" tIns="0" rIns="0" bIns="0" anchor="t">
+            <a:normAutofit fontScale="100000"/>
+          </a:bodyPr>
+          <a:lstStyle xmlns:a="http://schemas.openxmlformats.org/drawingml/2006/main"/>
+          <a:p xmlns:a="http://schemas.openxmlformats.org/drawingml/2006/main">
+            <a:pPr algn="l">
+              <a:defRPr sz="1350" b="0">
+                <a:solidFill>
+                  <a:srgbClr val="475569"/>
+                </a:solidFill>
+                <a:latin typeface="Microsoft YaHei"/>
+                <a:ea typeface="Microsoft YaHei"/>
+                <a:cs typeface="Microsoft YaHei"/>
+              </a:defRPr>
+            </a:pPr>
+            <a:r>
+              <a:rPr sz="1350" b="0">
+                <a:solidFill>
+                  <a:srgbClr val="475569"/>
+                </a:solidFill>
+                <a:latin typeface="Microsoft YaHei"/>
+                <a:ea typeface="Microsoft YaHei"/>
+                <a:cs typeface="Microsoft YaHei"/>
+              </a:rPr>
+              <a:t>让 HTML 与 Builder 使用同一输入</a:t>
+            </a:r>
+          </a:p>
+        </p:txBody>
+      </p:sp>
+      <p:sp>
+        <p:nvSpPr>
+          <p:cNvPr id="19" name="PPAGENT_QA|parent=improvement-item-2|domains=improvement-items">
+            <a:extLst xmlns:a="http://schemas.openxmlformats.org/drawingml/2006/main">
+              <a:ext uri="{FF2B5EF4-FFF2-40B4-BE49-F238E27FC236}">
+                <a16:creationId xmlns:a16="http://schemas.microsoft.com/office/drawing/2014/main" id="{36D9D834-E8C6-468A-9318-AFDF245F0265}"/>
+              </a:ext>
+            </a:extLst>
+          </p:cNvPr>
+          <p:cNvSpPr>
+            <a:spLocks xmlns:a="http://schemas.openxmlformats.org/drawingml/2006/main" noGrp="1"/>
+          </p:cNvSpPr>
+          <p:nvPr/>
+        </p:nvSpPr>
+        <p:spPr>
+          <a:xfrm xmlns:a="http://schemas.openxmlformats.org/drawingml/2006/main">
+            <a:off x="7410450" y="4476750"/>
+            <a:ext cx="3714750" cy="819150"/>
+          </a:xfrm>
+          <a:prstGeom xmlns:a="http://schemas.openxmlformats.org/drawingml/2006/main" prst="roundRect">
+            <a:avLst>
+              <a:gd name="adj" fmla="val 13953"/>
+            </a:avLst>
+          </a:prstGeom>
+          <a:solidFill xmlns:a="http://schemas.openxmlformats.org/drawingml/2006/main">
+            <a:srgbClr val="ECFBFC"/>
+          </a:solidFill>
+          <a:ln xmlns:a="http://schemas.openxmlformats.org/drawingml/2006/main" w="9525">
+            <a:solidFill>
+              <a:srgbClr val="A8E7EA"/>
+            </a:solidFill>
+            <a:prstDash val="solid"/>
+          </a:ln>
+        </p:spPr>
+      </p:sp>
+      <p:sp>
+        <p:nvSpPr>
+          <p:cNvPr id="20" name="PPAGENT_QA|within=improvement-item-2|role=title">
+            <a:extLst xmlns:a="http://schemas.openxmlformats.org/drawingml/2006/main">
+              <a:ext uri="{FF2B5EF4-FFF2-40B4-BE49-F238E27FC236}">
+                <a16:creationId xmlns:a16="http://schemas.microsoft.com/office/drawing/2014/main" id="{DA49989F-3F53-4CE2-A141-6F6A64ABDC45}"/>
+              </a:ext>
+            </a:extLst>
+          </p:cNvPr>
+          <p:cNvSpPr>
+            <a:spLocks xmlns:a="http://schemas.openxmlformats.org/drawingml/2006/main" noGrp="1"/>
+          </p:cNvSpPr>
+          <p:nvPr/>
+        </p:nvSpPr>
+        <p:spPr>
+          <a:xfrm xmlns:a="http://schemas.openxmlformats.org/drawingml/2006/main">
+            <a:off x="7562850" y="4591050"/>
+            <a:ext cx="3409950" cy="247650"/>
+          </a:xfrm>
+          <a:prstGeom xmlns:a="http://schemas.openxmlformats.org/drawingml/2006/main" prst="rect">
+            <a:avLst/>
+          </a:prstGeom>
+          <a:noFill xmlns:a="http://schemas.openxmlformats.org/drawingml/2006/main"/>
+          <a:ln xmlns:a="http://schemas.openxmlformats.org/drawingml/2006/main" w="0">
+            <a:noFill/>
+            <a:prstDash val="solid"/>
+          </a:ln>
+        </p:spPr>
+        <p:txBody>
+          <a:bodyPr xmlns:a="http://schemas.openxmlformats.org/drawingml/2006/main" lIns="0" tIns="0" rIns="0" bIns="0" anchor="ctr">
+            <a:normAutofit fontScale="100000"/>
+          </a:bodyPr>
+          <a:lstStyle xmlns:a="http://schemas.openxmlformats.org/drawingml/2006/main"/>
+          <a:p xmlns:a="http://schemas.openxmlformats.org/drawingml/2006/main">
+            <a:pPr algn="l">
+              <a:defRPr sz="1425" b="1">
+                <a:solidFill>
+                  <a:srgbClr val="475569"/>
+                </a:solidFill>
+                <a:latin typeface="Microsoft YaHei"/>
+                <a:ea typeface="Microsoft YaHei"/>
+                <a:cs typeface="Microsoft YaHei"/>
+              </a:defRPr>
+            </a:pPr>
+            <a:r>
+              <a:rPr sz="1425" b="1">
+                <a:solidFill>
+                  <a:srgbClr val="475569"/>
+                </a:solidFill>
+                <a:latin typeface="Microsoft YaHei"/>
+                <a:ea typeface="Microsoft YaHei"/>
+                <a:cs typeface="Microsoft YaHei"/>
+              </a:rPr>
+              <a:t>建立审查闭环</a:t>
+            </a:r>
+          </a:p>
+        </p:txBody>
+      </p:sp>
+      <p:sp>
+        <p:nvSpPr>
+          <p:cNvPr id="21" name="PPAGENT_QA|within=improvement-item-2|role=body">
+            <a:extLst xmlns:a="http://schemas.openxmlformats.org/drawingml/2006/main">
+              <a:ext uri="{FF2B5EF4-FFF2-40B4-BE49-F238E27FC236}">
+                <a16:creationId xmlns:a16="http://schemas.microsoft.com/office/drawing/2014/main" id="{7F3A209E-713F-4B58-A926-1CE432512ED9}"/>
+              </a:ext>
+            </a:extLst>
+          </p:cNvPr>
+          <p:cNvSpPr>
+            <a:spLocks xmlns:a="http://schemas.openxmlformats.org/drawingml/2006/main" noGrp="1"/>
+          </p:cNvSpPr>
+          <p:nvPr/>
+        </p:nvSpPr>
+        <p:spPr>
+          <a:xfrm xmlns:a="http://schemas.openxmlformats.org/drawingml/2006/main">
+            <a:off x="7562850" y="4876800"/>
+            <a:ext cx="3409950" cy="342900"/>
+          </a:xfrm>
+          <a:prstGeom xmlns:a="http://schemas.openxmlformats.org/drawingml/2006/main" prst="rect">
+            <a:avLst/>
+          </a:prstGeom>
+          <a:noFill xmlns:a="http://schemas.openxmlformats.org/drawingml/2006/main"/>
+          <a:ln xmlns:a="http://schemas.openxmlformats.org/drawingml/2006/main" w="0">
+            <a:noFill/>
+            <a:prstDash val="solid"/>
+          </a:ln>
+        </p:spPr>
+        <p:txBody>
+          <a:bodyPr xmlns:a="http://schemas.openxmlformats.org/drawingml/2006/main" lIns="0" tIns="0" rIns="0" bIns="0" anchor="t">
+            <a:normAutofit fontScale="100000"/>
+          </a:bodyPr>
+          <a:lstStyle xmlns:a="http://schemas.openxmlformats.org/drawingml/2006/main"/>
+          <a:p xmlns:a="http://schemas.openxmlformats.org/drawingml/2006/main">
+            <a:pPr algn="l">
+              <a:defRPr sz="1350" b="0">
+                <a:solidFill>
+                  <a:srgbClr val="475569"/>
+                </a:solidFill>
+                <a:latin typeface="Microsoft YaHei"/>
+                <a:ea typeface="Microsoft YaHei"/>
+                <a:cs typeface="Microsoft YaHei"/>
+              </a:defRPr>
+            </a:pPr>
+            <a:r>
+              <a:rPr sz="1350" b="0">
+                <a:solidFill>
+                  <a:srgbClr val="475569"/>
+                </a:solidFill>
+                <a:latin typeface="Microsoft YaHei"/>
+                <a:ea typeface="Microsoft YaHei"/>
+                <a:cs typeface="Microsoft YaHei"/>
+              </a:rPr>
+              <a:t>在入库前完成状态与视觉确认</a:t>
+            </a:r>
+          </a:p>
+        </p:txBody>
+      </p:sp>
+      <p:sp>
+        <p:nvSpPr>
+          <p:cNvPr id="22" name="">
+            <a:extLst xmlns:a="http://schemas.openxmlformats.org/drawingml/2006/main">
+              <a:ext uri="{FF2B5EF4-FFF2-40B4-BE49-F238E27FC236}">
+                <a16:creationId xmlns:a16="http://schemas.microsoft.com/office/drawing/2014/main" id="{037CBFF2-5BEC-49C8-A3A6-B2FB728C91FE}"/>
               </a:ext>
             </a:extLst>
           </p:cNvPr>
@@ -2016,7 +3346,2428 @@
     </p:spTree>
     <p:extLst>
       <p:ext uri="{BB962C8B-B14F-4D97-AF65-F5344CB8AC3E}">
-        <p14:creationId xmlns:p14="http://schemas.microsoft.com/office/powerpoint/2010/main" val="860145192"/>
+        <p14:creationId xmlns:p14="http://schemas.microsoft.com/office/powerpoint/2010/main" val="2108983355"/>
+      </p:ext>
+    </p:extLst>
+  </p:cSld>
+</p:sld>
+</file>
+
+<file path=ppt/slides/slide3.xml><?xml version="1.0" encoding="utf-8"?>
+<p:sld xmlns:p="http://schemas.openxmlformats.org/presentationml/2006/main">
+  <p:cSld>
+    <p:bg>
+      <p:bgPr>
+        <a:solidFill xmlns:a="http://schemas.openxmlformats.org/drawingml/2006/main">
+          <a:srgbClr val="F7FAFC"/>
+        </a:solidFill>
+      </p:bgPr>
+    </p:bg>
+    <p:spTree>
+      <p:nvGrpSpPr>
+        <p:cNvPr id="1" name=""/>
+        <p:cNvGrpSpPr/>
+        <p:nvPr/>
+      </p:nvGrpSpPr>
+      <p:grpSpPr>
+        <a:xfrm xmlns:a="http://schemas.openxmlformats.org/drawingml/2006/main"/>
+      </p:grpSpPr>
+      <p:sp>
+        <p:nvSpPr>
+          <p:cNvPr id="23" name="">
+            <a:extLst xmlns:a="http://schemas.openxmlformats.org/drawingml/2006/main">
+              <a:ext uri="{FF2B5EF4-FFF2-40B4-BE49-F238E27FC236}">
+                <a16:creationId xmlns:a16="http://schemas.microsoft.com/office/drawing/2014/main" id="{3BB9D5B5-EDD2-42D1-9EFF-028E265A23FA}"/>
+              </a:ext>
+            </a:extLst>
+          </p:cNvPr>
+          <p:cNvSpPr>
+            <a:spLocks xmlns:a="http://schemas.openxmlformats.org/drawingml/2006/main" noGrp="1"/>
+          </p:cNvSpPr>
+          <p:nvPr/>
+        </p:nvSpPr>
+        <p:spPr>
+          <a:xfrm xmlns:a="http://schemas.openxmlformats.org/drawingml/2006/main">
+            <a:off x="685800" y="400050"/>
+            <a:ext cx="8382000" cy="457200"/>
+          </a:xfrm>
+          <a:prstGeom xmlns:a="http://schemas.openxmlformats.org/drawingml/2006/main" prst="rect">
+            <a:avLst/>
+          </a:prstGeom>
+          <a:noFill xmlns:a="http://schemas.openxmlformats.org/drawingml/2006/main"/>
+          <a:ln xmlns:a="http://schemas.openxmlformats.org/drawingml/2006/main" w="0">
+            <a:noFill/>
+            <a:prstDash val="solid"/>
+          </a:ln>
+        </p:spPr>
+        <p:txBody>
+          <a:bodyPr xmlns:a="http://schemas.openxmlformats.org/drawingml/2006/main" lIns="0" tIns="0" rIns="0" bIns="0" anchor="ctr">
+            <a:normAutofit fontScale="100000"/>
+          </a:bodyPr>
+          <a:lstStyle xmlns:a="http://schemas.openxmlformats.org/drawingml/2006/main"/>
+          <a:p xmlns:a="http://schemas.openxmlformats.org/drawingml/2006/main">
+            <a:pPr algn="l">
+              <a:defRPr sz="2700" b="1">
+                <a:solidFill>
+                  <a:srgbClr val="1677C8"/>
+                </a:solidFill>
+                <a:latin typeface="Microsoft YaHei"/>
+                <a:ea typeface="Microsoft YaHei"/>
+                <a:cs typeface="Microsoft YaHei"/>
+              </a:defRPr>
+            </a:pPr>
+            <a:r>
+              <a:rPr sz="2700" b="1">
+                <a:solidFill>
+                  <a:srgbClr val="1677C8"/>
+                </a:solidFill>
+                <a:latin typeface="Microsoft YaHei"/>
+                <a:ea typeface="Microsoft YaHei"/>
+                <a:cs typeface="Microsoft YaHei"/>
+              </a:rPr>
+              <a:t>问题与改进措施</a:t>
+            </a:r>
+          </a:p>
+        </p:txBody>
+      </p:sp>
+      <p:sp>
+        <p:nvSpPr>
+          <p:cNvPr id="2" name="">
+            <a:extLst xmlns:a="http://schemas.openxmlformats.org/drawingml/2006/main">
+              <a:ext uri="{FF2B5EF4-FFF2-40B4-BE49-F238E27FC236}">
+                <a16:creationId xmlns:a16="http://schemas.microsoft.com/office/drawing/2014/main" id="{7A2A739F-7CBA-4B2F-BC23-C5BEDB31BDC8}"/>
+              </a:ext>
+            </a:extLst>
+          </p:cNvPr>
+          <p:cNvSpPr>
+            <a:spLocks xmlns:a="http://schemas.openxmlformats.org/drawingml/2006/main" noGrp="1"/>
+          </p:cNvSpPr>
+          <p:nvPr/>
+        </p:nvSpPr>
+        <p:spPr>
+          <a:xfrm xmlns:a="http://schemas.openxmlformats.org/drawingml/2006/main">
+            <a:off x="704850" y="876300"/>
+            <a:ext cx="4953000" cy="247650"/>
+          </a:xfrm>
+          <a:prstGeom xmlns:a="http://schemas.openxmlformats.org/drawingml/2006/main" prst="rect">
+            <a:avLst/>
+          </a:prstGeom>
+          <a:noFill xmlns:a="http://schemas.openxmlformats.org/drawingml/2006/main"/>
+          <a:ln xmlns:a="http://schemas.openxmlformats.org/drawingml/2006/main" w="0">
+            <a:noFill/>
+            <a:prstDash val="solid"/>
+          </a:ln>
+        </p:spPr>
+        <p:txBody>
+          <a:bodyPr xmlns:a="http://schemas.openxmlformats.org/drawingml/2006/main" lIns="0" tIns="0" rIns="0" bIns="0" anchor="ctr">
+            <a:normAutofit fontScale="100000"/>
+          </a:bodyPr>
+          <a:lstStyle xmlns:a="http://schemas.openxmlformats.org/drawingml/2006/main"/>
+          <a:p xmlns:a="http://schemas.openxmlformats.org/drawingml/2006/main">
+            <a:pPr algn="l">
+              <a:defRPr sz="1200" b="0">
+                <a:solidFill>
+                  <a:srgbClr val="7C8A9A"/>
+                </a:solidFill>
+                <a:latin typeface="Microsoft YaHei"/>
+                <a:ea typeface="Microsoft YaHei"/>
+                <a:cs typeface="Microsoft YaHei"/>
+              </a:defRPr>
+            </a:pPr>
+            <a:r>
+              <a:rPr sz="1200" b="0">
+                <a:solidFill>
+                  <a:srgbClr val="7C8A9A"/>
+                </a:solidFill>
+                <a:latin typeface="Microsoft YaHei"/>
+                <a:ea typeface="Microsoft YaHei"/>
+                <a:cs typeface="Microsoft YaHei"/>
+              </a:rPr>
+              <a:t>问题—改进</a:t>
+            </a:r>
+          </a:p>
+        </p:txBody>
+      </p:sp>
+      <p:sp>
+        <p:nvSpPr>
+          <p:cNvPr id="3" name="">
+            <a:extLst xmlns:a="http://schemas.openxmlformats.org/drawingml/2006/main">
+              <a:ext uri="{FF2B5EF4-FFF2-40B4-BE49-F238E27FC236}">
+                <a16:creationId xmlns:a16="http://schemas.microsoft.com/office/drawing/2014/main" id="{A3F91C75-67AA-4949-9F7A-F34B13A872ED}"/>
+              </a:ext>
+            </a:extLst>
+          </p:cNvPr>
+          <p:cNvSpPr>
+            <a:spLocks xmlns:a="http://schemas.openxmlformats.org/drawingml/2006/main" noGrp="1"/>
+          </p:cNvSpPr>
+          <p:nvPr/>
+        </p:nvSpPr>
+        <p:spPr>
+          <a:xfrm xmlns:a="http://schemas.openxmlformats.org/drawingml/2006/main">
+            <a:off x="685800" y="1428750"/>
+            <a:ext cx="4476750" cy="4572000"/>
+          </a:xfrm>
+          <a:prstGeom xmlns:a="http://schemas.openxmlformats.org/drawingml/2006/main" prst="roundRect">
+            <a:avLst>
+              <a:gd name="adj" fmla="val 2553"/>
+            </a:avLst>
+          </a:prstGeom>
+          <a:solidFill xmlns:a="http://schemas.openxmlformats.org/drawingml/2006/main">
+            <a:srgbClr val="FFFFFF"/>
+          </a:solidFill>
+          <a:ln xmlns:a="http://schemas.openxmlformats.org/drawingml/2006/main" w="19050">
+            <a:solidFill>
+              <a:srgbClr val="1677C8"/>
+            </a:solidFill>
+            <a:prstDash val="solid"/>
+          </a:ln>
+        </p:spPr>
+        <p:style>
+          <a:lnRef xmlns:a="http://schemas.openxmlformats.org/drawingml/2006/main" idx="0"/>
+          <a:fillRef xmlns:a="http://schemas.openxmlformats.org/drawingml/2006/main" idx="0"/>
+          <a:effectRef xmlns:a="http://schemas.openxmlformats.org/drawingml/2006/main" idx="4"/>
+          <a:fontRef xmlns:a="http://schemas.openxmlformats.org/drawingml/2006/main" idx="major"/>
+        </p:style>
+      </p:sp>
+      <p:sp>
+        <p:nvSpPr>
+          <p:cNvPr id="4" name="">
+            <a:extLst xmlns:a="http://schemas.openxmlformats.org/drawingml/2006/main">
+              <a:ext uri="{FF2B5EF4-FFF2-40B4-BE49-F238E27FC236}">
+                <a16:creationId xmlns:a16="http://schemas.microsoft.com/office/drawing/2014/main" id="{75D2D963-39EA-4E04-AE19-239DDFCDA343}"/>
+              </a:ext>
+            </a:extLst>
+          </p:cNvPr>
+          <p:cNvSpPr>
+            <a:spLocks xmlns:a="http://schemas.openxmlformats.org/drawingml/2006/main" noGrp="1"/>
+          </p:cNvSpPr>
+          <p:nvPr/>
+        </p:nvSpPr>
+        <p:spPr>
+          <a:xfrm xmlns:a="http://schemas.openxmlformats.org/drawingml/2006/main">
+            <a:off x="7029450" y="1428750"/>
+            <a:ext cx="4476750" cy="4572000"/>
+          </a:xfrm>
+          <a:prstGeom xmlns:a="http://schemas.openxmlformats.org/drawingml/2006/main" prst="roundRect">
+            <a:avLst>
+              <a:gd name="adj" fmla="val 2553"/>
+            </a:avLst>
+          </a:prstGeom>
+          <a:solidFill xmlns:a="http://schemas.openxmlformats.org/drawingml/2006/main">
+            <a:srgbClr val="FFFFFF"/>
+          </a:solidFill>
+          <a:ln xmlns:a="http://schemas.openxmlformats.org/drawingml/2006/main" w="19050">
+            <a:solidFill>
+              <a:srgbClr val="00A8D8"/>
+            </a:solidFill>
+            <a:prstDash val="solid"/>
+          </a:ln>
+        </p:spPr>
+        <p:style>
+          <a:lnRef xmlns:a="http://schemas.openxmlformats.org/drawingml/2006/main" idx="0"/>
+          <a:fillRef xmlns:a="http://schemas.openxmlformats.org/drawingml/2006/main" idx="0"/>
+          <a:effectRef xmlns:a="http://schemas.openxmlformats.org/drawingml/2006/main" idx="4"/>
+          <a:fontRef xmlns:a="http://schemas.openxmlformats.org/drawingml/2006/main" idx="major"/>
+        </p:style>
+      </p:sp>
+      <p:sp>
+        <p:nvSpPr>
+          <p:cNvPr id="5" name="">
+            <a:extLst xmlns:a="http://schemas.openxmlformats.org/drawingml/2006/main">
+              <a:ext uri="{FF2B5EF4-FFF2-40B4-BE49-F238E27FC236}">
+                <a16:creationId xmlns:a16="http://schemas.microsoft.com/office/drawing/2014/main" id="{4356C299-A916-4684-901B-16BD0FDFA73B}"/>
+              </a:ext>
+            </a:extLst>
+          </p:cNvPr>
+          <p:cNvSpPr>
+            <a:spLocks xmlns:a="http://schemas.openxmlformats.org/drawingml/2006/main" noGrp="1"/>
+          </p:cNvSpPr>
+          <p:nvPr/>
+        </p:nvSpPr>
+        <p:spPr>
+          <a:xfrm xmlns:a="http://schemas.openxmlformats.org/drawingml/2006/main">
+            <a:off x="971550" y="1695450"/>
+            <a:ext cx="3905250" cy="419100"/>
+          </a:xfrm>
+          <a:prstGeom xmlns:a="http://schemas.openxmlformats.org/drawingml/2006/main" prst="rect">
+            <a:avLst/>
+          </a:prstGeom>
+          <a:noFill xmlns:a="http://schemas.openxmlformats.org/drawingml/2006/main"/>
+          <a:ln xmlns:a="http://schemas.openxmlformats.org/drawingml/2006/main" w="0">
+            <a:noFill/>
+            <a:prstDash val="solid"/>
+          </a:ln>
+        </p:spPr>
+        <p:txBody>
+          <a:bodyPr xmlns:a="http://schemas.openxmlformats.org/drawingml/2006/main" lIns="0" tIns="0" rIns="0" bIns="0" anchor="ctr">
+            <a:normAutofit fontScale="100000"/>
+          </a:bodyPr>
+          <a:lstStyle xmlns:a="http://schemas.openxmlformats.org/drawingml/2006/main"/>
+          <a:p xmlns:a="http://schemas.openxmlformats.org/drawingml/2006/main">
+            <a:pPr algn="ctr">
+              <a:defRPr sz="1950" b="1">
+                <a:solidFill>
+                  <a:srgbClr val="1677C8"/>
+                </a:solidFill>
+                <a:latin typeface="Microsoft YaHei"/>
+                <a:ea typeface="Microsoft YaHei"/>
+                <a:cs typeface="Microsoft YaHei"/>
+              </a:defRPr>
+            </a:pPr>
+            <a:r>
+              <a:rPr sz="1950" b="1">
+                <a:solidFill>
+                  <a:srgbClr val="1677C8"/>
+                </a:solidFill>
+                <a:latin typeface="Microsoft YaHei"/>
+                <a:ea typeface="Microsoft YaHei"/>
+                <a:cs typeface="Microsoft YaHei"/>
+              </a:rPr>
+              <a:t>现状与缺口</a:t>
+            </a:r>
+          </a:p>
+        </p:txBody>
+      </p:sp>
+      <p:sp>
+        <p:nvSpPr>
+          <p:cNvPr id="6" name="">
+            <a:extLst xmlns:a="http://schemas.openxmlformats.org/drawingml/2006/main">
+              <a:ext uri="{FF2B5EF4-FFF2-40B4-BE49-F238E27FC236}">
+                <a16:creationId xmlns:a16="http://schemas.microsoft.com/office/drawing/2014/main" id="{AE838FA6-BFC5-47D0-9EFA-386628D7EAB2}"/>
+              </a:ext>
+            </a:extLst>
+          </p:cNvPr>
+          <p:cNvSpPr>
+            <a:spLocks xmlns:a="http://schemas.openxmlformats.org/drawingml/2006/main" noGrp="1"/>
+          </p:cNvSpPr>
+          <p:nvPr/>
+        </p:nvSpPr>
+        <p:spPr>
+          <a:xfrm xmlns:a="http://schemas.openxmlformats.org/drawingml/2006/main">
+            <a:off x="7315200" y="1695450"/>
+            <a:ext cx="3905250" cy="419100"/>
+          </a:xfrm>
+          <a:prstGeom xmlns:a="http://schemas.openxmlformats.org/drawingml/2006/main" prst="rect">
+            <a:avLst/>
+          </a:prstGeom>
+          <a:noFill xmlns:a="http://schemas.openxmlformats.org/drawingml/2006/main"/>
+          <a:ln xmlns:a="http://schemas.openxmlformats.org/drawingml/2006/main" w="0">
+            <a:noFill/>
+            <a:prstDash val="solid"/>
+          </a:ln>
+        </p:spPr>
+        <p:txBody>
+          <a:bodyPr xmlns:a="http://schemas.openxmlformats.org/drawingml/2006/main" lIns="0" tIns="0" rIns="0" bIns="0" anchor="ctr">
+            <a:normAutofit fontScale="100000"/>
+          </a:bodyPr>
+          <a:lstStyle xmlns:a="http://schemas.openxmlformats.org/drawingml/2006/main"/>
+          <a:p xmlns:a="http://schemas.openxmlformats.org/drawingml/2006/main">
+            <a:pPr algn="ctr">
+              <a:defRPr sz="1950" b="1">
+                <a:solidFill>
+                  <a:srgbClr val="00A8D8"/>
+                </a:solidFill>
+                <a:latin typeface="Microsoft YaHei"/>
+                <a:ea typeface="Microsoft YaHei"/>
+                <a:cs typeface="Microsoft YaHei"/>
+              </a:defRPr>
+            </a:pPr>
+            <a:r>
+              <a:rPr sz="1950" b="1">
+                <a:solidFill>
+                  <a:srgbClr val="00A8D8"/>
+                </a:solidFill>
+                <a:latin typeface="Microsoft YaHei"/>
+                <a:ea typeface="Microsoft YaHei"/>
+                <a:cs typeface="Microsoft YaHei"/>
+              </a:rPr>
+              <a:t>系统介入与结果</a:t>
+            </a:r>
+          </a:p>
+        </p:txBody>
+      </p:sp>
+      <p:sp>
+        <p:nvSpPr>
+          <p:cNvPr id="7" name="PPAGENT_QA|parent=problem-item-0|domains=problem-items">
+            <a:extLst xmlns:a="http://schemas.openxmlformats.org/drawingml/2006/main">
+              <a:ext uri="{FF2B5EF4-FFF2-40B4-BE49-F238E27FC236}">
+                <a16:creationId xmlns:a16="http://schemas.microsoft.com/office/drawing/2014/main" id="{E5D6796F-44BE-4EDD-9A3F-DB04C7CC151C}"/>
+              </a:ext>
+            </a:extLst>
+          </p:cNvPr>
+          <p:cNvSpPr>
+            <a:spLocks xmlns:a="http://schemas.openxmlformats.org/drawingml/2006/main" noGrp="1"/>
+          </p:cNvSpPr>
+          <p:nvPr/>
+        </p:nvSpPr>
+        <p:spPr>
+          <a:xfrm xmlns:a="http://schemas.openxmlformats.org/drawingml/2006/main">
+            <a:off x="1066800" y="2343150"/>
+            <a:ext cx="3714750" cy="819150"/>
+          </a:xfrm>
+          <a:prstGeom xmlns:a="http://schemas.openxmlformats.org/drawingml/2006/main" prst="roundRect">
+            <a:avLst>
+              <a:gd name="adj" fmla="val 13953"/>
+            </a:avLst>
+          </a:prstGeom>
+          <a:solidFill xmlns:a="http://schemas.openxmlformats.org/drawingml/2006/main">
+            <a:srgbClr val="F1F7FB"/>
+          </a:solidFill>
+          <a:ln xmlns:a="http://schemas.openxmlformats.org/drawingml/2006/main" w="9525">
+            <a:solidFill>
+              <a:srgbClr val="C9D5E3"/>
+            </a:solidFill>
+            <a:prstDash val="solid"/>
+          </a:ln>
+        </p:spPr>
+      </p:sp>
+      <p:sp>
+        <p:nvSpPr>
+          <p:cNvPr id="8" name="PPAGENT_QA|within=problem-item-0|role=title">
+            <a:extLst xmlns:a="http://schemas.openxmlformats.org/drawingml/2006/main">
+              <a:ext uri="{FF2B5EF4-FFF2-40B4-BE49-F238E27FC236}">
+                <a16:creationId xmlns:a16="http://schemas.microsoft.com/office/drawing/2014/main" id="{DC68C241-4D45-474A-8C09-E782DFFF3980}"/>
+              </a:ext>
+            </a:extLst>
+          </p:cNvPr>
+          <p:cNvSpPr>
+            <a:spLocks xmlns:a="http://schemas.openxmlformats.org/drawingml/2006/main" noGrp="1"/>
+          </p:cNvSpPr>
+          <p:nvPr/>
+        </p:nvSpPr>
+        <p:spPr>
+          <a:xfrm xmlns:a="http://schemas.openxmlformats.org/drawingml/2006/main">
+            <a:off x="1219200" y="2457450"/>
+            <a:ext cx="3409950" cy="247650"/>
+          </a:xfrm>
+          <a:prstGeom xmlns:a="http://schemas.openxmlformats.org/drawingml/2006/main" prst="rect">
+            <a:avLst/>
+          </a:prstGeom>
+          <a:noFill xmlns:a="http://schemas.openxmlformats.org/drawingml/2006/main"/>
+          <a:ln xmlns:a="http://schemas.openxmlformats.org/drawingml/2006/main" w="0">
+            <a:noFill/>
+            <a:prstDash val="solid"/>
+          </a:ln>
+        </p:spPr>
+        <p:txBody>
+          <a:bodyPr xmlns:a="http://schemas.openxmlformats.org/drawingml/2006/main" lIns="0" tIns="0" rIns="0" bIns="0" anchor="ctr">
+            <a:normAutofit fontScale="100000"/>
+          </a:bodyPr>
+          <a:lstStyle xmlns:a="http://schemas.openxmlformats.org/drawingml/2006/main"/>
+          <a:p xmlns:a="http://schemas.openxmlformats.org/drawingml/2006/main">
+            <a:pPr algn="l">
+              <a:defRPr sz="1425" b="1">
+                <a:solidFill>
+                  <a:srgbClr val="475569"/>
+                </a:solidFill>
+                <a:latin typeface="Microsoft YaHei"/>
+                <a:ea typeface="Microsoft YaHei"/>
+                <a:cs typeface="Microsoft YaHei"/>
+              </a:defRPr>
+            </a:pPr>
+            <a:r>
+              <a:rPr sz="1425" b="1">
+                <a:solidFill>
+                  <a:srgbClr val="475569"/>
+                </a:solidFill>
+                <a:latin typeface="Microsoft YaHei"/>
+                <a:ea typeface="Microsoft YaHei"/>
+                <a:cs typeface="Microsoft YaHei"/>
+              </a:rPr>
+              <a:t>结果不稳定</a:t>
+            </a:r>
+          </a:p>
+        </p:txBody>
+      </p:sp>
+      <p:sp>
+        <p:nvSpPr>
+          <p:cNvPr id="9" name="PPAGENT_QA|within=problem-item-0|role=body">
+            <a:extLst xmlns:a="http://schemas.openxmlformats.org/drawingml/2006/main">
+              <a:ext uri="{FF2B5EF4-FFF2-40B4-BE49-F238E27FC236}">
+                <a16:creationId xmlns:a16="http://schemas.microsoft.com/office/drawing/2014/main" id="{AE234E40-F153-4D5D-AE95-E2B0E6652C07}"/>
+              </a:ext>
+            </a:extLst>
+          </p:cNvPr>
+          <p:cNvSpPr>
+            <a:spLocks xmlns:a="http://schemas.openxmlformats.org/drawingml/2006/main" noGrp="1"/>
+          </p:cNvSpPr>
+          <p:nvPr/>
+        </p:nvSpPr>
+        <p:spPr>
+          <a:xfrm xmlns:a="http://schemas.openxmlformats.org/drawingml/2006/main">
+            <a:off x="1219200" y="2743200"/>
+            <a:ext cx="3409950" cy="342900"/>
+          </a:xfrm>
+          <a:prstGeom xmlns:a="http://schemas.openxmlformats.org/drawingml/2006/main" prst="rect">
+            <a:avLst/>
+          </a:prstGeom>
+          <a:noFill xmlns:a="http://schemas.openxmlformats.org/drawingml/2006/main"/>
+          <a:ln xmlns:a="http://schemas.openxmlformats.org/drawingml/2006/main" w="0">
+            <a:noFill/>
+            <a:prstDash val="solid"/>
+          </a:ln>
+        </p:spPr>
+        <p:txBody>
+          <a:bodyPr xmlns:a="http://schemas.openxmlformats.org/drawingml/2006/main" lIns="0" tIns="0" rIns="0" bIns="0" anchor="t">
+            <a:normAutofit fontScale="100000"/>
+          </a:bodyPr>
+          <a:lstStyle xmlns:a="http://schemas.openxmlformats.org/drawingml/2006/main"/>
+          <a:p xmlns:a="http://schemas.openxmlformats.org/drawingml/2006/main">
+            <a:pPr algn="l">
+              <a:defRPr sz="1350" b="0">
+                <a:solidFill>
+                  <a:srgbClr val="475569"/>
+                </a:solidFill>
+                <a:latin typeface="Microsoft YaHei"/>
+                <a:ea typeface="Microsoft YaHei"/>
+                <a:cs typeface="Microsoft YaHei"/>
+              </a:defRPr>
+            </a:pPr>
+            <a:r>
+              <a:rPr sz="1350" b="0">
+                <a:solidFill>
+                  <a:srgbClr val="475569"/>
+                </a:solidFill>
+                <a:latin typeface="Microsoft YaHei"/>
+                <a:ea typeface="Microsoft YaHei"/>
+                <a:cs typeface="Microsoft YaHei"/>
+              </a:rPr>
+              <a:t>相同输入仍可能得到差异较大的页面</a:t>
+            </a:r>
+          </a:p>
+        </p:txBody>
+      </p:sp>
+      <p:sp>
+        <p:nvSpPr>
+          <p:cNvPr id="10" name="PPAGENT_QA|parent=problem-item-1|domains=problem-items">
+            <a:extLst xmlns:a="http://schemas.openxmlformats.org/drawingml/2006/main">
+              <a:ext uri="{FF2B5EF4-FFF2-40B4-BE49-F238E27FC236}">
+                <a16:creationId xmlns:a16="http://schemas.microsoft.com/office/drawing/2014/main" id="{1C5ACFEF-F431-463F-97AE-8D80FB3ED890}"/>
+              </a:ext>
+            </a:extLst>
+          </p:cNvPr>
+          <p:cNvSpPr>
+            <a:spLocks xmlns:a="http://schemas.openxmlformats.org/drawingml/2006/main" noGrp="1"/>
+          </p:cNvSpPr>
+          <p:nvPr/>
+        </p:nvSpPr>
+        <p:spPr>
+          <a:xfrm xmlns:a="http://schemas.openxmlformats.org/drawingml/2006/main">
+            <a:off x="1066800" y="3409950"/>
+            <a:ext cx="3714750" cy="819150"/>
+          </a:xfrm>
+          <a:prstGeom xmlns:a="http://schemas.openxmlformats.org/drawingml/2006/main" prst="roundRect">
+            <a:avLst>
+              <a:gd name="adj" fmla="val 13953"/>
+            </a:avLst>
+          </a:prstGeom>
+          <a:solidFill xmlns:a="http://schemas.openxmlformats.org/drawingml/2006/main">
+            <a:srgbClr val="F1F7FB"/>
+          </a:solidFill>
+          <a:ln xmlns:a="http://schemas.openxmlformats.org/drawingml/2006/main" w="9525">
+            <a:solidFill>
+              <a:srgbClr val="C9D5E3"/>
+            </a:solidFill>
+            <a:prstDash val="solid"/>
+          </a:ln>
+        </p:spPr>
+      </p:sp>
+      <p:sp>
+        <p:nvSpPr>
+          <p:cNvPr id="11" name="PPAGENT_QA|within=problem-item-1|role=title">
+            <a:extLst xmlns:a="http://schemas.openxmlformats.org/drawingml/2006/main">
+              <a:ext uri="{FF2B5EF4-FFF2-40B4-BE49-F238E27FC236}">
+                <a16:creationId xmlns:a16="http://schemas.microsoft.com/office/drawing/2014/main" id="{2C275DF9-077A-47F4-A4E5-DCF0E5EC1A77}"/>
+              </a:ext>
+            </a:extLst>
+          </p:cNvPr>
+          <p:cNvSpPr>
+            <a:spLocks xmlns:a="http://schemas.openxmlformats.org/drawingml/2006/main" noGrp="1"/>
+          </p:cNvSpPr>
+          <p:nvPr/>
+        </p:nvSpPr>
+        <p:spPr>
+          <a:xfrm xmlns:a="http://schemas.openxmlformats.org/drawingml/2006/main">
+            <a:off x="1219200" y="3524250"/>
+            <a:ext cx="3409950" cy="247650"/>
+          </a:xfrm>
+          <a:prstGeom xmlns:a="http://schemas.openxmlformats.org/drawingml/2006/main" prst="rect">
+            <a:avLst/>
+          </a:prstGeom>
+          <a:noFill xmlns:a="http://schemas.openxmlformats.org/drawingml/2006/main"/>
+          <a:ln xmlns:a="http://schemas.openxmlformats.org/drawingml/2006/main" w="0">
+            <a:noFill/>
+            <a:prstDash val="solid"/>
+          </a:ln>
+        </p:spPr>
+        <p:txBody>
+          <a:bodyPr xmlns:a="http://schemas.openxmlformats.org/drawingml/2006/main" lIns="0" tIns="0" rIns="0" bIns="0" anchor="ctr">
+            <a:normAutofit fontScale="100000"/>
+          </a:bodyPr>
+          <a:lstStyle xmlns:a="http://schemas.openxmlformats.org/drawingml/2006/main"/>
+          <a:p xmlns:a="http://schemas.openxmlformats.org/drawingml/2006/main">
+            <a:pPr algn="l">
+              <a:defRPr sz="1425" b="1">
+                <a:solidFill>
+                  <a:srgbClr val="475569"/>
+                </a:solidFill>
+                <a:latin typeface="Microsoft YaHei"/>
+                <a:ea typeface="Microsoft YaHei"/>
+                <a:cs typeface="Microsoft YaHei"/>
+              </a:defRPr>
+            </a:pPr>
+            <a:r>
+              <a:rPr sz="1425" b="1">
+                <a:solidFill>
+                  <a:srgbClr val="475569"/>
+                </a:solidFill>
+                <a:latin typeface="Microsoft YaHei"/>
+                <a:ea typeface="Microsoft YaHei"/>
+                <a:cs typeface="Microsoft YaHei"/>
+              </a:rPr>
+              <a:t>经验难沉淀</a:t>
+            </a:r>
+          </a:p>
+        </p:txBody>
+      </p:sp>
+      <p:sp>
+        <p:nvSpPr>
+          <p:cNvPr id="12" name="PPAGENT_QA|within=problem-item-1|role=body">
+            <a:extLst xmlns:a="http://schemas.openxmlformats.org/drawingml/2006/main">
+              <a:ext uri="{FF2B5EF4-FFF2-40B4-BE49-F238E27FC236}">
+                <a16:creationId xmlns:a16="http://schemas.microsoft.com/office/drawing/2014/main" id="{C383E43F-4123-445A-B954-5E7E3361AD0C}"/>
+              </a:ext>
+            </a:extLst>
+          </p:cNvPr>
+          <p:cNvSpPr>
+            <a:spLocks xmlns:a="http://schemas.openxmlformats.org/drawingml/2006/main" noGrp="1"/>
+          </p:cNvSpPr>
+          <p:nvPr/>
+        </p:nvSpPr>
+        <p:spPr>
+          <a:xfrm xmlns:a="http://schemas.openxmlformats.org/drawingml/2006/main">
+            <a:off x="1219200" y="3810000"/>
+            <a:ext cx="3409950" cy="342900"/>
+          </a:xfrm>
+          <a:prstGeom xmlns:a="http://schemas.openxmlformats.org/drawingml/2006/main" prst="rect">
+            <a:avLst/>
+          </a:prstGeom>
+          <a:noFill xmlns:a="http://schemas.openxmlformats.org/drawingml/2006/main"/>
+          <a:ln xmlns:a="http://schemas.openxmlformats.org/drawingml/2006/main" w="0">
+            <a:noFill/>
+            <a:prstDash val="solid"/>
+          </a:ln>
+        </p:spPr>
+        <p:txBody>
+          <a:bodyPr xmlns:a="http://schemas.openxmlformats.org/drawingml/2006/main" lIns="0" tIns="0" rIns="0" bIns="0" anchor="t">
+            <a:normAutofit fontScale="100000"/>
+          </a:bodyPr>
+          <a:lstStyle xmlns:a="http://schemas.openxmlformats.org/drawingml/2006/main"/>
+          <a:p xmlns:a="http://schemas.openxmlformats.org/drawingml/2006/main">
+            <a:pPr algn="l">
+              <a:defRPr sz="1350" b="0">
+                <a:solidFill>
+                  <a:srgbClr val="475569"/>
+                </a:solidFill>
+                <a:latin typeface="Microsoft YaHei"/>
+                <a:ea typeface="Microsoft YaHei"/>
+                <a:cs typeface="Microsoft YaHei"/>
+              </a:defRPr>
+            </a:pPr>
+            <a:r>
+              <a:rPr sz="1350" b="0">
+                <a:solidFill>
+                  <a:srgbClr val="475569"/>
+                </a:solidFill>
+                <a:latin typeface="Microsoft YaHei"/>
+                <a:ea typeface="Microsoft YaHei"/>
+                <a:cs typeface="Microsoft YaHei"/>
+              </a:rPr>
+              <a:t>每次任务都需要重新判断和修正</a:t>
+            </a:r>
+          </a:p>
+        </p:txBody>
+      </p:sp>
+      <p:sp>
+        <p:nvSpPr>
+          <p:cNvPr id="13" name="PPAGENT_QA|parent=problem-item-2|domains=problem-items">
+            <a:extLst xmlns:a="http://schemas.openxmlformats.org/drawingml/2006/main">
+              <a:ext uri="{FF2B5EF4-FFF2-40B4-BE49-F238E27FC236}">
+                <a16:creationId xmlns:a16="http://schemas.microsoft.com/office/drawing/2014/main" id="{B1B84E95-6020-44FE-BA06-90A20CCCFEC4}"/>
+              </a:ext>
+            </a:extLst>
+          </p:cNvPr>
+          <p:cNvSpPr>
+            <a:spLocks xmlns:a="http://schemas.openxmlformats.org/drawingml/2006/main" noGrp="1"/>
+          </p:cNvSpPr>
+          <p:nvPr/>
+        </p:nvSpPr>
+        <p:spPr>
+          <a:xfrm xmlns:a="http://schemas.openxmlformats.org/drawingml/2006/main">
+            <a:off x="1066800" y="4476750"/>
+            <a:ext cx="3714750" cy="819150"/>
+          </a:xfrm>
+          <a:prstGeom xmlns:a="http://schemas.openxmlformats.org/drawingml/2006/main" prst="roundRect">
+            <a:avLst>
+              <a:gd name="adj" fmla="val 13953"/>
+            </a:avLst>
+          </a:prstGeom>
+          <a:solidFill xmlns:a="http://schemas.openxmlformats.org/drawingml/2006/main">
+            <a:srgbClr val="F1F7FB"/>
+          </a:solidFill>
+          <a:ln xmlns:a="http://schemas.openxmlformats.org/drawingml/2006/main" w="9525">
+            <a:solidFill>
+              <a:srgbClr val="C9D5E3"/>
+            </a:solidFill>
+            <a:prstDash val="solid"/>
+          </a:ln>
+        </p:spPr>
+      </p:sp>
+      <p:sp>
+        <p:nvSpPr>
+          <p:cNvPr id="14" name="PPAGENT_QA|within=problem-item-2|role=title">
+            <a:extLst xmlns:a="http://schemas.openxmlformats.org/drawingml/2006/main">
+              <a:ext uri="{FF2B5EF4-FFF2-40B4-BE49-F238E27FC236}">
+                <a16:creationId xmlns:a16="http://schemas.microsoft.com/office/drawing/2014/main" id="{1E6AE4B6-E18F-4DC0-8D83-726747857848}"/>
+              </a:ext>
+            </a:extLst>
+          </p:cNvPr>
+          <p:cNvSpPr>
+            <a:spLocks xmlns:a="http://schemas.openxmlformats.org/drawingml/2006/main" noGrp="1"/>
+          </p:cNvSpPr>
+          <p:nvPr/>
+        </p:nvSpPr>
+        <p:spPr>
+          <a:xfrm xmlns:a="http://schemas.openxmlformats.org/drawingml/2006/main">
+            <a:off x="1219200" y="4591050"/>
+            <a:ext cx="3409950" cy="247650"/>
+          </a:xfrm>
+          <a:prstGeom xmlns:a="http://schemas.openxmlformats.org/drawingml/2006/main" prst="rect">
+            <a:avLst/>
+          </a:prstGeom>
+          <a:noFill xmlns:a="http://schemas.openxmlformats.org/drawingml/2006/main"/>
+          <a:ln xmlns:a="http://schemas.openxmlformats.org/drawingml/2006/main" w="0">
+            <a:noFill/>
+            <a:prstDash val="solid"/>
+          </a:ln>
+        </p:spPr>
+        <p:txBody>
+          <a:bodyPr xmlns:a="http://schemas.openxmlformats.org/drawingml/2006/main" lIns="0" tIns="0" rIns="0" bIns="0" anchor="ctr">
+            <a:normAutofit fontScale="100000"/>
+          </a:bodyPr>
+          <a:lstStyle xmlns:a="http://schemas.openxmlformats.org/drawingml/2006/main"/>
+          <a:p xmlns:a="http://schemas.openxmlformats.org/drawingml/2006/main">
+            <a:pPr algn="l">
+              <a:defRPr sz="1425" b="1">
+                <a:solidFill>
+                  <a:srgbClr val="475569"/>
+                </a:solidFill>
+                <a:latin typeface="Microsoft YaHei"/>
+                <a:ea typeface="Microsoft YaHei"/>
+                <a:cs typeface="Microsoft YaHei"/>
+              </a:defRPr>
+            </a:pPr>
+            <a:r>
+              <a:rPr sz="1425" b="1">
+                <a:solidFill>
+                  <a:srgbClr val="475569"/>
+                </a:solidFill>
+                <a:latin typeface="Microsoft YaHei"/>
+                <a:ea typeface="Microsoft YaHei"/>
+                <a:cs typeface="Microsoft YaHei"/>
+              </a:rPr>
+              <a:t>维护成本高</a:t>
+            </a:r>
+          </a:p>
+        </p:txBody>
+      </p:sp>
+      <p:sp>
+        <p:nvSpPr>
+          <p:cNvPr id="15" name="PPAGENT_QA|within=problem-item-2|role=body">
+            <a:extLst xmlns:a="http://schemas.openxmlformats.org/drawingml/2006/main">
+              <a:ext uri="{FF2B5EF4-FFF2-40B4-BE49-F238E27FC236}">
+                <a16:creationId xmlns:a16="http://schemas.microsoft.com/office/drawing/2014/main" id="{DE6313E0-24ED-47DC-9A5B-BE09BC014F50}"/>
+              </a:ext>
+            </a:extLst>
+          </p:cNvPr>
+          <p:cNvSpPr>
+            <a:spLocks xmlns:a="http://schemas.openxmlformats.org/drawingml/2006/main" noGrp="1"/>
+          </p:cNvSpPr>
+          <p:nvPr/>
+        </p:nvSpPr>
+        <p:spPr>
+          <a:xfrm xmlns:a="http://schemas.openxmlformats.org/drawingml/2006/main">
+            <a:off x="1219200" y="4876800"/>
+            <a:ext cx="3409950" cy="342900"/>
+          </a:xfrm>
+          <a:prstGeom xmlns:a="http://schemas.openxmlformats.org/drawingml/2006/main" prst="rect">
+            <a:avLst/>
+          </a:prstGeom>
+          <a:noFill xmlns:a="http://schemas.openxmlformats.org/drawingml/2006/main"/>
+          <a:ln xmlns:a="http://schemas.openxmlformats.org/drawingml/2006/main" w="0">
+            <a:noFill/>
+            <a:prstDash val="solid"/>
+          </a:ln>
+        </p:spPr>
+        <p:txBody>
+          <a:bodyPr xmlns:a="http://schemas.openxmlformats.org/drawingml/2006/main" lIns="0" tIns="0" rIns="0" bIns="0" anchor="t">
+            <a:normAutofit fontScale="100000"/>
+          </a:bodyPr>
+          <a:lstStyle xmlns:a="http://schemas.openxmlformats.org/drawingml/2006/main"/>
+          <a:p xmlns:a="http://schemas.openxmlformats.org/drawingml/2006/main">
+            <a:pPr algn="l">
+              <a:defRPr sz="1350" b="0">
+                <a:solidFill>
+                  <a:srgbClr val="475569"/>
+                </a:solidFill>
+                <a:latin typeface="Microsoft YaHei"/>
+                <a:ea typeface="Microsoft YaHei"/>
+                <a:cs typeface="Microsoft YaHei"/>
+              </a:defRPr>
+            </a:pPr>
+            <a:r>
+              <a:rPr sz="1350" b="0">
+                <a:solidFill>
+                  <a:srgbClr val="475569"/>
+                </a:solidFill>
+                <a:latin typeface="Microsoft YaHei"/>
+                <a:ea typeface="Microsoft YaHei"/>
+                <a:cs typeface="Microsoft YaHei"/>
+              </a:rPr>
+              <a:t>多套实现造成重复修改与偏差</a:t>
+            </a:r>
+          </a:p>
+        </p:txBody>
+      </p:sp>
+      <p:sp>
+        <p:nvSpPr>
+          <p:cNvPr id="16" name="PPAGENT_QA|parent=improvement-item-0|domains=improvement-items">
+            <a:extLst xmlns:a="http://schemas.openxmlformats.org/drawingml/2006/main">
+              <a:ext uri="{FF2B5EF4-FFF2-40B4-BE49-F238E27FC236}">
+                <a16:creationId xmlns:a16="http://schemas.microsoft.com/office/drawing/2014/main" id="{0430B415-D1B4-43AA-AF07-9023706B63BA}"/>
+              </a:ext>
+            </a:extLst>
+          </p:cNvPr>
+          <p:cNvSpPr>
+            <a:spLocks xmlns:a="http://schemas.openxmlformats.org/drawingml/2006/main" noGrp="1"/>
+          </p:cNvSpPr>
+          <p:nvPr/>
+        </p:nvSpPr>
+        <p:spPr>
+          <a:xfrm xmlns:a="http://schemas.openxmlformats.org/drawingml/2006/main">
+            <a:off x="7410450" y="2647950"/>
+            <a:ext cx="3714750" cy="990600"/>
+          </a:xfrm>
+          <a:prstGeom xmlns:a="http://schemas.openxmlformats.org/drawingml/2006/main" prst="roundRect">
+            <a:avLst>
+              <a:gd name="adj" fmla="val 11538"/>
+            </a:avLst>
+          </a:prstGeom>
+          <a:solidFill xmlns:a="http://schemas.openxmlformats.org/drawingml/2006/main">
+            <a:srgbClr val="ECFBFC"/>
+          </a:solidFill>
+          <a:ln xmlns:a="http://schemas.openxmlformats.org/drawingml/2006/main" w="9525">
+            <a:solidFill>
+              <a:srgbClr val="A8E7EA"/>
+            </a:solidFill>
+            <a:prstDash val="solid"/>
+          </a:ln>
+        </p:spPr>
+      </p:sp>
+      <p:sp>
+        <p:nvSpPr>
+          <p:cNvPr id="17" name="PPAGENT_QA|within=improvement-item-0|role=title">
+            <a:extLst xmlns:a="http://schemas.openxmlformats.org/drawingml/2006/main">
+              <a:ext uri="{FF2B5EF4-FFF2-40B4-BE49-F238E27FC236}">
+                <a16:creationId xmlns:a16="http://schemas.microsoft.com/office/drawing/2014/main" id="{ACCB4CE6-DA55-4636-827D-A22F1554CEF5}"/>
+              </a:ext>
+            </a:extLst>
+          </p:cNvPr>
+          <p:cNvSpPr>
+            <a:spLocks xmlns:a="http://schemas.openxmlformats.org/drawingml/2006/main" noGrp="1"/>
+          </p:cNvSpPr>
+          <p:nvPr/>
+        </p:nvSpPr>
+        <p:spPr>
+          <a:xfrm xmlns:a="http://schemas.openxmlformats.org/drawingml/2006/main">
+            <a:off x="7562850" y="2762250"/>
+            <a:ext cx="3409950" cy="247650"/>
+          </a:xfrm>
+          <a:prstGeom xmlns:a="http://schemas.openxmlformats.org/drawingml/2006/main" prst="rect">
+            <a:avLst/>
+          </a:prstGeom>
+          <a:noFill xmlns:a="http://schemas.openxmlformats.org/drawingml/2006/main"/>
+          <a:ln xmlns:a="http://schemas.openxmlformats.org/drawingml/2006/main" w="0">
+            <a:noFill/>
+            <a:prstDash val="solid"/>
+          </a:ln>
+        </p:spPr>
+        <p:txBody>
+          <a:bodyPr xmlns:a="http://schemas.openxmlformats.org/drawingml/2006/main" lIns="0" tIns="0" rIns="0" bIns="0" anchor="ctr">
+            <a:normAutofit fontScale="100000"/>
+          </a:bodyPr>
+          <a:lstStyle xmlns:a="http://schemas.openxmlformats.org/drawingml/2006/main"/>
+          <a:p xmlns:a="http://schemas.openxmlformats.org/drawingml/2006/main">
+            <a:pPr algn="l">
+              <a:defRPr sz="1425" b="1">
+                <a:solidFill>
+                  <a:srgbClr val="475569"/>
+                </a:solidFill>
+                <a:latin typeface="Microsoft YaHei"/>
+                <a:ea typeface="Microsoft YaHei"/>
+                <a:cs typeface="Microsoft YaHei"/>
+              </a:defRPr>
+            </a:pPr>
+            <a:r>
+              <a:rPr sz="1425" b="1">
+                <a:solidFill>
+                  <a:srgbClr val="475569"/>
+                </a:solidFill>
+                <a:latin typeface="Microsoft YaHei"/>
+                <a:ea typeface="Microsoft YaHei"/>
+                <a:cs typeface="Microsoft YaHei"/>
+              </a:rPr>
+              <a:t>固定能力边界</a:t>
+            </a:r>
+          </a:p>
+        </p:txBody>
+      </p:sp>
+      <p:sp>
+        <p:nvSpPr>
+          <p:cNvPr id="18" name="PPAGENT_QA|within=improvement-item-0|role=body">
+            <a:extLst xmlns:a="http://schemas.openxmlformats.org/drawingml/2006/main">
+              <a:ext uri="{FF2B5EF4-FFF2-40B4-BE49-F238E27FC236}">
+                <a16:creationId xmlns:a16="http://schemas.microsoft.com/office/drawing/2014/main" id="{A8D65C0F-478A-47AA-A3EC-2715FA4B2427}"/>
+              </a:ext>
+            </a:extLst>
+          </p:cNvPr>
+          <p:cNvSpPr>
+            <a:spLocks xmlns:a="http://schemas.openxmlformats.org/drawingml/2006/main" noGrp="1"/>
+          </p:cNvSpPr>
+          <p:nvPr/>
+        </p:nvSpPr>
+        <p:spPr>
+          <a:xfrm xmlns:a="http://schemas.openxmlformats.org/drawingml/2006/main">
+            <a:off x="7562850" y="3048000"/>
+            <a:ext cx="3409950" cy="514350"/>
+          </a:xfrm>
+          <a:prstGeom xmlns:a="http://schemas.openxmlformats.org/drawingml/2006/main" prst="rect">
+            <a:avLst/>
+          </a:prstGeom>
+          <a:noFill xmlns:a="http://schemas.openxmlformats.org/drawingml/2006/main"/>
+          <a:ln xmlns:a="http://schemas.openxmlformats.org/drawingml/2006/main" w="0">
+            <a:noFill/>
+            <a:prstDash val="solid"/>
+          </a:ln>
+        </p:spPr>
+        <p:txBody>
+          <a:bodyPr xmlns:a="http://schemas.openxmlformats.org/drawingml/2006/main" lIns="0" tIns="0" rIns="0" bIns="0" anchor="t">
+            <a:normAutofit fontScale="100000"/>
+          </a:bodyPr>
+          <a:lstStyle xmlns:a="http://schemas.openxmlformats.org/drawingml/2006/main"/>
+          <a:p xmlns:a="http://schemas.openxmlformats.org/drawingml/2006/main">
+            <a:pPr algn="l">
+              <a:defRPr sz="1350" b="0">
+                <a:solidFill>
+                  <a:srgbClr val="475569"/>
+                </a:solidFill>
+                <a:latin typeface="Microsoft YaHei"/>
+                <a:ea typeface="Microsoft YaHei"/>
+                <a:cs typeface="Microsoft YaHei"/>
+              </a:defRPr>
+            </a:pPr>
+            <a:r>
+              <a:rPr sz="1350" b="0">
+                <a:solidFill>
+                  <a:srgbClr val="475569"/>
+                </a:solidFill>
+                <a:latin typeface="Microsoft YaHei"/>
+                <a:ea typeface="Microsoft YaHei"/>
+                <a:cs typeface="Microsoft YaHei"/>
+              </a:rPr>
+              <a:t>用已登记 Style Group 承担结构表达</a:t>
+            </a:r>
+          </a:p>
+        </p:txBody>
+      </p:sp>
+      <p:sp>
+        <p:nvSpPr>
+          <p:cNvPr id="19" name="PPAGENT_QA|parent=improvement-item-1|domains=improvement-items">
+            <a:extLst xmlns:a="http://schemas.openxmlformats.org/drawingml/2006/main">
+              <a:ext uri="{FF2B5EF4-FFF2-40B4-BE49-F238E27FC236}">
+                <a16:creationId xmlns:a16="http://schemas.microsoft.com/office/drawing/2014/main" id="{E4FEA8F0-E29E-4F5B-8386-79C9FAABA612}"/>
+              </a:ext>
+            </a:extLst>
+          </p:cNvPr>
+          <p:cNvSpPr>
+            <a:spLocks xmlns:a="http://schemas.openxmlformats.org/drawingml/2006/main" noGrp="1"/>
+          </p:cNvSpPr>
+          <p:nvPr/>
+        </p:nvSpPr>
+        <p:spPr>
+          <a:xfrm xmlns:a="http://schemas.openxmlformats.org/drawingml/2006/main">
+            <a:off x="7410450" y="4000500"/>
+            <a:ext cx="3714750" cy="990600"/>
+          </a:xfrm>
+          <a:prstGeom xmlns:a="http://schemas.openxmlformats.org/drawingml/2006/main" prst="roundRect">
+            <a:avLst>
+              <a:gd name="adj" fmla="val 11538"/>
+            </a:avLst>
+          </a:prstGeom>
+          <a:solidFill xmlns:a="http://schemas.openxmlformats.org/drawingml/2006/main">
+            <a:srgbClr val="ECFBFC"/>
+          </a:solidFill>
+          <a:ln xmlns:a="http://schemas.openxmlformats.org/drawingml/2006/main" w="9525">
+            <a:solidFill>
+              <a:srgbClr val="A8E7EA"/>
+            </a:solidFill>
+            <a:prstDash val="solid"/>
+          </a:ln>
+        </p:spPr>
+      </p:sp>
+      <p:sp>
+        <p:nvSpPr>
+          <p:cNvPr id="20" name="PPAGENT_QA|within=improvement-item-1|role=title">
+            <a:extLst xmlns:a="http://schemas.openxmlformats.org/drawingml/2006/main">
+              <a:ext uri="{FF2B5EF4-FFF2-40B4-BE49-F238E27FC236}">
+                <a16:creationId xmlns:a16="http://schemas.microsoft.com/office/drawing/2014/main" id="{4A0FAF51-F442-4F1E-B4C7-BDBC80DBE932}"/>
+              </a:ext>
+            </a:extLst>
+          </p:cNvPr>
+          <p:cNvSpPr>
+            <a:spLocks xmlns:a="http://schemas.openxmlformats.org/drawingml/2006/main" noGrp="1"/>
+          </p:cNvSpPr>
+          <p:nvPr/>
+        </p:nvSpPr>
+        <p:spPr>
+          <a:xfrm xmlns:a="http://schemas.openxmlformats.org/drawingml/2006/main">
+            <a:off x="7562850" y="4114800"/>
+            <a:ext cx="3409950" cy="247650"/>
+          </a:xfrm>
+          <a:prstGeom xmlns:a="http://schemas.openxmlformats.org/drawingml/2006/main" prst="rect">
+            <a:avLst/>
+          </a:prstGeom>
+          <a:noFill xmlns:a="http://schemas.openxmlformats.org/drawingml/2006/main"/>
+          <a:ln xmlns:a="http://schemas.openxmlformats.org/drawingml/2006/main" w="0">
+            <a:noFill/>
+            <a:prstDash val="solid"/>
+          </a:ln>
+        </p:spPr>
+        <p:txBody>
+          <a:bodyPr xmlns:a="http://schemas.openxmlformats.org/drawingml/2006/main" lIns="0" tIns="0" rIns="0" bIns="0" anchor="ctr">
+            <a:normAutofit fontScale="100000"/>
+          </a:bodyPr>
+          <a:lstStyle xmlns:a="http://schemas.openxmlformats.org/drawingml/2006/main"/>
+          <a:p xmlns:a="http://schemas.openxmlformats.org/drawingml/2006/main">
+            <a:pPr algn="l">
+              <a:defRPr sz="1425" b="1">
+                <a:solidFill>
+                  <a:srgbClr val="475569"/>
+                </a:solidFill>
+                <a:latin typeface="Microsoft YaHei"/>
+                <a:ea typeface="Microsoft YaHei"/>
+                <a:cs typeface="Microsoft YaHei"/>
+              </a:defRPr>
+            </a:pPr>
+            <a:r>
+              <a:rPr sz="1425" b="1">
+                <a:solidFill>
+                  <a:srgbClr val="475569"/>
+                </a:solidFill>
+                <a:latin typeface="Microsoft YaHei"/>
+                <a:ea typeface="Microsoft YaHei"/>
+                <a:cs typeface="Microsoft YaHei"/>
+              </a:rPr>
+              <a:t>统一参数接口</a:t>
+            </a:r>
+          </a:p>
+        </p:txBody>
+      </p:sp>
+      <p:sp>
+        <p:nvSpPr>
+          <p:cNvPr id="21" name="PPAGENT_QA|within=improvement-item-1|role=body">
+            <a:extLst xmlns:a="http://schemas.openxmlformats.org/drawingml/2006/main">
+              <a:ext uri="{FF2B5EF4-FFF2-40B4-BE49-F238E27FC236}">
+                <a16:creationId xmlns:a16="http://schemas.microsoft.com/office/drawing/2014/main" id="{41197812-57B9-40C5-93EE-E4BB9FBB90F2}"/>
+              </a:ext>
+            </a:extLst>
+          </p:cNvPr>
+          <p:cNvSpPr>
+            <a:spLocks xmlns:a="http://schemas.openxmlformats.org/drawingml/2006/main" noGrp="1"/>
+          </p:cNvSpPr>
+          <p:nvPr/>
+        </p:nvSpPr>
+        <p:spPr>
+          <a:xfrm xmlns:a="http://schemas.openxmlformats.org/drawingml/2006/main">
+            <a:off x="7562850" y="4400550"/>
+            <a:ext cx="3409950" cy="514350"/>
+          </a:xfrm>
+          <a:prstGeom xmlns:a="http://schemas.openxmlformats.org/drawingml/2006/main" prst="rect">
+            <a:avLst/>
+          </a:prstGeom>
+          <a:noFill xmlns:a="http://schemas.openxmlformats.org/drawingml/2006/main"/>
+          <a:ln xmlns:a="http://schemas.openxmlformats.org/drawingml/2006/main" w="0">
+            <a:noFill/>
+            <a:prstDash val="solid"/>
+          </a:ln>
+        </p:spPr>
+        <p:txBody>
+          <a:bodyPr xmlns:a="http://schemas.openxmlformats.org/drawingml/2006/main" lIns="0" tIns="0" rIns="0" bIns="0" anchor="t">
+            <a:normAutofit fontScale="100000"/>
+          </a:bodyPr>
+          <a:lstStyle xmlns:a="http://schemas.openxmlformats.org/drawingml/2006/main"/>
+          <a:p xmlns:a="http://schemas.openxmlformats.org/drawingml/2006/main">
+            <a:pPr algn="l">
+              <a:defRPr sz="1350" b="0">
+                <a:solidFill>
+                  <a:srgbClr val="475569"/>
+                </a:solidFill>
+                <a:latin typeface="Microsoft YaHei"/>
+                <a:ea typeface="Microsoft YaHei"/>
+                <a:cs typeface="Microsoft YaHei"/>
+              </a:defRPr>
+            </a:pPr>
+            <a:r>
+              <a:rPr sz="1350" b="0">
+                <a:solidFill>
+                  <a:srgbClr val="475569"/>
+                </a:solidFill>
+                <a:latin typeface="Microsoft YaHei"/>
+                <a:ea typeface="Microsoft YaHei"/>
+                <a:cs typeface="Microsoft YaHei"/>
+              </a:rPr>
+              <a:t>让 HTML 与 Builder 使用同一输入</a:t>
+            </a:r>
+          </a:p>
+        </p:txBody>
+      </p:sp>
+      <p:sp>
+        <p:nvSpPr>
+          <p:cNvPr id="22" name="">
+            <a:extLst xmlns:a="http://schemas.openxmlformats.org/drawingml/2006/main">
+              <a:ext uri="{FF2B5EF4-FFF2-40B4-BE49-F238E27FC236}">
+                <a16:creationId xmlns:a16="http://schemas.microsoft.com/office/drawing/2014/main" id="{93ED6098-60A1-4C19-9E21-131BBEA9CFBF}"/>
+              </a:ext>
+            </a:extLst>
+          </p:cNvPr>
+          <p:cNvSpPr>
+            <a:spLocks xmlns:a="http://schemas.openxmlformats.org/drawingml/2006/main" noGrp="1"/>
+          </p:cNvSpPr>
+          <p:nvPr/>
+        </p:nvSpPr>
+        <p:spPr>
+          <a:xfrm xmlns:a="http://schemas.openxmlformats.org/drawingml/2006/main">
+            <a:off x="5543550" y="3124200"/>
+            <a:ext cx="1104900" cy="1104900"/>
+          </a:xfrm>
+          <a:prstGeom xmlns:a="http://schemas.openxmlformats.org/drawingml/2006/main" prst="rightArrow">
+            <a:avLst/>
+          </a:prstGeom>
+          <a:solidFill xmlns:a="http://schemas.openxmlformats.org/drawingml/2006/main">
+            <a:srgbClr val="14CBD1"/>
+          </a:solidFill>
+          <a:ln xmlns:a="http://schemas.openxmlformats.org/drawingml/2006/main" w="0">
+            <a:noFill/>
+            <a:prstDash val="solid"/>
+          </a:ln>
+        </p:spPr>
+        <p:style>
+          <a:lnRef xmlns:a="http://schemas.openxmlformats.org/drawingml/2006/main" idx="0"/>
+          <a:fillRef xmlns:a="http://schemas.openxmlformats.org/drawingml/2006/main" idx="0"/>
+          <a:effectRef xmlns:a="http://schemas.openxmlformats.org/drawingml/2006/main" idx="6"/>
+          <a:fontRef xmlns:a="http://schemas.openxmlformats.org/drawingml/2006/main" idx="major"/>
+        </p:style>
+      </p:sp>
+    </p:spTree>
+    <p:extLst>
+      <p:ext uri="{BB962C8B-B14F-4D97-AF65-F5344CB8AC3E}">
+        <p14:creationId xmlns:p14="http://schemas.microsoft.com/office/powerpoint/2010/main" val="1949774819"/>
+      </p:ext>
+    </p:extLst>
+  </p:cSld>
+</p:sld>
+</file>
+
+<file path=ppt/slides/slide4.xml><?xml version="1.0" encoding="utf-8"?>
+<p:sld xmlns:p="http://schemas.openxmlformats.org/presentationml/2006/main">
+  <p:cSld>
+    <p:bg>
+      <p:bgPr>
+        <a:solidFill xmlns:a="http://schemas.openxmlformats.org/drawingml/2006/main">
+          <a:srgbClr val="F7FAFC"/>
+        </a:solidFill>
+      </p:bgPr>
+    </p:bg>
+    <p:spTree>
+      <p:nvGrpSpPr>
+        <p:cNvPr id="1" name=""/>
+        <p:cNvGrpSpPr/>
+        <p:nvPr/>
+      </p:nvGrpSpPr>
+      <p:grpSpPr>
+        <a:xfrm xmlns:a="http://schemas.openxmlformats.org/drawingml/2006/main"/>
+      </p:grpSpPr>
+      <p:sp>
+        <p:nvSpPr>
+          <p:cNvPr id="26" name="">
+            <a:extLst xmlns:a="http://schemas.openxmlformats.org/drawingml/2006/main">
+              <a:ext uri="{FF2B5EF4-FFF2-40B4-BE49-F238E27FC236}">
+                <a16:creationId xmlns:a16="http://schemas.microsoft.com/office/drawing/2014/main" id="{6DEAC982-EB47-4EA3-B54C-B6C4F5A65198}"/>
+              </a:ext>
+            </a:extLst>
+          </p:cNvPr>
+          <p:cNvSpPr>
+            <a:spLocks xmlns:a="http://schemas.openxmlformats.org/drawingml/2006/main" noGrp="1"/>
+          </p:cNvSpPr>
+          <p:nvPr/>
+        </p:nvSpPr>
+        <p:spPr>
+          <a:xfrm xmlns:a="http://schemas.openxmlformats.org/drawingml/2006/main">
+            <a:off x="685800" y="400050"/>
+            <a:ext cx="8382000" cy="457200"/>
+          </a:xfrm>
+          <a:prstGeom xmlns:a="http://schemas.openxmlformats.org/drawingml/2006/main" prst="rect">
+            <a:avLst/>
+          </a:prstGeom>
+          <a:noFill xmlns:a="http://schemas.openxmlformats.org/drawingml/2006/main"/>
+          <a:ln xmlns:a="http://schemas.openxmlformats.org/drawingml/2006/main" w="0">
+            <a:noFill/>
+            <a:prstDash val="solid"/>
+          </a:ln>
+        </p:spPr>
+        <p:txBody>
+          <a:bodyPr xmlns:a="http://schemas.openxmlformats.org/drawingml/2006/main" lIns="0" tIns="0" rIns="0" bIns="0" anchor="ctr">
+            <a:normAutofit fontScale="100000"/>
+          </a:bodyPr>
+          <a:lstStyle xmlns:a="http://schemas.openxmlformats.org/drawingml/2006/main"/>
+          <a:p xmlns:a="http://schemas.openxmlformats.org/drawingml/2006/main">
+            <a:pPr algn="l">
+              <a:defRPr sz="2700" b="1">
+                <a:solidFill>
+                  <a:srgbClr val="1677C8"/>
+                </a:solidFill>
+                <a:latin typeface="Microsoft YaHei"/>
+                <a:ea typeface="Microsoft YaHei"/>
+                <a:cs typeface="Microsoft YaHei"/>
+              </a:defRPr>
+            </a:pPr>
+            <a:r>
+              <a:rPr sz="2700" b="1">
+                <a:solidFill>
+                  <a:srgbClr val="1677C8"/>
+                </a:solidFill>
+                <a:latin typeface="Microsoft YaHei"/>
+                <a:ea typeface="Microsoft YaHei"/>
+                <a:cs typeface="Microsoft YaHei"/>
+              </a:rPr>
+              <a:t>问题与改进措施</a:t>
+            </a:r>
+          </a:p>
+        </p:txBody>
+      </p:sp>
+      <p:sp>
+        <p:nvSpPr>
+          <p:cNvPr id="2" name="">
+            <a:extLst xmlns:a="http://schemas.openxmlformats.org/drawingml/2006/main">
+              <a:ext uri="{FF2B5EF4-FFF2-40B4-BE49-F238E27FC236}">
+                <a16:creationId xmlns:a16="http://schemas.microsoft.com/office/drawing/2014/main" id="{499310E5-83FC-45BB-B7A5-7A1A05A43BAE}"/>
+              </a:ext>
+            </a:extLst>
+          </p:cNvPr>
+          <p:cNvSpPr>
+            <a:spLocks xmlns:a="http://schemas.openxmlformats.org/drawingml/2006/main" noGrp="1"/>
+          </p:cNvSpPr>
+          <p:nvPr/>
+        </p:nvSpPr>
+        <p:spPr>
+          <a:xfrm xmlns:a="http://schemas.openxmlformats.org/drawingml/2006/main">
+            <a:off x="704850" y="876300"/>
+            <a:ext cx="4953000" cy="247650"/>
+          </a:xfrm>
+          <a:prstGeom xmlns:a="http://schemas.openxmlformats.org/drawingml/2006/main" prst="rect">
+            <a:avLst/>
+          </a:prstGeom>
+          <a:noFill xmlns:a="http://schemas.openxmlformats.org/drawingml/2006/main"/>
+          <a:ln xmlns:a="http://schemas.openxmlformats.org/drawingml/2006/main" w="0">
+            <a:noFill/>
+            <a:prstDash val="solid"/>
+          </a:ln>
+        </p:spPr>
+        <p:txBody>
+          <a:bodyPr xmlns:a="http://schemas.openxmlformats.org/drawingml/2006/main" lIns="0" tIns="0" rIns="0" bIns="0" anchor="ctr">
+            <a:normAutofit fontScale="100000"/>
+          </a:bodyPr>
+          <a:lstStyle xmlns:a="http://schemas.openxmlformats.org/drawingml/2006/main"/>
+          <a:p xmlns:a="http://schemas.openxmlformats.org/drawingml/2006/main">
+            <a:pPr algn="l">
+              <a:defRPr sz="1200" b="0">
+                <a:solidFill>
+                  <a:srgbClr val="7C8A9A"/>
+                </a:solidFill>
+                <a:latin typeface="Microsoft YaHei"/>
+                <a:ea typeface="Microsoft YaHei"/>
+                <a:cs typeface="Microsoft YaHei"/>
+              </a:defRPr>
+            </a:pPr>
+            <a:r>
+              <a:rPr sz="1200" b="0">
+                <a:solidFill>
+                  <a:srgbClr val="7C8A9A"/>
+                </a:solidFill>
+                <a:latin typeface="Microsoft YaHei"/>
+                <a:ea typeface="Microsoft YaHei"/>
+                <a:cs typeface="Microsoft YaHei"/>
+              </a:rPr>
+              <a:t>问题—改进</a:t>
+            </a:r>
+          </a:p>
+        </p:txBody>
+      </p:sp>
+      <p:sp>
+        <p:nvSpPr>
+          <p:cNvPr id="3" name="">
+            <a:extLst xmlns:a="http://schemas.openxmlformats.org/drawingml/2006/main">
+              <a:ext uri="{FF2B5EF4-FFF2-40B4-BE49-F238E27FC236}">
+                <a16:creationId xmlns:a16="http://schemas.microsoft.com/office/drawing/2014/main" id="{8887BC47-4B63-4567-A08E-DF456F822D8D}"/>
+              </a:ext>
+            </a:extLst>
+          </p:cNvPr>
+          <p:cNvSpPr>
+            <a:spLocks xmlns:a="http://schemas.openxmlformats.org/drawingml/2006/main" noGrp="1"/>
+          </p:cNvSpPr>
+          <p:nvPr/>
+        </p:nvSpPr>
+        <p:spPr>
+          <a:xfrm xmlns:a="http://schemas.openxmlformats.org/drawingml/2006/main">
+            <a:off x="685800" y="1428750"/>
+            <a:ext cx="4476750" cy="4572000"/>
+          </a:xfrm>
+          <a:prstGeom xmlns:a="http://schemas.openxmlformats.org/drawingml/2006/main" prst="roundRect">
+            <a:avLst>
+              <a:gd name="adj" fmla="val 2553"/>
+            </a:avLst>
+          </a:prstGeom>
+          <a:solidFill xmlns:a="http://schemas.openxmlformats.org/drawingml/2006/main">
+            <a:srgbClr val="FFFFFF"/>
+          </a:solidFill>
+          <a:ln xmlns:a="http://schemas.openxmlformats.org/drawingml/2006/main" w="19050">
+            <a:solidFill>
+              <a:srgbClr val="1677C8"/>
+            </a:solidFill>
+            <a:prstDash val="solid"/>
+          </a:ln>
+        </p:spPr>
+        <p:style>
+          <a:lnRef xmlns:a="http://schemas.openxmlformats.org/drawingml/2006/main" idx="0"/>
+          <a:fillRef xmlns:a="http://schemas.openxmlformats.org/drawingml/2006/main" idx="0"/>
+          <a:effectRef xmlns:a="http://schemas.openxmlformats.org/drawingml/2006/main" idx="4"/>
+          <a:fontRef xmlns:a="http://schemas.openxmlformats.org/drawingml/2006/main" idx="major"/>
+        </p:style>
+      </p:sp>
+      <p:sp>
+        <p:nvSpPr>
+          <p:cNvPr id="4" name="">
+            <a:extLst xmlns:a="http://schemas.openxmlformats.org/drawingml/2006/main">
+              <a:ext uri="{FF2B5EF4-FFF2-40B4-BE49-F238E27FC236}">
+                <a16:creationId xmlns:a16="http://schemas.microsoft.com/office/drawing/2014/main" id="{A4518CC9-3F2E-4A72-BFC1-FFB452C19722}"/>
+              </a:ext>
+            </a:extLst>
+          </p:cNvPr>
+          <p:cNvSpPr>
+            <a:spLocks xmlns:a="http://schemas.openxmlformats.org/drawingml/2006/main" noGrp="1"/>
+          </p:cNvSpPr>
+          <p:nvPr/>
+        </p:nvSpPr>
+        <p:spPr>
+          <a:xfrm xmlns:a="http://schemas.openxmlformats.org/drawingml/2006/main">
+            <a:off x="7029450" y="1428750"/>
+            <a:ext cx="4476750" cy="4572000"/>
+          </a:xfrm>
+          <a:prstGeom xmlns:a="http://schemas.openxmlformats.org/drawingml/2006/main" prst="roundRect">
+            <a:avLst>
+              <a:gd name="adj" fmla="val 2553"/>
+            </a:avLst>
+          </a:prstGeom>
+          <a:solidFill xmlns:a="http://schemas.openxmlformats.org/drawingml/2006/main">
+            <a:srgbClr val="FFFFFF"/>
+          </a:solidFill>
+          <a:ln xmlns:a="http://schemas.openxmlformats.org/drawingml/2006/main" w="19050">
+            <a:solidFill>
+              <a:srgbClr val="00A8D8"/>
+            </a:solidFill>
+            <a:prstDash val="solid"/>
+          </a:ln>
+        </p:spPr>
+        <p:style>
+          <a:lnRef xmlns:a="http://schemas.openxmlformats.org/drawingml/2006/main" idx="0"/>
+          <a:fillRef xmlns:a="http://schemas.openxmlformats.org/drawingml/2006/main" idx="0"/>
+          <a:effectRef xmlns:a="http://schemas.openxmlformats.org/drawingml/2006/main" idx="4"/>
+          <a:fontRef xmlns:a="http://schemas.openxmlformats.org/drawingml/2006/main" idx="major"/>
+        </p:style>
+      </p:sp>
+      <p:sp>
+        <p:nvSpPr>
+          <p:cNvPr id="5" name="">
+            <a:extLst xmlns:a="http://schemas.openxmlformats.org/drawingml/2006/main">
+              <a:ext uri="{FF2B5EF4-FFF2-40B4-BE49-F238E27FC236}">
+                <a16:creationId xmlns:a16="http://schemas.microsoft.com/office/drawing/2014/main" id="{D8D7E17D-17C1-4B8A-B66C-99886B798F78}"/>
+              </a:ext>
+            </a:extLst>
+          </p:cNvPr>
+          <p:cNvSpPr>
+            <a:spLocks xmlns:a="http://schemas.openxmlformats.org/drawingml/2006/main" noGrp="1"/>
+          </p:cNvSpPr>
+          <p:nvPr/>
+        </p:nvSpPr>
+        <p:spPr>
+          <a:xfrm xmlns:a="http://schemas.openxmlformats.org/drawingml/2006/main">
+            <a:off x="971550" y="1695450"/>
+            <a:ext cx="3905250" cy="419100"/>
+          </a:xfrm>
+          <a:prstGeom xmlns:a="http://schemas.openxmlformats.org/drawingml/2006/main" prst="rect">
+            <a:avLst/>
+          </a:prstGeom>
+          <a:noFill xmlns:a="http://schemas.openxmlformats.org/drawingml/2006/main"/>
+          <a:ln xmlns:a="http://schemas.openxmlformats.org/drawingml/2006/main" w="0">
+            <a:noFill/>
+            <a:prstDash val="solid"/>
+          </a:ln>
+        </p:spPr>
+        <p:txBody>
+          <a:bodyPr xmlns:a="http://schemas.openxmlformats.org/drawingml/2006/main" lIns="0" tIns="0" rIns="0" bIns="0" anchor="ctr">
+            <a:normAutofit fontScale="100000"/>
+          </a:bodyPr>
+          <a:lstStyle xmlns:a="http://schemas.openxmlformats.org/drawingml/2006/main"/>
+          <a:p xmlns:a="http://schemas.openxmlformats.org/drawingml/2006/main">
+            <a:pPr algn="ctr">
+              <a:defRPr sz="1950" b="1">
+                <a:solidFill>
+                  <a:srgbClr val="1677C8"/>
+                </a:solidFill>
+                <a:latin typeface="Microsoft YaHei"/>
+                <a:ea typeface="Microsoft YaHei"/>
+                <a:cs typeface="Microsoft YaHei"/>
+              </a:defRPr>
+            </a:pPr>
+            <a:r>
+              <a:rPr sz="1950" b="1">
+                <a:solidFill>
+                  <a:srgbClr val="1677C8"/>
+                </a:solidFill>
+                <a:latin typeface="Microsoft YaHei"/>
+                <a:ea typeface="Microsoft YaHei"/>
+                <a:cs typeface="Microsoft YaHei"/>
+              </a:rPr>
+              <a:t>现状与缺口</a:t>
+            </a:r>
+          </a:p>
+        </p:txBody>
+      </p:sp>
+      <p:sp>
+        <p:nvSpPr>
+          <p:cNvPr id="6" name="">
+            <a:extLst xmlns:a="http://schemas.openxmlformats.org/drawingml/2006/main">
+              <a:ext uri="{FF2B5EF4-FFF2-40B4-BE49-F238E27FC236}">
+                <a16:creationId xmlns:a16="http://schemas.microsoft.com/office/drawing/2014/main" id="{B2803054-3D58-47AD-AFC7-3118E0215046}"/>
+              </a:ext>
+            </a:extLst>
+          </p:cNvPr>
+          <p:cNvSpPr>
+            <a:spLocks xmlns:a="http://schemas.openxmlformats.org/drawingml/2006/main" noGrp="1"/>
+          </p:cNvSpPr>
+          <p:nvPr/>
+        </p:nvSpPr>
+        <p:spPr>
+          <a:xfrm xmlns:a="http://schemas.openxmlformats.org/drawingml/2006/main">
+            <a:off x="7315200" y="1695450"/>
+            <a:ext cx="3905250" cy="419100"/>
+          </a:xfrm>
+          <a:prstGeom xmlns:a="http://schemas.openxmlformats.org/drawingml/2006/main" prst="rect">
+            <a:avLst/>
+          </a:prstGeom>
+          <a:noFill xmlns:a="http://schemas.openxmlformats.org/drawingml/2006/main"/>
+          <a:ln xmlns:a="http://schemas.openxmlformats.org/drawingml/2006/main" w="0">
+            <a:noFill/>
+            <a:prstDash val="solid"/>
+          </a:ln>
+        </p:spPr>
+        <p:txBody>
+          <a:bodyPr xmlns:a="http://schemas.openxmlformats.org/drawingml/2006/main" lIns="0" tIns="0" rIns="0" bIns="0" anchor="ctr">
+            <a:normAutofit fontScale="100000"/>
+          </a:bodyPr>
+          <a:lstStyle xmlns:a="http://schemas.openxmlformats.org/drawingml/2006/main"/>
+          <a:p xmlns:a="http://schemas.openxmlformats.org/drawingml/2006/main">
+            <a:pPr algn="ctr">
+              <a:defRPr sz="1950" b="1">
+                <a:solidFill>
+                  <a:srgbClr val="00A8D8"/>
+                </a:solidFill>
+                <a:latin typeface="Microsoft YaHei"/>
+                <a:ea typeface="Microsoft YaHei"/>
+                <a:cs typeface="Microsoft YaHei"/>
+              </a:defRPr>
+            </a:pPr>
+            <a:r>
+              <a:rPr sz="1950" b="1">
+                <a:solidFill>
+                  <a:srgbClr val="00A8D8"/>
+                </a:solidFill>
+                <a:latin typeface="Microsoft YaHei"/>
+                <a:ea typeface="Microsoft YaHei"/>
+                <a:cs typeface="Microsoft YaHei"/>
+              </a:rPr>
+              <a:t>系统介入与结果</a:t>
+            </a:r>
+          </a:p>
+        </p:txBody>
+      </p:sp>
+      <p:sp>
+        <p:nvSpPr>
+          <p:cNvPr id="7" name="PPAGENT_QA|parent=problem-item-0|domains=problem-items">
+            <a:extLst xmlns:a="http://schemas.openxmlformats.org/drawingml/2006/main">
+              <a:ext uri="{FF2B5EF4-FFF2-40B4-BE49-F238E27FC236}">
+                <a16:creationId xmlns:a16="http://schemas.microsoft.com/office/drawing/2014/main" id="{BEFBC8DF-087D-45BB-A26B-2FF490079E33}"/>
+              </a:ext>
+            </a:extLst>
+          </p:cNvPr>
+          <p:cNvSpPr>
+            <a:spLocks xmlns:a="http://schemas.openxmlformats.org/drawingml/2006/main" noGrp="1"/>
+          </p:cNvSpPr>
+          <p:nvPr/>
+        </p:nvSpPr>
+        <p:spPr>
+          <a:xfrm xmlns:a="http://schemas.openxmlformats.org/drawingml/2006/main">
+            <a:off x="1066800" y="2343150"/>
+            <a:ext cx="3714750" cy="819150"/>
+          </a:xfrm>
+          <a:prstGeom xmlns:a="http://schemas.openxmlformats.org/drawingml/2006/main" prst="roundRect">
+            <a:avLst>
+              <a:gd name="adj" fmla="val 13953"/>
+            </a:avLst>
+          </a:prstGeom>
+          <a:solidFill xmlns:a="http://schemas.openxmlformats.org/drawingml/2006/main">
+            <a:srgbClr val="F1F7FB"/>
+          </a:solidFill>
+          <a:ln xmlns:a="http://schemas.openxmlformats.org/drawingml/2006/main" w="9525">
+            <a:solidFill>
+              <a:srgbClr val="C9D5E3"/>
+            </a:solidFill>
+            <a:prstDash val="solid"/>
+          </a:ln>
+        </p:spPr>
+      </p:sp>
+      <p:sp>
+        <p:nvSpPr>
+          <p:cNvPr id="8" name="PPAGENT_QA|within=problem-item-0|role=title">
+            <a:extLst xmlns:a="http://schemas.openxmlformats.org/drawingml/2006/main">
+              <a:ext uri="{FF2B5EF4-FFF2-40B4-BE49-F238E27FC236}">
+                <a16:creationId xmlns:a16="http://schemas.microsoft.com/office/drawing/2014/main" id="{425942CC-90A1-46DE-B09B-2643012E6B47}"/>
+              </a:ext>
+            </a:extLst>
+          </p:cNvPr>
+          <p:cNvSpPr>
+            <a:spLocks xmlns:a="http://schemas.openxmlformats.org/drawingml/2006/main" noGrp="1"/>
+          </p:cNvSpPr>
+          <p:nvPr/>
+        </p:nvSpPr>
+        <p:spPr>
+          <a:xfrm xmlns:a="http://schemas.openxmlformats.org/drawingml/2006/main">
+            <a:off x="1219200" y="2457450"/>
+            <a:ext cx="3409950" cy="247650"/>
+          </a:xfrm>
+          <a:prstGeom xmlns:a="http://schemas.openxmlformats.org/drawingml/2006/main" prst="rect">
+            <a:avLst/>
+          </a:prstGeom>
+          <a:noFill xmlns:a="http://schemas.openxmlformats.org/drawingml/2006/main"/>
+          <a:ln xmlns:a="http://schemas.openxmlformats.org/drawingml/2006/main" w="0">
+            <a:noFill/>
+            <a:prstDash val="solid"/>
+          </a:ln>
+        </p:spPr>
+        <p:txBody>
+          <a:bodyPr xmlns:a="http://schemas.openxmlformats.org/drawingml/2006/main" lIns="0" tIns="0" rIns="0" bIns="0" anchor="ctr">
+            <a:normAutofit fontScale="100000"/>
+          </a:bodyPr>
+          <a:lstStyle xmlns:a="http://schemas.openxmlformats.org/drawingml/2006/main"/>
+          <a:p xmlns:a="http://schemas.openxmlformats.org/drawingml/2006/main">
+            <a:pPr algn="l">
+              <a:defRPr sz="1425" b="1">
+                <a:solidFill>
+                  <a:srgbClr val="475569"/>
+                </a:solidFill>
+                <a:latin typeface="Microsoft YaHei"/>
+                <a:ea typeface="Microsoft YaHei"/>
+                <a:cs typeface="Microsoft YaHei"/>
+              </a:defRPr>
+            </a:pPr>
+            <a:r>
+              <a:rPr sz="1425" b="1">
+                <a:solidFill>
+                  <a:srgbClr val="475569"/>
+                </a:solidFill>
+                <a:latin typeface="Microsoft YaHei"/>
+                <a:ea typeface="Microsoft YaHei"/>
+                <a:cs typeface="Microsoft YaHei"/>
+              </a:rPr>
+              <a:t>结果不稳定</a:t>
+            </a:r>
+          </a:p>
+        </p:txBody>
+      </p:sp>
+      <p:sp>
+        <p:nvSpPr>
+          <p:cNvPr id="9" name="PPAGENT_QA|within=problem-item-0|role=body">
+            <a:extLst xmlns:a="http://schemas.openxmlformats.org/drawingml/2006/main">
+              <a:ext uri="{FF2B5EF4-FFF2-40B4-BE49-F238E27FC236}">
+                <a16:creationId xmlns:a16="http://schemas.microsoft.com/office/drawing/2014/main" id="{78976D04-8581-4E12-BE04-8D56BDF288BC}"/>
+              </a:ext>
+            </a:extLst>
+          </p:cNvPr>
+          <p:cNvSpPr>
+            <a:spLocks xmlns:a="http://schemas.openxmlformats.org/drawingml/2006/main" noGrp="1"/>
+          </p:cNvSpPr>
+          <p:nvPr/>
+        </p:nvSpPr>
+        <p:spPr>
+          <a:xfrm xmlns:a="http://schemas.openxmlformats.org/drawingml/2006/main">
+            <a:off x="1219200" y="2743200"/>
+            <a:ext cx="3409950" cy="342900"/>
+          </a:xfrm>
+          <a:prstGeom xmlns:a="http://schemas.openxmlformats.org/drawingml/2006/main" prst="rect">
+            <a:avLst/>
+          </a:prstGeom>
+          <a:noFill xmlns:a="http://schemas.openxmlformats.org/drawingml/2006/main"/>
+          <a:ln xmlns:a="http://schemas.openxmlformats.org/drawingml/2006/main" w="0">
+            <a:noFill/>
+            <a:prstDash val="solid"/>
+          </a:ln>
+        </p:spPr>
+        <p:txBody>
+          <a:bodyPr xmlns:a="http://schemas.openxmlformats.org/drawingml/2006/main" lIns="0" tIns="0" rIns="0" bIns="0" anchor="t">
+            <a:normAutofit fontScale="100000"/>
+          </a:bodyPr>
+          <a:lstStyle xmlns:a="http://schemas.openxmlformats.org/drawingml/2006/main"/>
+          <a:p xmlns:a="http://schemas.openxmlformats.org/drawingml/2006/main">
+            <a:pPr algn="l">
+              <a:defRPr sz="1350" b="0">
+                <a:solidFill>
+                  <a:srgbClr val="475569"/>
+                </a:solidFill>
+                <a:latin typeface="Microsoft YaHei"/>
+                <a:ea typeface="Microsoft YaHei"/>
+                <a:cs typeface="Microsoft YaHei"/>
+              </a:defRPr>
+            </a:pPr>
+            <a:r>
+              <a:rPr sz="1350" b="0">
+                <a:solidFill>
+                  <a:srgbClr val="475569"/>
+                </a:solidFill>
+                <a:latin typeface="Microsoft YaHei"/>
+                <a:ea typeface="Microsoft YaHei"/>
+                <a:cs typeface="Microsoft YaHei"/>
+              </a:rPr>
+              <a:t>相同输入仍可能得到差异较大的页面</a:t>
+            </a:r>
+          </a:p>
+        </p:txBody>
+      </p:sp>
+      <p:sp>
+        <p:nvSpPr>
+          <p:cNvPr id="10" name="PPAGENT_QA|parent=problem-item-1|domains=problem-items">
+            <a:extLst xmlns:a="http://schemas.openxmlformats.org/drawingml/2006/main">
+              <a:ext uri="{FF2B5EF4-FFF2-40B4-BE49-F238E27FC236}">
+                <a16:creationId xmlns:a16="http://schemas.microsoft.com/office/drawing/2014/main" id="{02C84EF0-A691-408E-A714-CB6C97A788A7}"/>
+              </a:ext>
+            </a:extLst>
+          </p:cNvPr>
+          <p:cNvSpPr>
+            <a:spLocks xmlns:a="http://schemas.openxmlformats.org/drawingml/2006/main" noGrp="1"/>
+          </p:cNvSpPr>
+          <p:nvPr/>
+        </p:nvSpPr>
+        <p:spPr>
+          <a:xfrm xmlns:a="http://schemas.openxmlformats.org/drawingml/2006/main">
+            <a:off x="1066800" y="3409950"/>
+            <a:ext cx="3714750" cy="819150"/>
+          </a:xfrm>
+          <a:prstGeom xmlns:a="http://schemas.openxmlformats.org/drawingml/2006/main" prst="roundRect">
+            <a:avLst>
+              <a:gd name="adj" fmla="val 13953"/>
+            </a:avLst>
+          </a:prstGeom>
+          <a:solidFill xmlns:a="http://schemas.openxmlformats.org/drawingml/2006/main">
+            <a:srgbClr val="F1F7FB"/>
+          </a:solidFill>
+          <a:ln xmlns:a="http://schemas.openxmlformats.org/drawingml/2006/main" w="9525">
+            <a:solidFill>
+              <a:srgbClr val="C9D5E3"/>
+            </a:solidFill>
+            <a:prstDash val="solid"/>
+          </a:ln>
+        </p:spPr>
+      </p:sp>
+      <p:sp>
+        <p:nvSpPr>
+          <p:cNvPr id="11" name="PPAGENT_QA|within=problem-item-1|role=title">
+            <a:extLst xmlns:a="http://schemas.openxmlformats.org/drawingml/2006/main">
+              <a:ext uri="{FF2B5EF4-FFF2-40B4-BE49-F238E27FC236}">
+                <a16:creationId xmlns:a16="http://schemas.microsoft.com/office/drawing/2014/main" id="{69463D71-2F6B-43E7-B44F-59DA6E888F3E}"/>
+              </a:ext>
+            </a:extLst>
+          </p:cNvPr>
+          <p:cNvSpPr>
+            <a:spLocks xmlns:a="http://schemas.openxmlformats.org/drawingml/2006/main" noGrp="1"/>
+          </p:cNvSpPr>
+          <p:nvPr/>
+        </p:nvSpPr>
+        <p:spPr>
+          <a:xfrm xmlns:a="http://schemas.openxmlformats.org/drawingml/2006/main">
+            <a:off x="1219200" y="3524250"/>
+            <a:ext cx="3409950" cy="247650"/>
+          </a:xfrm>
+          <a:prstGeom xmlns:a="http://schemas.openxmlformats.org/drawingml/2006/main" prst="rect">
+            <a:avLst/>
+          </a:prstGeom>
+          <a:noFill xmlns:a="http://schemas.openxmlformats.org/drawingml/2006/main"/>
+          <a:ln xmlns:a="http://schemas.openxmlformats.org/drawingml/2006/main" w="0">
+            <a:noFill/>
+            <a:prstDash val="solid"/>
+          </a:ln>
+        </p:spPr>
+        <p:txBody>
+          <a:bodyPr xmlns:a="http://schemas.openxmlformats.org/drawingml/2006/main" lIns="0" tIns="0" rIns="0" bIns="0" anchor="ctr">
+            <a:normAutofit fontScale="100000"/>
+          </a:bodyPr>
+          <a:lstStyle xmlns:a="http://schemas.openxmlformats.org/drawingml/2006/main"/>
+          <a:p xmlns:a="http://schemas.openxmlformats.org/drawingml/2006/main">
+            <a:pPr algn="l">
+              <a:defRPr sz="1425" b="1">
+                <a:solidFill>
+                  <a:srgbClr val="475569"/>
+                </a:solidFill>
+                <a:latin typeface="Microsoft YaHei"/>
+                <a:ea typeface="Microsoft YaHei"/>
+                <a:cs typeface="Microsoft YaHei"/>
+              </a:defRPr>
+            </a:pPr>
+            <a:r>
+              <a:rPr sz="1425" b="1">
+                <a:solidFill>
+                  <a:srgbClr val="475569"/>
+                </a:solidFill>
+                <a:latin typeface="Microsoft YaHei"/>
+                <a:ea typeface="Microsoft YaHei"/>
+                <a:cs typeface="Microsoft YaHei"/>
+              </a:rPr>
+              <a:t>经验难沉淀</a:t>
+            </a:r>
+          </a:p>
+        </p:txBody>
+      </p:sp>
+      <p:sp>
+        <p:nvSpPr>
+          <p:cNvPr id="12" name="PPAGENT_QA|within=problem-item-1|role=body">
+            <a:extLst xmlns:a="http://schemas.openxmlformats.org/drawingml/2006/main">
+              <a:ext uri="{FF2B5EF4-FFF2-40B4-BE49-F238E27FC236}">
+                <a16:creationId xmlns:a16="http://schemas.microsoft.com/office/drawing/2014/main" id="{90EFA5FD-94B6-455E-A523-EA55BC003208}"/>
+              </a:ext>
+            </a:extLst>
+          </p:cNvPr>
+          <p:cNvSpPr>
+            <a:spLocks xmlns:a="http://schemas.openxmlformats.org/drawingml/2006/main" noGrp="1"/>
+          </p:cNvSpPr>
+          <p:nvPr/>
+        </p:nvSpPr>
+        <p:spPr>
+          <a:xfrm xmlns:a="http://schemas.openxmlformats.org/drawingml/2006/main">
+            <a:off x="1219200" y="3810000"/>
+            <a:ext cx="3409950" cy="342900"/>
+          </a:xfrm>
+          <a:prstGeom xmlns:a="http://schemas.openxmlformats.org/drawingml/2006/main" prst="rect">
+            <a:avLst/>
+          </a:prstGeom>
+          <a:noFill xmlns:a="http://schemas.openxmlformats.org/drawingml/2006/main"/>
+          <a:ln xmlns:a="http://schemas.openxmlformats.org/drawingml/2006/main" w="0">
+            <a:noFill/>
+            <a:prstDash val="solid"/>
+          </a:ln>
+        </p:spPr>
+        <p:txBody>
+          <a:bodyPr xmlns:a="http://schemas.openxmlformats.org/drawingml/2006/main" lIns="0" tIns="0" rIns="0" bIns="0" anchor="t">
+            <a:normAutofit fontScale="100000"/>
+          </a:bodyPr>
+          <a:lstStyle xmlns:a="http://schemas.openxmlformats.org/drawingml/2006/main"/>
+          <a:p xmlns:a="http://schemas.openxmlformats.org/drawingml/2006/main">
+            <a:pPr algn="l">
+              <a:defRPr sz="1350" b="0">
+                <a:solidFill>
+                  <a:srgbClr val="475569"/>
+                </a:solidFill>
+                <a:latin typeface="Microsoft YaHei"/>
+                <a:ea typeface="Microsoft YaHei"/>
+                <a:cs typeface="Microsoft YaHei"/>
+              </a:defRPr>
+            </a:pPr>
+            <a:r>
+              <a:rPr sz="1350" b="0">
+                <a:solidFill>
+                  <a:srgbClr val="475569"/>
+                </a:solidFill>
+                <a:latin typeface="Microsoft YaHei"/>
+                <a:ea typeface="Microsoft YaHei"/>
+                <a:cs typeface="Microsoft YaHei"/>
+              </a:rPr>
+              <a:t>每次任务都需要重新判断和修正</a:t>
+            </a:r>
+          </a:p>
+        </p:txBody>
+      </p:sp>
+      <p:sp>
+        <p:nvSpPr>
+          <p:cNvPr id="13" name="PPAGENT_QA|parent=problem-item-2|domains=problem-items">
+            <a:extLst xmlns:a="http://schemas.openxmlformats.org/drawingml/2006/main">
+              <a:ext uri="{FF2B5EF4-FFF2-40B4-BE49-F238E27FC236}">
+                <a16:creationId xmlns:a16="http://schemas.microsoft.com/office/drawing/2014/main" id="{1ED4A2BC-555F-4CEA-9E55-552AF0ACD7AA}"/>
+              </a:ext>
+            </a:extLst>
+          </p:cNvPr>
+          <p:cNvSpPr>
+            <a:spLocks xmlns:a="http://schemas.openxmlformats.org/drawingml/2006/main" noGrp="1"/>
+          </p:cNvSpPr>
+          <p:nvPr/>
+        </p:nvSpPr>
+        <p:spPr>
+          <a:xfrm xmlns:a="http://schemas.openxmlformats.org/drawingml/2006/main">
+            <a:off x="1066800" y="4476750"/>
+            <a:ext cx="3714750" cy="819150"/>
+          </a:xfrm>
+          <a:prstGeom xmlns:a="http://schemas.openxmlformats.org/drawingml/2006/main" prst="roundRect">
+            <a:avLst>
+              <a:gd name="adj" fmla="val 13953"/>
+            </a:avLst>
+          </a:prstGeom>
+          <a:solidFill xmlns:a="http://schemas.openxmlformats.org/drawingml/2006/main">
+            <a:srgbClr val="F1F7FB"/>
+          </a:solidFill>
+          <a:ln xmlns:a="http://schemas.openxmlformats.org/drawingml/2006/main" w="9525">
+            <a:solidFill>
+              <a:srgbClr val="C9D5E3"/>
+            </a:solidFill>
+            <a:prstDash val="solid"/>
+          </a:ln>
+        </p:spPr>
+      </p:sp>
+      <p:sp>
+        <p:nvSpPr>
+          <p:cNvPr id="14" name="PPAGENT_QA|within=problem-item-2|role=title">
+            <a:extLst xmlns:a="http://schemas.openxmlformats.org/drawingml/2006/main">
+              <a:ext uri="{FF2B5EF4-FFF2-40B4-BE49-F238E27FC236}">
+                <a16:creationId xmlns:a16="http://schemas.microsoft.com/office/drawing/2014/main" id="{529C0A9A-4CA0-4423-B6C7-D1EFAB27D6F8}"/>
+              </a:ext>
+            </a:extLst>
+          </p:cNvPr>
+          <p:cNvSpPr>
+            <a:spLocks xmlns:a="http://schemas.openxmlformats.org/drawingml/2006/main" noGrp="1"/>
+          </p:cNvSpPr>
+          <p:nvPr/>
+        </p:nvSpPr>
+        <p:spPr>
+          <a:xfrm xmlns:a="http://schemas.openxmlformats.org/drawingml/2006/main">
+            <a:off x="1219200" y="4591050"/>
+            <a:ext cx="3409950" cy="247650"/>
+          </a:xfrm>
+          <a:prstGeom xmlns:a="http://schemas.openxmlformats.org/drawingml/2006/main" prst="rect">
+            <a:avLst/>
+          </a:prstGeom>
+          <a:noFill xmlns:a="http://schemas.openxmlformats.org/drawingml/2006/main"/>
+          <a:ln xmlns:a="http://schemas.openxmlformats.org/drawingml/2006/main" w="0">
+            <a:noFill/>
+            <a:prstDash val="solid"/>
+          </a:ln>
+        </p:spPr>
+        <p:txBody>
+          <a:bodyPr xmlns:a="http://schemas.openxmlformats.org/drawingml/2006/main" lIns="0" tIns="0" rIns="0" bIns="0" anchor="ctr">
+            <a:normAutofit fontScale="100000"/>
+          </a:bodyPr>
+          <a:lstStyle xmlns:a="http://schemas.openxmlformats.org/drawingml/2006/main"/>
+          <a:p xmlns:a="http://schemas.openxmlformats.org/drawingml/2006/main">
+            <a:pPr algn="l">
+              <a:defRPr sz="1425" b="1">
+                <a:solidFill>
+                  <a:srgbClr val="475569"/>
+                </a:solidFill>
+                <a:latin typeface="Microsoft YaHei"/>
+                <a:ea typeface="Microsoft YaHei"/>
+                <a:cs typeface="Microsoft YaHei"/>
+              </a:defRPr>
+            </a:pPr>
+            <a:r>
+              <a:rPr sz="1425" b="1">
+                <a:solidFill>
+                  <a:srgbClr val="475569"/>
+                </a:solidFill>
+                <a:latin typeface="Microsoft YaHei"/>
+                <a:ea typeface="Microsoft YaHei"/>
+                <a:cs typeface="Microsoft YaHei"/>
+              </a:rPr>
+              <a:t>维护成本高</a:t>
+            </a:r>
+          </a:p>
+        </p:txBody>
+      </p:sp>
+      <p:sp>
+        <p:nvSpPr>
+          <p:cNvPr id="15" name="PPAGENT_QA|within=problem-item-2|role=body">
+            <a:extLst xmlns:a="http://schemas.openxmlformats.org/drawingml/2006/main">
+              <a:ext uri="{FF2B5EF4-FFF2-40B4-BE49-F238E27FC236}">
+                <a16:creationId xmlns:a16="http://schemas.microsoft.com/office/drawing/2014/main" id="{F12133B3-3133-4C3A-839A-03874415B50D}"/>
+              </a:ext>
+            </a:extLst>
+          </p:cNvPr>
+          <p:cNvSpPr>
+            <a:spLocks xmlns:a="http://schemas.openxmlformats.org/drawingml/2006/main" noGrp="1"/>
+          </p:cNvSpPr>
+          <p:nvPr/>
+        </p:nvSpPr>
+        <p:spPr>
+          <a:xfrm xmlns:a="http://schemas.openxmlformats.org/drawingml/2006/main">
+            <a:off x="1219200" y="4876800"/>
+            <a:ext cx="3409950" cy="342900"/>
+          </a:xfrm>
+          <a:prstGeom xmlns:a="http://schemas.openxmlformats.org/drawingml/2006/main" prst="rect">
+            <a:avLst/>
+          </a:prstGeom>
+          <a:noFill xmlns:a="http://schemas.openxmlformats.org/drawingml/2006/main"/>
+          <a:ln xmlns:a="http://schemas.openxmlformats.org/drawingml/2006/main" w="0">
+            <a:noFill/>
+            <a:prstDash val="solid"/>
+          </a:ln>
+        </p:spPr>
+        <p:txBody>
+          <a:bodyPr xmlns:a="http://schemas.openxmlformats.org/drawingml/2006/main" lIns="0" tIns="0" rIns="0" bIns="0" anchor="t">
+            <a:normAutofit fontScale="100000"/>
+          </a:bodyPr>
+          <a:lstStyle xmlns:a="http://schemas.openxmlformats.org/drawingml/2006/main"/>
+          <a:p xmlns:a="http://schemas.openxmlformats.org/drawingml/2006/main">
+            <a:pPr algn="l">
+              <a:defRPr sz="1350" b="0">
+                <a:solidFill>
+                  <a:srgbClr val="475569"/>
+                </a:solidFill>
+                <a:latin typeface="Microsoft YaHei"/>
+                <a:ea typeface="Microsoft YaHei"/>
+                <a:cs typeface="Microsoft YaHei"/>
+              </a:defRPr>
+            </a:pPr>
+            <a:r>
+              <a:rPr sz="1350" b="0">
+                <a:solidFill>
+                  <a:srgbClr val="475569"/>
+                </a:solidFill>
+                <a:latin typeface="Microsoft YaHei"/>
+                <a:ea typeface="Microsoft YaHei"/>
+                <a:cs typeface="Microsoft YaHei"/>
+              </a:rPr>
+              <a:t>多套实现造成重复修改与偏差</a:t>
+            </a:r>
+          </a:p>
+        </p:txBody>
+      </p:sp>
+      <p:sp>
+        <p:nvSpPr>
+          <p:cNvPr id="16" name="PPAGENT_QA|parent=improvement-item-0|domains=improvement-items">
+            <a:extLst xmlns:a="http://schemas.openxmlformats.org/drawingml/2006/main">
+              <a:ext uri="{FF2B5EF4-FFF2-40B4-BE49-F238E27FC236}">
+                <a16:creationId xmlns:a16="http://schemas.microsoft.com/office/drawing/2014/main" id="{EEB69E34-254A-4985-953A-4155D2A8552E}"/>
+              </a:ext>
+            </a:extLst>
+          </p:cNvPr>
+          <p:cNvSpPr>
+            <a:spLocks xmlns:a="http://schemas.openxmlformats.org/drawingml/2006/main" noGrp="1"/>
+          </p:cNvSpPr>
+          <p:nvPr/>
+        </p:nvSpPr>
+        <p:spPr>
+          <a:xfrm xmlns:a="http://schemas.openxmlformats.org/drawingml/2006/main">
+            <a:off x="7410450" y="2343150"/>
+            <a:ext cx="3714750" cy="819150"/>
+          </a:xfrm>
+          <a:prstGeom xmlns:a="http://schemas.openxmlformats.org/drawingml/2006/main" prst="roundRect">
+            <a:avLst>
+              <a:gd name="adj" fmla="val 13953"/>
+            </a:avLst>
+          </a:prstGeom>
+          <a:solidFill xmlns:a="http://schemas.openxmlformats.org/drawingml/2006/main">
+            <a:srgbClr val="ECFBFC"/>
+          </a:solidFill>
+          <a:ln xmlns:a="http://schemas.openxmlformats.org/drawingml/2006/main" w="9525">
+            <a:solidFill>
+              <a:srgbClr val="A8E7EA"/>
+            </a:solidFill>
+            <a:prstDash val="solid"/>
+          </a:ln>
+        </p:spPr>
+      </p:sp>
+      <p:sp>
+        <p:nvSpPr>
+          <p:cNvPr id="17" name="PPAGENT_QA|within=improvement-item-0|role=title">
+            <a:extLst xmlns:a="http://schemas.openxmlformats.org/drawingml/2006/main">
+              <a:ext uri="{FF2B5EF4-FFF2-40B4-BE49-F238E27FC236}">
+                <a16:creationId xmlns:a16="http://schemas.microsoft.com/office/drawing/2014/main" id="{CAA1E591-802B-4CD5-828F-12D6C971030C}"/>
+              </a:ext>
+            </a:extLst>
+          </p:cNvPr>
+          <p:cNvSpPr>
+            <a:spLocks xmlns:a="http://schemas.openxmlformats.org/drawingml/2006/main" noGrp="1"/>
+          </p:cNvSpPr>
+          <p:nvPr/>
+        </p:nvSpPr>
+        <p:spPr>
+          <a:xfrm xmlns:a="http://schemas.openxmlformats.org/drawingml/2006/main">
+            <a:off x="7562850" y="2457450"/>
+            <a:ext cx="3409950" cy="247650"/>
+          </a:xfrm>
+          <a:prstGeom xmlns:a="http://schemas.openxmlformats.org/drawingml/2006/main" prst="rect">
+            <a:avLst/>
+          </a:prstGeom>
+          <a:noFill xmlns:a="http://schemas.openxmlformats.org/drawingml/2006/main"/>
+          <a:ln xmlns:a="http://schemas.openxmlformats.org/drawingml/2006/main" w="0">
+            <a:noFill/>
+            <a:prstDash val="solid"/>
+          </a:ln>
+        </p:spPr>
+        <p:txBody>
+          <a:bodyPr xmlns:a="http://schemas.openxmlformats.org/drawingml/2006/main" lIns="0" tIns="0" rIns="0" bIns="0" anchor="ctr">
+            <a:normAutofit fontScale="100000"/>
+          </a:bodyPr>
+          <a:lstStyle xmlns:a="http://schemas.openxmlformats.org/drawingml/2006/main"/>
+          <a:p xmlns:a="http://schemas.openxmlformats.org/drawingml/2006/main">
+            <a:pPr algn="l">
+              <a:defRPr sz="1425" b="1">
+                <a:solidFill>
+                  <a:srgbClr val="475569"/>
+                </a:solidFill>
+                <a:latin typeface="Microsoft YaHei"/>
+                <a:ea typeface="Microsoft YaHei"/>
+                <a:cs typeface="Microsoft YaHei"/>
+              </a:defRPr>
+            </a:pPr>
+            <a:r>
+              <a:rPr sz="1425" b="1">
+                <a:solidFill>
+                  <a:srgbClr val="475569"/>
+                </a:solidFill>
+                <a:latin typeface="Microsoft YaHei"/>
+                <a:ea typeface="Microsoft YaHei"/>
+                <a:cs typeface="Microsoft YaHei"/>
+              </a:rPr>
+              <a:t>固定能力边界</a:t>
+            </a:r>
+          </a:p>
+        </p:txBody>
+      </p:sp>
+      <p:sp>
+        <p:nvSpPr>
+          <p:cNvPr id="18" name="PPAGENT_QA|within=improvement-item-0|role=body">
+            <a:extLst xmlns:a="http://schemas.openxmlformats.org/drawingml/2006/main">
+              <a:ext uri="{FF2B5EF4-FFF2-40B4-BE49-F238E27FC236}">
+                <a16:creationId xmlns:a16="http://schemas.microsoft.com/office/drawing/2014/main" id="{2A3C870A-79DB-47C8-8051-32398F9457CC}"/>
+              </a:ext>
+            </a:extLst>
+          </p:cNvPr>
+          <p:cNvSpPr>
+            <a:spLocks xmlns:a="http://schemas.openxmlformats.org/drawingml/2006/main" noGrp="1"/>
+          </p:cNvSpPr>
+          <p:nvPr/>
+        </p:nvSpPr>
+        <p:spPr>
+          <a:xfrm xmlns:a="http://schemas.openxmlformats.org/drawingml/2006/main">
+            <a:off x="7562850" y="2743200"/>
+            <a:ext cx="3409950" cy="342900"/>
+          </a:xfrm>
+          <a:prstGeom xmlns:a="http://schemas.openxmlformats.org/drawingml/2006/main" prst="rect">
+            <a:avLst/>
+          </a:prstGeom>
+          <a:noFill xmlns:a="http://schemas.openxmlformats.org/drawingml/2006/main"/>
+          <a:ln xmlns:a="http://schemas.openxmlformats.org/drawingml/2006/main" w="0">
+            <a:noFill/>
+            <a:prstDash val="solid"/>
+          </a:ln>
+        </p:spPr>
+        <p:txBody>
+          <a:bodyPr xmlns:a="http://schemas.openxmlformats.org/drawingml/2006/main" lIns="0" tIns="0" rIns="0" bIns="0" anchor="t">
+            <a:normAutofit fontScale="100000"/>
+          </a:bodyPr>
+          <a:lstStyle xmlns:a="http://schemas.openxmlformats.org/drawingml/2006/main"/>
+          <a:p xmlns:a="http://schemas.openxmlformats.org/drawingml/2006/main">
+            <a:pPr algn="l">
+              <a:defRPr sz="1350" b="0">
+                <a:solidFill>
+                  <a:srgbClr val="475569"/>
+                </a:solidFill>
+                <a:latin typeface="Microsoft YaHei"/>
+                <a:ea typeface="Microsoft YaHei"/>
+                <a:cs typeface="Microsoft YaHei"/>
+              </a:defRPr>
+            </a:pPr>
+            <a:r>
+              <a:rPr sz="1350" b="0">
+                <a:solidFill>
+                  <a:srgbClr val="475569"/>
+                </a:solidFill>
+                <a:latin typeface="Microsoft YaHei"/>
+                <a:ea typeface="Microsoft YaHei"/>
+                <a:cs typeface="Microsoft YaHei"/>
+              </a:rPr>
+              <a:t>用已登记 Style Group 承担结构表达</a:t>
+            </a:r>
+          </a:p>
+        </p:txBody>
+      </p:sp>
+      <p:sp>
+        <p:nvSpPr>
+          <p:cNvPr id="19" name="PPAGENT_QA|parent=improvement-item-1|domains=improvement-items">
+            <a:extLst xmlns:a="http://schemas.openxmlformats.org/drawingml/2006/main">
+              <a:ext uri="{FF2B5EF4-FFF2-40B4-BE49-F238E27FC236}">
+                <a16:creationId xmlns:a16="http://schemas.microsoft.com/office/drawing/2014/main" id="{901F3D61-BF09-4093-A0B0-59C9580179DD}"/>
+              </a:ext>
+            </a:extLst>
+          </p:cNvPr>
+          <p:cNvSpPr>
+            <a:spLocks xmlns:a="http://schemas.openxmlformats.org/drawingml/2006/main" noGrp="1"/>
+          </p:cNvSpPr>
+          <p:nvPr/>
+        </p:nvSpPr>
+        <p:spPr>
+          <a:xfrm xmlns:a="http://schemas.openxmlformats.org/drawingml/2006/main">
+            <a:off x="7410450" y="3409950"/>
+            <a:ext cx="3714750" cy="819150"/>
+          </a:xfrm>
+          <a:prstGeom xmlns:a="http://schemas.openxmlformats.org/drawingml/2006/main" prst="roundRect">
+            <a:avLst>
+              <a:gd name="adj" fmla="val 13953"/>
+            </a:avLst>
+          </a:prstGeom>
+          <a:solidFill xmlns:a="http://schemas.openxmlformats.org/drawingml/2006/main">
+            <a:srgbClr val="ECFBFC"/>
+          </a:solidFill>
+          <a:ln xmlns:a="http://schemas.openxmlformats.org/drawingml/2006/main" w="9525">
+            <a:solidFill>
+              <a:srgbClr val="A8E7EA"/>
+            </a:solidFill>
+            <a:prstDash val="solid"/>
+          </a:ln>
+        </p:spPr>
+      </p:sp>
+      <p:sp>
+        <p:nvSpPr>
+          <p:cNvPr id="20" name="PPAGENT_QA|within=improvement-item-1|role=title">
+            <a:extLst xmlns:a="http://schemas.openxmlformats.org/drawingml/2006/main">
+              <a:ext uri="{FF2B5EF4-FFF2-40B4-BE49-F238E27FC236}">
+                <a16:creationId xmlns:a16="http://schemas.microsoft.com/office/drawing/2014/main" id="{72728502-701A-44A7-9A64-5D97A21E2AEB}"/>
+              </a:ext>
+            </a:extLst>
+          </p:cNvPr>
+          <p:cNvSpPr>
+            <a:spLocks xmlns:a="http://schemas.openxmlformats.org/drawingml/2006/main" noGrp="1"/>
+          </p:cNvSpPr>
+          <p:nvPr/>
+        </p:nvSpPr>
+        <p:spPr>
+          <a:xfrm xmlns:a="http://schemas.openxmlformats.org/drawingml/2006/main">
+            <a:off x="7562850" y="3524250"/>
+            <a:ext cx="3409950" cy="247650"/>
+          </a:xfrm>
+          <a:prstGeom xmlns:a="http://schemas.openxmlformats.org/drawingml/2006/main" prst="rect">
+            <a:avLst/>
+          </a:prstGeom>
+          <a:noFill xmlns:a="http://schemas.openxmlformats.org/drawingml/2006/main"/>
+          <a:ln xmlns:a="http://schemas.openxmlformats.org/drawingml/2006/main" w="0">
+            <a:noFill/>
+            <a:prstDash val="solid"/>
+          </a:ln>
+        </p:spPr>
+        <p:txBody>
+          <a:bodyPr xmlns:a="http://schemas.openxmlformats.org/drawingml/2006/main" lIns="0" tIns="0" rIns="0" bIns="0" anchor="ctr">
+            <a:normAutofit fontScale="100000"/>
+          </a:bodyPr>
+          <a:lstStyle xmlns:a="http://schemas.openxmlformats.org/drawingml/2006/main"/>
+          <a:p xmlns:a="http://schemas.openxmlformats.org/drawingml/2006/main">
+            <a:pPr algn="l">
+              <a:defRPr sz="1425" b="1">
+                <a:solidFill>
+                  <a:srgbClr val="475569"/>
+                </a:solidFill>
+                <a:latin typeface="Microsoft YaHei"/>
+                <a:ea typeface="Microsoft YaHei"/>
+                <a:cs typeface="Microsoft YaHei"/>
+              </a:defRPr>
+            </a:pPr>
+            <a:r>
+              <a:rPr sz="1425" b="1">
+                <a:solidFill>
+                  <a:srgbClr val="475569"/>
+                </a:solidFill>
+                <a:latin typeface="Microsoft YaHei"/>
+                <a:ea typeface="Microsoft YaHei"/>
+                <a:cs typeface="Microsoft YaHei"/>
+              </a:rPr>
+              <a:t>统一参数接口</a:t>
+            </a:r>
+          </a:p>
+        </p:txBody>
+      </p:sp>
+      <p:sp>
+        <p:nvSpPr>
+          <p:cNvPr id="21" name="PPAGENT_QA|within=improvement-item-1|role=body">
+            <a:extLst xmlns:a="http://schemas.openxmlformats.org/drawingml/2006/main">
+              <a:ext uri="{FF2B5EF4-FFF2-40B4-BE49-F238E27FC236}">
+                <a16:creationId xmlns:a16="http://schemas.microsoft.com/office/drawing/2014/main" id="{ACB33554-E6CC-49EC-8322-0B780C1211E3}"/>
+              </a:ext>
+            </a:extLst>
+          </p:cNvPr>
+          <p:cNvSpPr>
+            <a:spLocks xmlns:a="http://schemas.openxmlformats.org/drawingml/2006/main" noGrp="1"/>
+          </p:cNvSpPr>
+          <p:nvPr/>
+        </p:nvSpPr>
+        <p:spPr>
+          <a:xfrm xmlns:a="http://schemas.openxmlformats.org/drawingml/2006/main">
+            <a:off x="7562850" y="3810000"/>
+            <a:ext cx="3409950" cy="342900"/>
+          </a:xfrm>
+          <a:prstGeom xmlns:a="http://schemas.openxmlformats.org/drawingml/2006/main" prst="rect">
+            <a:avLst/>
+          </a:prstGeom>
+          <a:noFill xmlns:a="http://schemas.openxmlformats.org/drawingml/2006/main"/>
+          <a:ln xmlns:a="http://schemas.openxmlformats.org/drawingml/2006/main" w="0">
+            <a:noFill/>
+            <a:prstDash val="solid"/>
+          </a:ln>
+        </p:spPr>
+        <p:txBody>
+          <a:bodyPr xmlns:a="http://schemas.openxmlformats.org/drawingml/2006/main" lIns="0" tIns="0" rIns="0" bIns="0" anchor="t">
+            <a:normAutofit fontScale="100000"/>
+          </a:bodyPr>
+          <a:lstStyle xmlns:a="http://schemas.openxmlformats.org/drawingml/2006/main"/>
+          <a:p xmlns:a="http://schemas.openxmlformats.org/drawingml/2006/main">
+            <a:pPr algn="l">
+              <a:defRPr sz="1350" b="0">
+                <a:solidFill>
+                  <a:srgbClr val="475569"/>
+                </a:solidFill>
+                <a:latin typeface="Microsoft YaHei"/>
+                <a:ea typeface="Microsoft YaHei"/>
+                <a:cs typeface="Microsoft YaHei"/>
+              </a:defRPr>
+            </a:pPr>
+            <a:r>
+              <a:rPr sz="1350" b="0">
+                <a:solidFill>
+                  <a:srgbClr val="475569"/>
+                </a:solidFill>
+                <a:latin typeface="Microsoft YaHei"/>
+                <a:ea typeface="Microsoft YaHei"/>
+                <a:cs typeface="Microsoft YaHei"/>
+              </a:rPr>
+              <a:t>让 HTML 与 Builder 使用同一输入</a:t>
+            </a:r>
+          </a:p>
+        </p:txBody>
+      </p:sp>
+      <p:sp>
+        <p:nvSpPr>
+          <p:cNvPr id="22" name="PPAGENT_QA|parent=improvement-item-2|domains=improvement-items">
+            <a:extLst xmlns:a="http://schemas.openxmlformats.org/drawingml/2006/main">
+              <a:ext uri="{FF2B5EF4-FFF2-40B4-BE49-F238E27FC236}">
+                <a16:creationId xmlns:a16="http://schemas.microsoft.com/office/drawing/2014/main" id="{EAEBE131-DC70-4377-AD45-8BB27A129B1A}"/>
+              </a:ext>
+            </a:extLst>
+          </p:cNvPr>
+          <p:cNvSpPr>
+            <a:spLocks xmlns:a="http://schemas.openxmlformats.org/drawingml/2006/main" noGrp="1"/>
+          </p:cNvSpPr>
+          <p:nvPr/>
+        </p:nvSpPr>
+        <p:spPr>
+          <a:xfrm xmlns:a="http://schemas.openxmlformats.org/drawingml/2006/main">
+            <a:off x="7410450" y="4476750"/>
+            <a:ext cx="3714750" cy="819150"/>
+          </a:xfrm>
+          <a:prstGeom xmlns:a="http://schemas.openxmlformats.org/drawingml/2006/main" prst="roundRect">
+            <a:avLst>
+              <a:gd name="adj" fmla="val 13953"/>
+            </a:avLst>
+          </a:prstGeom>
+          <a:solidFill xmlns:a="http://schemas.openxmlformats.org/drawingml/2006/main">
+            <a:srgbClr val="ECFBFC"/>
+          </a:solidFill>
+          <a:ln xmlns:a="http://schemas.openxmlformats.org/drawingml/2006/main" w="9525">
+            <a:solidFill>
+              <a:srgbClr val="A8E7EA"/>
+            </a:solidFill>
+            <a:prstDash val="solid"/>
+          </a:ln>
+        </p:spPr>
+      </p:sp>
+      <p:sp>
+        <p:nvSpPr>
+          <p:cNvPr id="23" name="PPAGENT_QA|within=improvement-item-2|role=title">
+            <a:extLst xmlns:a="http://schemas.openxmlformats.org/drawingml/2006/main">
+              <a:ext uri="{FF2B5EF4-FFF2-40B4-BE49-F238E27FC236}">
+                <a16:creationId xmlns:a16="http://schemas.microsoft.com/office/drawing/2014/main" id="{56014A8E-F59A-4132-B6F7-DA25F998A30F}"/>
+              </a:ext>
+            </a:extLst>
+          </p:cNvPr>
+          <p:cNvSpPr>
+            <a:spLocks xmlns:a="http://schemas.openxmlformats.org/drawingml/2006/main" noGrp="1"/>
+          </p:cNvSpPr>
+          <p:nvPr/>
+        </p:nvSpPr>
+        <p:spPr>
+          <a:xfrm xmlns:a="http://schemas.openxmlformats.org/drawingml/2006/main">
+            <a:off x="7562850" y="4591050"/>
+            <a:ext cx="3409950" cy="247650"/>
+          </a:xfrm>
+          <a:prstGeom xmlns:a="http://schemas.openxmlformats.org/drawingml/2006/main" prst="rect">
+            <a:avLst/>
+          </a:prstGeom>
+          <a:noFill xmlns:a="http://schemas.openxmlformats.org/drawingml/2006/main"/>
+          <a:ln xmlns:a="http://schemas.openxmlformats.org/drawingml/2006/main" w="0">
+            <a:noFill/>
+            <a:prstDash val="solid"/>
+          </a:ln>
+        </p:spPr>
+        <p:txBody>
+          <a:bodyPr xmlns:a="http://schemas.openxmlformats.org/drawingml/2006/main" lIns="0" tIns="0" rIns="0" bIns="0" anchor="ctr">
+            <a:normAutofit fontScale="100000"/>
+          </a:bodyPr>
+          <a:lstStyle xmlns:a="http://schemas.openxmlformats.org/drawingml/2006/main"/>
+          <a:p xmlns:a="http://schemas.openxmlformats.org/drawingml/2006/main">
+            <a:pPr algn="l">
+              <a:defRPr sz="1425" b="1">
+                <a:solidFill>
+                  <a:srgbClr val="475569"/>
+                </a:solidFill>
+                <a:latin typeface="Microsoft YaHei"/>
+                <a:ea typeface="Microsoft YaHei"/>
+                <a:cs typeface="Microsoft YaHei"/>
+              </a:defRPr>
+            </a:pPr>
+            <a:r>
+              <a:rPr sz="1425" b="1">
+                <a:solidFill>
+                  <a:srgbClr val="475569"/>
+                </a:solidFill>
+                <a:latin typeface="Microsoft YaHei"/>
+                <a:ea typeface="Microsoft YaHei"/>
+                <a:cs typeface="Microsoft YaHei"/>
+              </a:rPr>
+              <a:t>建立审查闭环</a:t>
+            </a:r>
+          </a:p>
+        </p:txBody>
+      </p:sp>
+      <p:sp>
+        <p:nvSpPr>
+          <p:cNvPr id="24" name="PPAGENT_QA|within=improvement-item-2|role=body">
+            <a:extLst xmlns:a="http://schemas.openxmlformats.org/drawingml/2006/main">
+              <a:ext uri="{FF2B5EF4-FFF2-40B4-BE49-F238E27FC236}">
+                <a16:creationId xmlns:a16="http://schemas.microsoft.com/office/drawing/2014/main" id="{80B6177D-A6D9-49A3-BF2B-AD847AAC266D}"/>
+              </a:ext>
+            </a:extLst>
+          </p:cNvPr>
+          <p:cNvSpPr>
+            <a:spLocks xmlns:a="http://schemas.openxmlformats.org/drawingml/2006/main" noGrp="1"/>
+          </p:cNvSpPr>
+          <p:nvPr/>
+        </p:nvSpPr>
+        <p:spPr>
+          <a:xfrm xmlns:a="http://schemas.openxmlformats.org/drawingml/2006/main">
+            <a:off x="7562850" y="4876800"/>
+            <a:ext cx="3409950" cy="342900"/>
+          </a:xfrm>
+          <a:prstGeom xmlns:a="http://schemas.openxmlformats.org/drawingml/2006/main" prst="rect">
+            <a:avLst/>
+          </a:prstGeom>
+          <a:noFill xmlns:a="http://schemas.openxmlformats.org/drawingml/2006/main"/>
+          <a:ln xmlns:a="http://schemas.openxmlformats.org/drawingml/2006/main" w="0">
+            <a:noFill/>
+            <a:prstDash val="solid"/>
+          </a:ln>
+        </p:spPr>
+        <p:txBody>
+          <a:bodyPr xmlns:a="http://schemas.openxmlformats.org/drawingml/2006/main" lIns="0" tIns="0" rIns="0" bIns="0" anchor="t">
+            <a:normAutofit fontScale="100000"/>
+          </a:bodyPr>
+          <a:lstStyle xmlns:a="http://schemas.openxmlformats.org/drawingml/2006/main"/>
+          <a:p xmlns:a="http://schemas.openxmlformats.org/drawingml/2006/main">
+            <a:pPr algn="l">
+              <a:defRPr sz="1350" b="0">
+                <a:solidFill>
+                  <a:srgbClr val="475569"/>
+                </a:solidFill>
+                <a:latin typeface="Microsoft YaHei"/>
+                <a:ea typeface="Microsoft YaHei"/>
+                <a:cs typeface="Microsoft YaHei"/>
+              </a:defRPr>
+            </a:pPr>
+            <a:r>
+              <a:rPr sz="1350" b="0">
+                <a:solidFill>
+                  <a:srgbClr val="475569"/>
+                </a:solidFill>
+                <a:latin typeface="Microsoft YaHei"/>
+                <a:ea typeface="Microsoft YaHei"/>
+                <a:cs typeface="Microsoft YaHei"/>
+              </a:rPr>
+              <a:t>在入库前完成状态与视觉确认</a:t>
+            </a:r>
+          </a:p>
+        </p:txBody>
+      </p:sp>
+      <p:sp>
+        <p:nvSpPr>
+          <p:cNvPr id="25" name="">
+            <a:extLst xmlns:a="http://schemas.openxmlformats.org/drawingml/2006/main">
+              <a:ext uri="{FF2B5EF4-FFF2-40B4-BE49-F238E27FC236}">
+                <a16:creationId xmlns:a16="http://schemas.microsoft.com/office/drawing/2014/main" id="{8F258038-1A4C-4C86-8595-D47215E2E507}"/>
+              </a:ext>
+            </a:extLst>
+          </p:cNvPr>
+          <p:cNvSpPr>
+            <a:spLocks xmlns:a="http://schemas.openxmlformats.org/drawingml/2006/main" noGrp="1"/>
+          </p:cNvSpPr>
+          <p:nvPr/>
+        </p:nvSpPr>
+        <p:spPr>
+          <a:xfrm xmlns:a="http://schemas.openxmlformats.org/drawingml/2006/main">
+            <a:off x="5543550" y="3124200"/>
+            <a:ext cx="1104900" cy="1104900"/>
+          </a:xfrm>
+          <a:prstGeom xmlns:a="http://schemas.openxmlformats.org/drawingml/2006/main" prst="rightArrow">
+            <a:avLst/>
+          </a:prstGeom>
+          <a:solidFill xmlns:a="http://schemas.openxmlformats.org/drawingml/2006/main">
+            <a:srgbClr val="14CBD1"/>
+          </a:solidFill>
+          <a:ln xmlns:a="http://schemas.openxmlformats.org/drawingml/2006/main" w="0">
+            <a:noFill/>
+            <a:prstDash val="solid"/>
+          </a:ln>
+        </p:spPr>
+        <p:style>
+          <a:lnRef xmlns:a="http://schemas.openxmlformats.org/drawingml/2006/main" idx="0"/>
+          <a:fillRef xmlns:a="http://schemas.openxmlformats.org/drawingml/2006/main" idx="0"/>
+          <a:effectRef xmlns:a="http://schemas.openxmlformats.org/drawingml/2006/main" idx="6"/>
+          <a:fontRef xmlns:a="http://schemas.openxmlformats.org/drawingml/2006/main" idx="major"/>
+        </p:style>
+      </p:sp>
+    </p:spTree>
+    <p:extLst>
+      <p:ext uri="{BB962C8B-B14F-4D97-AF65-F5344CB8AC3E}">
+        <p14:creationId xmlns:p14="http://schemas.microsoft.com/office/powerpoint/2010/main" val="484558634"/>
       </p:ext>
     </p:extLst>
   </p:cSld>

</xml_diff>